<commit_message>
Align ETL package with company spec: rename to Load DW Pipeline, CurrentJobTime window, product SCD2 + SellEndDate, Language param; add DW backup, presentation, submission zip
</commit_message>
<xml_diff>
--- a/Docs/AdventureWorks_ETL_Presentation.pptx
+++ b/Docs/AdventureWorks_ETL_Presentation.pptx
@@ -142,7 +142,7 @@
           <p:cNvPr id="2" name="Title 1">
             <a:extLst>
               <a:ext uri="{FF2B5EF4-FFF2-40B4-BE49-F238E27FC236}">
-                <a16:creationId xmlns:a16="http://schemas.microsoft.com/office/drawing/2014/main" id="{DACFD526-CE66-1BD1-7476-C0A59D9C85B0}"/>
+                <a16:creationId xmlns:a16="http://schemas.microsoft.com/office/drawing/2014/main" id="{7A922292-210A-22C6-D3BD-1FF5071F0E6B}"/>
               </a:ext>
             </a:extLst>
           </p:cNvPr>
@@ -179,7 +179,7 @@
           <p:cNvPr id="3" name="Subtitle 2">
             <a:extLst>
               <a:ext uri="{FF2B5EF4-FFF2-40B4-BE49-F238E27FC236}">
-                <a16:creationId xmlns:a16="http://schemas.microsoft.com/office/drawing/2014/main" id="{F11C70FF-0535-9DDA-2FF3-14A25C767705}"/>
+                <a16:creationId xmlns:a16="http://schemas.microsoft.com/office/drawing/2014/main" id="{2BA4A99F-17DC-F3F4-4217-42A27368845A}"/>
               </a:ext>
             </a:extLst>
           </p:cNvPr>
@@ -249,7 +249,7 @@
           <p:cNvPr id="4" name="Date Placeholder 3">
             <a:extLst>
               <a:ext uri="{FF2B5EF4-FFF2-40B4-BE49-F238E27FC236}">
-                <a16:creationId xmlns:a16="http://schemas.microsoft.com/office/drawing/2014/main" id="{8CDBED8E-E2BE-06E2-BA80-C19ADD7EC1F1}"/>
+                <a16:creationId xmlns:a16="http://schemas.microsoft.com/office/drawing/2014/main" id="{B5634EBF-BC79-CEC9-6434-03CE2052196D}"/>
               </a:ext>
             </a:extLst>
           </p:cNvPr>
@@ -265,9 +265,9 @@
           <a:bodyPr/>
           <a:lstStyle/>
           <a:p>
-            <a:fld id="{0D537BD8-EA9E-467F-B36B-CC24F78C48CB}" type="datetimeFigureOut">
+            <a:fld id="{7D1867BF-27E9-4E78-B03E-D1C72F0D04A0}" type="datetimeFigureOut">
               <a:rPr lang="en-US" smtClean="0"/>
-              <a:t>8/1/2026</a:t>
+              <a:t>8/2/2026</a:t>
             </a:fld>
             <a:endParaRPr lang="en-US"/>
           </a:p>
@@ -278,7 +278,7 @@
           <p:cNvPr id="5" name="Footer Placeholder 4">
             <a:extLst>
               <a:ext uri="{FF2B5EF4-FFF2-40B4-BE49-F238E27FC236}">
-                <a16:creationId xmlns:a16="http://schemas.microsoft.com/office/drawing/2014/main" id="{3A4648B9-2ABE-D21B-0C43-16BD08182B48}"/>
+                <a16:creationId xmlns:a16="http://schemas.microsoft.com/office/drawing/2014/main" id="{1BE1158A-E68C-8B2B-6E89-C533AD9ED794}"/>
               </a:ext>
             </a:extLst>
           </p:cNvPr>
@@ -303,7 +303,7 @@
           <p:cNvPr id="6" name="Slide Number Placeholder 5">
             <a:extLst>
               <a:ext uri="{FF2B5EF4-FFF2-40B4-BE49-F238E27FC236}">
-                <a16:creationId xmlns:a16="http://schemas.microsoft.com/office/drawing/2014/main" id="{EC9EEFF1-9928-1810-5530-FD5D97392E11}"/>
+                <a16:creationId xmlns:a16="http://schemas.microsoft.com/office/drawing/2014/main" id="{8DE891DA-7406-86D1-F3E2-1FFD9BCE431D}"/>
               </a:ext>
             </a:extLst>
           </p:cNvPr>
@@ -319,7 +319,7 @@
           <a:bodyPr/>
           <a:lstStyle/>
           <a:p>
-            <a:fld id="{51EA4D40-7E3E-4880-A61C-AC1212F849E4}" type="slidenum">
+            <a:fld id="{B08209FF-819D-43A2-97A4-6C4DDC35B4FA}" type="slidenum">
               <a:rPr lang="en-US" smtClean="0"/>
               <a:t>‹#›</a:t>
             </a:fld>
@@ -330,7 +330,7 @@
     </p:spTree>
     <p:extLst>
       <p:ext uri="{BB962C8B-B14F-4D97-AF65-F5344CB8AC3E}">
-        <p14:creationId xmlns:p14="http://schemas.microsoft.com/office/powerpoint/2010/main" val="2100262858"/>
+        <p14:creationId xmlns:p14="http://schemas.microsoft.com/office/powerpoint/2010/main" val="1398870731"/>
       </p:ext>
     </p:extLst>
   </p:cSld>
@@ -362,7 +362,7 @@
           <p:cNvPr id="2" name="Title 1">
             <a:extLst>
               <a:ext uri="{FF2B5EF4-FFF2-40B4-BE49-F238E27FC236}">
-                <a16:creationId xmlns:a16="http://schemas.microsoft.com/office/drawing/2014/main" id="{0C719E66-E6B8-39C4-A6D3-E79010A18533}"/>
+                <a16:creationId xmlns:a16="http://schemas.microsoft.com/office/drawing/2014/main" id="{DBD0BEF4-59F6-37A6-B23F-2F91D57ABFE3}"/>
               </a:ext>
             </a:extLst>
           </p:cNvPr>
@@ -390,7 +390,7 @@
           <p:cNvPr id="3" name="Vertical Text Placeholder 2">
             <a:extLst>
               <a:ext uri="{FF2B5EF4-FFF2-40B4-BE49-F238E27FC236}">
-                <a16:creationId xmlns:a16="http://schemas.microsoft.com/office/drawing/2014/main" id="{4F20C704-752B-846A-3DD5-7EBC485DE408}"/>
+                <a16:creationId xmlns:a16="http://schemas.microsoft.com/office/drawing/2014/main" id="{0D54E877-0EAA-733F-5180-F53E9FBFAFEA}"/>
               </a:ext>
             </a:extLst>
           </p:cNvPr>
@@ -447,7 +447,7 @@
           <p:cNvPr id="4" name="Date Placeholder 3">
             <a:extLst>
               <a:ext uri="{FF2B5EF4-FFF2-40B4-BE49-F238E27FC236}">
-                <a16:creationId xmlns:a16="http://schemas.microsoft.com/office/drawing/2014/main" id="{E1CCA1C8-EBE5-7FA2-C7DA-A622D8B695F5}"/>
+                <a16:creationId xmlns:a16="http://schemas.microsoft.com/office/drawing/2014/main" id="{4FE8F267-54C8-E403-7D8D-C0B7A868E050}"/>
               </a:ext>
             </a:extLst>
           </p:cNvPr>
@@ -463,9 +463,9 @@
           <a:bodyPr/>
           <a:lstStyle/>
           <a:p>
-            <a:fld id="{0D537BD8-EA9E-467F-B36B-CC24F78C48CB}" type="datetimeFigureOut">
+            <a:fld id="{7D1867BF-27E9-4E78-B03E-D1C72F0D04A0}" type="datetimeFigureOut">
               <a:rPr lang="en-US" smtClean="0"/>
-              <a:t>8/1/2026</a:t>
+              <a:t>8/2/2026</a:t>
             </a:fld>
             <a:endParaRPr lang="en-US"/>
           </a:p>
@@ -476,7 +476,7 @@
           <p:cNvPr id="5" name="Footer Placeholder 4">
             <a:extLst>
               <a:ext uri="{FF2B5EF4-FFF2-40B4-BE49-F238E27FC236}">
-                <a16:creationId xmlns:a16="http://schemas.microsoft.com/office/drawing/2014/main" id="{2CD8CC0A-F922-3B76-253A-B881C072B6F4}"/>
+                <a16:creationId xmlns:a16="http://schemas.microsoft.com/office/drawing/2014/main" id="{3BF5D561-28DF-B1B2-2166-2E8DDEB88FF4}"/>
               </a:ext>
             </a:extLst>
           </p:cNvPr>
@@ -501,7 +501,7 @@
           <p:cNvPr id="6" name="Slide Number Placeholder 5">
             <a:extLst>
               <a:ext uri="{FF2B5EF4-FFF2-40B4-BE49-F238E27FC236}">
-                <a16:creationId xmlns:a16="http://schemas.microsoft.com/office/drawing/2014/main" id="{8488C566-44CA-A786-5198-4FDA3798CECB}"/>
+                <a16:creationId xmlns:a16="http://schemas.microsoft.com/office/drawing/2014/main" id="{04980CC4-3007-DB6E-0F15-04644B29180D}"/>
               </a:ext>
             </a:extLst>
           </p:cNvPr>
@@ -517,7 +517,7 @@
           <a:bodyPr/>
           <a:lstStyle/>
           <a:p>
-            <a:fld id="{51EA4D40-7E3E-4880-A61C-AC1212F849E4}" type="slidenum">
+            <a:fld id="{B08209FF-819D-43A2-97A4-6C4DDC35B4FA}" type="slidenum">
               <a:rPr lang="en-US" smtClean="0"/>
               <a:t>‹#›</a:t>
             </a:fld>
@@ -528,7 +528,7 @@
     </p:spTree>
     <p:extLst>
       <p:ext uri="{BB962C8B-B14F-4D97-AF65-F5344CB8AC3E}">
-        <p14:creationId xmlns:p14="http://schemas.microsoft.com/office/powerpoint/2010/main" val="2134715266"/>
+        <p14:creationId xmlns:p14="http://schemas.microsoft.com/office/powerpoint/2010/main" val="3105608387"/>
       </p:ext>
     </p:extLst>
   </p:cSld>
@@ -560,7 +560,7 @@
           <p:cNvPr id="2" name="Vertical Title 1">
             <a:extLst>
               <a:ext uri="{FF2B5EF4-FFF2-40B4-BE49-F238E27FC236}">
-                <a16:creationId xmlns:a16="http://schemas.microsoft.com/office/drawing/2014/main" id="{9F039CEC-3FA3-44AE-B55C-4285A944BCB7}"/>
+                <a16:creationId xmlns:a16="http://schemas.microsoft.com/office/drawing/2014/main" id="{9A4DD5EF-3EF8-8BCF-D88C-EA88462F02A9}"/>
               </a:ext>
             </a:extLst>
           </p:cNvPr>
@@ -593,7 +593,7 @@
           <p:cNvPr id="3" name="Vertical Text Placeholder 2">
             <a:extLst>
               <a:ext uri="{FF2B5EF4-FFF2-40B4-BE49-F238E27FC236}">
-                <a16:creationId xmlns:a16="http://schemas.microsoft.com/office/drawing/2014/main" id="{8BE12422-0B95-2D9F-18CA-E5A674EFCBE1}"/>
+                <a16:creationId xmlns:a16="http://schemas.microsoft.com/office/drawing/2014/main" id="{089866F8-A0F0-1AFE-F333-58E0BAFECF1C}"/>
               </a:ext>
             </a:extLst>
           </p:cNvPr>
@@ -655,7 +655,7 @@
           <p:cNvPr id="4" name="Date Placeholder 3">
             <a:extLst>
               <a:ext uri="{FF2B5EF4-FFF2-40B4-BE49-F238E27FC236}">
-                <a16:creationId xmlns:a16="http://schemas.microsoft.com/office/drawing/2014/main" id="{D83EE314-3234-7E3A-6F37-608C03B8888C}"/>
+                <a16:creationId xmlns:a16="http://schemas.microsoft.com/office/drawing/2014/main" id="{534B2CEF-DBA1-B52F-1D1E-33A3D2ADE929}"/>
               </a:ext>
             </a:extLst>
           </p:cNvPr>
@@ -671,9 +671,9 @@
           <a:bodyPr/>
           <a:lstStyle/>
           <a:p>
-            <a:fld id="{0D537BD8-EA9E-467F-B36B-CC24F78C48CB}" type="datetimeFigureOut">
+            <a:fld id="{7D1867BF-27E9-4E78-B03E-D1C72F0D04A0}" type="datetimeFigureOut">
               <a:rPr lang="en-US" smtClean="0"/>
-              <a:t>8/1/2026</a:t>
+              <a:t>8/2/2026</a:t>
             </a:fld>
             <a:endParaRPr lang="en-US"/>
           </a:p>
@@ -684,7 +684,7 @@
           <p:cNvPr id="5" name="Footer Placeholder 4">
             <a:extLst>
               <a:ext uri="{FF2B5EF4-FFF2-40B4-BE49-F238E27FC236}">
-                <a16:creationId xmlns:a16="http://schemas.microsoft.com/office/drawing/2014/main" id="{6523E39D-D71F-2D8E-6759-1D38051C7CF5}"/>
+                <a16:creationId xmlns:a16="http://schemas.microsoft.com/office/drawing/2014/main" id="{BD734B09-6291-221E-8A38-8C06312F7E50}"/>
               </a:ext>
             </a:extLst>
           </p:cNvPr>
@@ -709,7 +709,7 @@
           <p:cNvPr id="6" name="Slide Number Placeholder 5">
             <a:extLst>
               <a:ext uri="{FF2B5EF4-FFF2-40B4-BE49-F238E27FC236}">
-                <a16:creationId xmlns:a16="http://schemas.microsoft.com/office/drawing/2014/main" id="{AD55E7D0-E56A-EB74-6C93-42BC7DD55F1B}"/>
+                <a16:creationId xmlns:a16="http://schemas.microsoft.com/office/drawing/2014/main" id="{475934B3-F396-89A6-D941-DEEE6C0F50C2}"/>
               </a:ext>
             </a:extLst>
           </p:cNvPr>
@@ -725,7 +725,7 @@
           <a:bodyPr/>
           <a:lstStyle/>
           <a:p>
-            <a:fld id="{51EA4D40-7E3E-4880-A61C-AC1212F849E4}" type="slidenum">
+            <a:fld id="{B08209FF-819D-43A2-97A4-6C4DDC35B4FA}" type="slidenum">
               <a:rPr lang="en-US" smtClean="0"/>
               <a:t>‹#›</a:t>
             </a:fld>
@@ -736,7 +736,7 @@
     </p:spTree>
     <p:extLst>
       <p:ext uri="{BB962C8B-B14F-4D97-AF65-F5344CB8AC3E}">
-        <p14:creationId xmlns:p14="http://schemas.microsoft.com/office/powerpoint/2010/main" val="2459655037"/>
+        <p14:creationId xmlns:p14="http://schemas.microsoft.com/office/powerpoint/2010/main" val="1890036477"/>
       </p:ext>
     </p:extLst>
   </p:cSld>
@@ -768,7 +768,7 @@
           <p:cNvPr id="2" name="Title 1">
             <a:extLst>
               <a:ext uri="{FF2B5EF4-FFF2-40B4-BE49-F238E27FC236}">
-                <a16:creationId xmlns:a16="http://schemas.microsoft.com/office/drawing/2014/main" id="{289F62AD-66A9-3EA2-21F4-1B14962C6994}"/>
+                <a16:creationId xmlns:a16="http://schemas.microsoft.com/office/drawing/2014/main" id="{FEE77A9A-3331-8887-BD9D-163BAB5C7124}"/>
               </a:ext>
             </a:extLst>
           </p:cNvPr>
@@ -796,7 +796,7 @@
           <p:cNvPr id="3" name="Content Placeholder 2">
             <a:extLst>
               <a:ext uri="{FF2B5EF4-FFF2-40B4-BE49-F238E27FC236}">
-                <a16:creationId xmlns:a16="http://schemas.microsoft.com/office/drawing/2014/main" id="{B42FEC38-EC60-51C7-3D12-E61137174063}"/>
+                <a16:creationId xmlns:a16="http://schemas.microsoft.com/office/drawing/2014/main" id="{5ADEC16D-AA79-CEEE-F3EA-76CC8FC95018}"/>
               </a:ext>
             </a:extLst>
           </p:cNvPr>
@@ -853,7 +853,7 @@
           <p:cNvPr id="4" name="Date Placeholder 3">
             <a:extLst>
               <a:ext uri="{FF2B5EF4-FFF2-40B4-BE49-F238E27FC236}">
-                <a16:creationId xmlns:a16="http://schemas.microsoft.com/office/drawing/2014/main" id="{DB05ACDE-E746-C339-F394-57C8E7B9AB1D}"/>
+                <a16:creationId xmlns:a16="http://schemas.microsoft.com/office/drawing/2014/main" id="{173271F5-F0C7-E53C-CF7D-85F06D672448}"/>
               </a:ext>
             </a:extLst>
           </p:cNvPr>
@@ -869,9 +869,9 @@
           <a:bodyPr/>
           <a:lstStyle/>
           <a:p>
-            <a:fld id="{0D537BD8-EA9E-467F-B36B-CC24F78C48CB}" type="datetimeFigureOut">
+            <a:fld id="{7D1867BF-27E9-4E78-B03E-D1C72F0D04A0}" type="datetimeFigureOut">
               <a:rPr lang="en-US" smtClean="0"/>
-              <a:t>8/1/2026</a:t>
+              <a:t>8/2/2026</a:t>
             </a:fld>
             <a:endParaRPr lang="en-US"/>
           </a:p>
@@ -882,7 +882,7 @@
           <p:cNvPr id="5" name="Footer Placeholder 4">
             <a:extLst>
               <a:ext uri="{FF2B5EF4-FFF2-40B4-BE49-F238E27FC236}">
-                <a16:creationId xmlns:a16="http://schemas.microsoft.com/office/drawing/2014/main" id="{89C1A573-6B33-4B2B-99EF-5FCDC00F3D0A}"/>
+                <a16:creationId xmlns:a16="http://schemas.microsoft.com/office/drawing/2014/main" id="{A1A5DFA8-1756-E78D-55DD-2FB84321F1C7}"/>
               </a:ext>
             </a:extLst>
           </p:cNvPr>
@@ -907,7 +907,7 @@
           <p:cNvPr id="6" name="Slide Number Placeholder 5">
             <a:extLst>
               <a:ext uri="{FF2B5EF4-FFF2-40B4-BE49-F238E27FC236}">
-                <a16:creationId xmlns:a16="http://schemas.microsoft.com/office/drawing/2014/main" id="{C714B035-0779-06FB-6030-64BE041C9E21}"/>
+                <a16:creationId xmlns:a16="http://schemas.microsoft.com/office/drawing/2014/main" id="{96CCC861-22B6-ED9B-E225-5BC4B9773125}"/>
               </a:ext>
             </a:extLst>
           </p:cNvPr>
@@ -923,7 +923,7 @@
           <a:bodyPr/>
           <a:lstStyle/>
           <a:p>
-            <a:fld id="{51EA4D40-7E3E-4880-A61C-AC1212F849E4}" type="slidenum">
+            <a:fld id="{B08209FF-819D-43A2-97A4-6C4DDC35B4FA}" type="slidenum">
               <a:rPr lang="en-US" smtClean="0"/>
               <a:t>‹#›</a:t>
             </a:fld>
@@ -934,7 +934,7 @@
     </p:spTree>
     <p:extLst>
       <p:ext uri="{BB962C8B-B14F-4D97-AF65-F5344CB8AC3E}">
-        <p14:creationId xmlns:p14="http://schemas.microsoft.com/office/powerpoint/2010/main" val="3103371711"/>
+        <p14:creationId xmlns:p14="http://schemas.microsoft.com/office/powerpoint/2010/main" val="459064832"/>
       </p:ext>
     </p:extLst>
   </p:cSld>
@@ -966,7 +966,7 @@
           <p:cNvPr id="2" name="Title 1">
             <a:extLst>
               <a:ext uri="{FF2B5EF4-FFF2-40B4-BE49-F238E27FC236}">
-                <a16:creationId xmlns:a16="http://schemas.microsoft.com/office/drawing/2014/main" id="{159ED8A8-CAE8-DB03-1DF3-F06789981726}"/>
+                <a16:creationId xmlns:a16="http://schemas.microsoft.com/office/drawing/2014/main" id="{92602320-9F5C-2C1F-00FF-C6B1FE8CF7ED}"/>
               </a:ext>
             </a:extLst>
           </p:cNvPr>
@@ -1003,7 +1003,7 @@
           <p:cNvPr id="3" name="Text Placeholder 2">
             <a:extLst>
               <a:ext uri="{FF2B5EF4-FFF2-40B4-BE49-F238E27FC236}">
-                <a16:creationId xmlns:a16="http://schemas.microsoft.com/office/drawing/2014/main" id="{81A07572-E818-4F39-E891-89E0AEF8C9AC}"/>
+                <a16:creationId xmlns:a16="http://schemas.microsoft.com/office/drawing/2014/main" id="{EF5D926E-9781-D4DC-5AE2-7029694B51D6}"/>
               </a:ext>
             </a:extLst>
           </p:cNvPr>
@@ -1128,7 +1128,7 @@
           <p:cNvPr id="4" name="Date Placeholder 3">
             <a:extLst>
               <a:ext uri="{FF2B5EF4-FFF2-40B4-BE49-F238E27FC236}">
-                <a16:creationId xmlns:a16="http://schemas.microsoft.com/office/drawing/2014/main" id="{812D015F-1FDB-AE19-731E-BBFE4A493006}"/>
+                <a16:creationId xmlns:a16="http://schemas.microsoft.com/office/drawing/2014/main" id="{07D11796-3DBF-45C1-7EC6-A5D908D569EF}"/>
               </a:ext>
             </a:extLst>
           </p:cNvPr>
@@ -1144,9 +1144,9 @@
           <a:bodyPr/>
           <a:lstStyle/>
           <a:p>
-            <a:fld id="{0D537BD8-EA9E-467F-B36B-CC24F78C48CB}" type="datetimeFigureOut">
+            <a:fld id="{7D1867BF-27E9-4E78-B03E-D1C72F0D04A0}" type="datetimeFigureOut">
               <a:rPr lang="en-US" smtClean="0"/>
-              <a:t>8/1/2026</a:t>
+              <a:t>8/2/2026</a:t>
             </a:fld>
             <a:endParaRPr lang="en-US"/>
           </a:p>
@@ -1157,7 +1157,7 @@
           <p:cNvPr id="5" name="Footer Placeholder 4">
             <a:extLst>
               <a:ext uri="{FF2B5EF4-FFF2-40B4-BE49-F238E27FC236}">
-                <a16:creationId xmlns:a16="http://schemas.microsoft.com/office/drawing/2014/main" id="{B826E5B7-66B9-95A5-0988-4171E39D0ED5}"/>
+                <a16:creationId xmlns:a16="http://schemas.microsoft.com/office/drawing/2014/main" id="{E9068F4A-E0F5-6955-58C0-7CA1A95EC7D3}"/>
               </a:ext>
             </a:extLst>
           </p:cNvPr>
@@ -1182,7 +1182,7 @@
           <p:cNvPr id="6" name="Slide Number Placeholder 5">
             <a:extLst>
               <a:ext uri="{FF2B5EF4-FFF2-40B4-BE49-F238E27FC236}">
-                <a16:creationId xmlns:a16="http://schemas.microsoft.com/office/drawing/2014/main" id="{91BE4B5C-096E-9CBD-F348-61E82C4681F4}"/>
+                <a16:creationId xmlns:a16="http://schemas.microsoft.com/office/drawing/2014/main" id="{7B86A716-8AD7-D83D-D3AD-531E71132212}"/>
               </a:ext>
             </a:extLst>
           </p:cNvPr>
@@ -1198,7 +1198,7 @@
           <a:bodyPr/>
           <a:lstStyle/>
           <a:p>
-            <a:fld id="{51EA4D40-7E3E-4880-A61C-AC1212F849E4}" type="slidenum">
+            <a:fld id="{B08209FF-819D-43A2-97A4-6C4DDC35B4FA}" type="slidenum">
               <a:rPr lang="en-US" smtClean="0"/>
               <a:t>‹#›</a:t>
             </a:fld>
@@ -1209,7 +1209,7 @@
     </p:spTree>
     <p:extLst>
       <p:ext uri="{BB962C8B-B14F-4D97-AF65-F5344CB8AC3E}">
-        <p14:creationId xmlns:p14="http://schemas.microsoft.com/office/powerpoint/2010/main" val="2319479950"/>
+        <p14:creationId xmlns:p14="http://schemas.microsoft.com/office/powerpoint/2010/main" val="3198805694"/>
       </p:ext>
     </p:extLst>
   </p:cSld>
@@ -1241,7 +1241,7 @@
           <p:cNvPr id="2" name="Title 1">
             <a:extLst>
               <a:ext uri="{FF2B5EF4-FFF2-40B4-BE49-F238E27FC236}">
-                <a16:creationId xmlns:a16="http://schemas.microsoft.com/office/drawing/2014/main" id="{5C081395-9286-F5DE-DE26-CF06AC6FF436}"/>
+                <a16:creationId xmlns:a16="http://schemas.microsoft.com/office/drawing/2014/main" id="{DB62B601-B9AE-1F18-28E1-6BD5708A90CC}"/>
               </a:ext>
             </a:extLst>
           </p:cNvPr>
@@ -1269,7 +1269,7 @@
           <p:cNvPr id="3" name="Content Placeholder 2">
             <a:extLst>
               <a:ext uri="{FF2B5EF4-FFF2-40B4-BE49-F238E27FC236}">
-                <a16:creationId xmlns:a16="http://schemas.microsoft.com/office/drawing/2014/main" id="{19A9AC2F-8A3E-1E3F-2014-216BB2EDC620}"/>
+                <a16:creationId xmlns:a16="http://schemas.microsoft.com/office/drawing/2014/main" id="{1A9F63FA-B229-74C8-7103-E508C8403E95}"/>
               </a:ext>
             </a:extLst>
           </p:cNvPr>
@@ -1331,7 +1331,7 @@
           <p:cNvPr id="4" name="Content Placeholder 3">
             <a:extLst>
               <a:ext uri="{FF2B5EF4-FFF2-40B4-BE49-F238E27FC236}">
-                <a16:creationId xmlns:a16="http://schemas.microsoft.com/office/drawing/2014/main" id="{A44F5B50-1ADE-3291-0851-E63C6F49D2C0}"/>
+                <a16:creationId xmlns:a16="http://schemas.microsoft.com/office/drawing/2014/main" id="{F3023DA2-8A6E-8BF5-BEF2-00413897EA79}"/>
               </a:ext>
             </a:extLst>
           </p:cNvPr>
@@ -1393,7 +1393,7 @@
           <p:cNvPr id="5" name="Date Placeholder 4">
             <a:extLst>
               <a:ext uri="{FF2B5EF4-FFF2-40B4-BE49-F238E27FC236}">
-                <a16:creationId xmlns:a16="http://schemas.microsoft.com/office/drawing/2014/main" id="{E711B5B7-8B19-1871-A1F3-0F14DE1FE0FC}"/>
+                <a16:creationId xmlns:a16="http://schemas.microsoft.com/office/drawing/2014/main" id="{A9487EEF-16D6-E34B-4BC6-8BC5E77AA2AA}"/>
               </a:ext>
             </a:extLst>
           </p:cNvPr>
@@ -1409,9 +1409,9 @@
           <a:bodyPr/>
           <a:lstStyle/>
           <a:p>
-            <a:fld id="{0D537BD8-EA9E-467F-B36B-CC24F78C48CB}" type="datetimeFigureOut">
+            <a:fld id="{7D1867BF-27E9-4E78-B03E-D1C72F0D04A0}" type="datetimeFigureOut">
               <a:rPr lang="en-US" smtClean="0"/>
-              <a:t>8/1/2026</a:t>
+              <a:t>8/2/2026</a:t>
             </a:fld>
             <a:endParaRPr lang="en-US"/>
           </a:p>
@@ -1422,7 +1422,7 @@
           <p:cNvPr id="6" name="Footer Placeholder 5">
             <a:extLst>
               <a:ext uri="{FF2B5EF4-FFF2-40B4-BE49-F238E27FC236}">
-                <a16:creationId xmlns:a16="http://schemas.microsoft.com/office/drawing/2014/main" id="{B7061024-C3CE-6AAE-6D50-368D5DA2A803}"/>
+                <a16:creationId xmlns:a16="http://schemas.microsoft.com/office/drawing/2014/main" id="{70BA9B7D-4CAD-77F0-6DD5-693D535700CE}"/>
               </a:ext>
             </a:extLst>
           </p:cNvPr>
@@ -1447,7 +1447,7 @@
           <p:cNvPr id="7" name="Slide Number Placeholder 6">
             <a:extLst>
               <a:ext uri="{FF2B5EF4-FFF2-40B4-BE49-F238E27FC236}">
-                <a16:creationId xmlns:a16="http://schemas.microsoft.com/office/drawing/2014/main" id="{E5A5EE2D-B482-A365-E628-76C7FFC8D5DA}"/>
+                <a16:creationId xmlns:a16="http://schemas.microsoft.com/office/drawing/2014/main" id="{D09C9711-1FAE-554A-F092-66F498AAFEFF}"/>
               </a:ext>
             </a:extLst>
           </p:cNvPr>
@@ -1463,7 +1463,7 @@
           <a:bodyPr/>
           <a:lstStyle/>
           <a:p>
-            <a:fld id="{51EA4D40-7E3E-4880-A61C-AC1212F849E4}" type="slidenum">
+            <a:fld id="{B08209FF-819D-43A2-97A4-6C4DDC35B4FA}" type="slidenum">
               <a:rPr lang="en-US" smtClean="0"/>
               <a:t>‹#›</a:t>
             </a:fld>
@@ -1474,7 +1474,7 @@
     </p:spTree>
     <p:extLst>
       <p:ext uri="{BB962C8B-B14F-4D97-AF65-F5344CB8AC3E}">
-        <p14:creationId xmlns:p14="http://schemas.microsoft.com/office/powerpoint/2010/main" val="4174654034"/>
+        <p14:creationId xmlns:p14="http://schemas.microsoft.com/office/powerpoint/2010/main" val="4071765513"/>
       </p:ext>
     </p:extLst>
   </p:cSld>
@@ -1506,7 +1506,7 @@
           <p:cNvPr id="2" name="Title 1">
             <a:extLst>
               <a:ext uri="{FF2B5EF4-FFF2-40B4-BE49-F238E27FC236}">
-                <a16:creationId xmlns:a16="http://schemas.microsoft.com/office/drawing/2014/main" id="{2D839C6E-4EDF-3EC0-DB9E-342AB84D23D7}"/>
+                <a16:creationId xmlns:a16="http://schemas.microsoft.com/office/drawing/2014/main" id="{079CC26A-D250-5E5F-5EB3-FBCFB66B893D}"/>
               </a:ext>
             </a:extLst>
           </p:cNvPr>
@@ -1539,7 +1539,7 @@
           <p:cNvPr id="3" name="Text Placeholder 2">
             <a:extLst>
               <a:ext uri="{FF2B5EF4-FFF2-40B4-BE49-F238E27FC236}">
-                <a16:creationId xmlns:a16="http://schemas.microsoft.com/office/drawing/2014/main" id="{B42B29AB-D075-2554-97AC-DD3786538A25}"/>
+                <a16:creationId xmlns:a16="http://schemas.microsoft.com/office/drawing/2014/main" id="{91F8107F-3F2F-EDF9-2587-9046EF05697A}"/>
               </a:ext>
             </a:extLst>
           </p:cNvPr>
@@ -1610,7 +1610,7 @@
           <p:cNvPr id="4" name="Content Placeholder 3">
             <a:extLst>
               <a:ext uri="{FF2B5EF4-FFF2-40B4-BE49-F238E27FC236}">
-                <a16:creationId xmlns:a16="http://schemas.microsoft.com/office/drawing/2014/main" id="{0AD83A92-2F64-9954-FA64-00A83465DCDC}"/>
+                <a16:creationId xmlns:a16="http://schemas.microsoft.com/office/drawing/2014/main" id="{0AA1BC83-C662-3D28-6C83-866BB5A946D7}"/>
               </a:ext>
             </a:extLst>
           </p:cNvPr>
@@ -1672,7 +1672,7 @@
           <p:cNvPr id="5" name="Text Placeholder 4">
             <a:extLst>
               <a:ext uri="{FF2B5EF4-FFF2-40B4-BE49-F238E27FC236}">
-                <a16:creationId xmlns:a16="http://schemas.microsoft.com/office/drawing/2014/main" id="{F1BBBC74-B1DF-0086-919C-C8F34965AB2D}"/>
+                <a16:creationId xmlns:a16="http://schemas.microsoft.com/office/drawing/2014/main" id="{714906E5-CA5F-38DE-2243-E1A66106B758}"/>
               </a:ext>
             </a:extLst>
           </p:cNvPr>
@@ -1743,7 +1743,7 @@
           <p:cNvPr id="6" name="Content Placeholder 5">
             <a:extLst>
               <a:ext uri="{FF2B5EF4-FFF2-40B4-BE49-F238E27FC236}">
-                <a16:creationId xmlns:a16="http://schemas.microsoft.com/office/drawing/2014/main" id="{F9D1C88A-8636-A0CD-801A-C4E8788B33C6}"/>
+                <a16:creationId xmlns:a16="http://schemas.microsoft.com/office/drawing/2014/main" id="{9431FF3B-AAAA-464B-B8E6-C79318FC020F}"/>
               </a:ext>
             </a:extLst>
           </p:cNvPr>
@@ -1805,7 +1805,7 @@
           <p:cNvPr id="7" name="Date Placeholder 6">
             <a:extLst>
               <a:ext uri="{FF2B5EF4-FFF2-40B4-BE49-F238E27FC236}">
-                <a16:creationId xmlns:a16="http://schemas.microsoft.com/office/drawing/2014/main" id="{91502E51-8C14-7424-B78D-9AF71645E884}"/>
+                <a16:creationId xmlns:a16="http://schemas.microsoft.com/office/drawing/2014/main" id="{246202D9-7FD3-FD76-D6AC-61B83B069A7C}"/>
               </a:ext>
             </a:extLst>
           </p:cNvPr>
@@ -1821,9 +1821,9 @@
           <a:bodyPr/>
           <a:lstStyle/>
           <a:p>
-            <a:fld id="{0D537BD8-EA9E-467F-B36B-CC24F78C48CB}" type="datetimeFigureOut">
+            <a:fld id="{7D1867BF-27E9-4E78-B03E-D1C72F0D04A0}" type="datetimeFigureOut">
               <a:rPr lang="en-US" smtClean="0"/>
-              <a:t>8/1/2026</a:t>
+              <a:t>8/2/2026</a:t>
             </a:fld>
             <a:endParaRPr lang="en-US"/>
           </a:p>
@@ -1834,7 +1834,7 @@
           <p:cNvPr id="8" name="Footer Placeholder 7">
             <a:extLst>
               <a:ext uri="{FF2B5EF4-FFF2-40B4-BE49-F238E27FC236}">
-                <a16:creationId xmlns:a16="http://schemas.microsoft.com/office/drawing/2014/main" id="{A00785F8-7945-EF9A-C3BA-181FD69DAE3E}"/>
+                <a16:creationId xmlns:a16="http://schemas.microsoft.com/office/drawing/2014/main" id="{617A36D3-A781-34AF-1774-9B42CDF42DD9}"/>
               </a:ext>
             </a:extLst>
           </p:cNvPr>
@@ -1859,7 +1859,7 @@
           <p:cNvPr id="9" name="Slide Number Placeholder 8">
             <a:extLst>
               <a:ext uri="{FF2B5EF4-FFF2-40B4-BE49-F238E27FC236}">
-                <a16:creationId xmlns:a16="http://schemas.microsoft.com/office/drawing/2014/main" id="{29CADFF2-1A51-3856-B90E-E03F4525823D}"/>
+                <a16:creationId xmlns:a16="http://schemas.microsoft.com/office/drawing/2014/main" id="{135E01F3-7443-D5AE-9DFF-A24E68488B96}"/>
               </a:ext>
             </a:extLst>
           </p:cNvPr>
@@ -1875,7 +1875,7 @@
           <a:bodyPr/>
           <a:lstStyle/>
           <a:p>
-            <a:fld id="{51EA4D40-7E3E-4880-A61C-AC1212F849E4}" type="slidenum">
+            <a:fld id="{B08209FF-819D-43A2-97A4-6C4DDC35B4FA}" type="slidenum">
               <a:rPr lang="en-US" smtClean="0"/>
               <a:t>‹#›</a:t>
             </a:fld>
@@ -1886,7 +1886,7 @@
     </p:spTree>
     <p:extLst>
       <p:ext uri="{BB962C8B-B14F-4D97-AF65-F5344CB8AC3E}">
-        <p14:creationId xmlns:p14="http://schemas.microsoft.com/office/powerpoint/2010/main" val="1209189980"/>
+        <p14:creationId xmlns:p14="http://schemas.microsoft.com/office/powerpoint/2010/main" val="2103526037"/>
       </p:ext>
     </p:extLst>
   </p:cSld>
@@ -1918,7 +1918,7 @@
           <p:cNvPr id="2" name="Title 1">
             <a:extLst>
               <a:ext uri="{FF2B5EF4-FFF2-40B4-BE49-F238E27FC236}">
-                <a16:creationId xmlns:a16="http://schemas.microsoft.com/office/drawing/2014/main" id="{0EB62AB5-960A-23F5-DB42-6C9C477AC345}"/>
+                <a16:creationId xmlns:a16="http://schemas.microsoft.com/office/drawing/2014/main" id="{BBFD94C2-0BA1-BD90-41F7-2BEF931B7C2B}"/>
               </a:ext>
             </a:extLst>
           </p:cNvPr>
@@ -1946,7 +1946,7 @@
           <p:cNvPr id="3" name="Date Placeholder 2">
             <a:extLst>
               <a:ext uri="{FF2B5EF4-FFF2-40B4-BE49-F238E27FC236}">
-                <a16:creationId xmlns:a16="http://schemas.microsoft.com/office/drawing/2014/main" id="{EC2A330B-705E-42C9-A29E-6EDF09C295C9}"/>
+                <a16:creationId xmlns:a16="http://schemas.microsoft.com/office/drawing/2014/main" id="{6D36B2C9-8D63-FF08-AE01-04E2F8411844}"/>
               </a:ext>
             </a:extLst>
           </p:cNvPr>
@@ -1962,9 +1962,9 @@
           <a:bodyPr/>
           <a:lstStyle/>
           <a:p>
-            <a:fld id="{0D537BD8-EA9E-467F-B36B-CC24F78C48CB}" type="datetimeFigureOut">
+            <a:fld id="{7D1867BF-27E9-4E78-B03E-D1C72F0D04A0}" type="datetimeFigureOut">
               <a:rPr lang="en-US" smtClean="0"/>
-              <a:t>8/1/2026</a:t>
+              <a:t>8/2/2026</a:t>
             </a:fld>
             <a:endParaRPr lang="en-US"/>
           </a:p>
@@ -1975,7 +1975,7 @@
           <p:cNvPr id="4" name="Footer Placeholder 3">
             <a:extLst>
               <a:ext uri="{FF2B5EF4-FFF2-40B4-BE49-F238E27FC236}">
-                <a16:creationId xmlns:a16="http://schemas.microsoft.com/office/drawing/2014/main" id="{6006FA9F-48E8-C4B1-D98D-8510221DFD90}"/>
+                <a16:creationId xmlns:a16="http://schemas.microsoft.com/office/drawing/2014/main" id="{ED733073-7E84-2A41-891E-672FC9DF898B}"/>
               </a:ext>
             </a:extLst>
           </p:cNvPr>
@@ -2000,7 +2000,7 @@
           <p:cNvPr id="5" name="Slide Number Placeholder 4">
             <a:extLst>
               <a:ext uri="{FF2B5EF4-FFF2-40B4-BE49-F238E27FC236}">
-                <a16:creationId xmlns:a16="http://schemas.microsoft.com/office/drawing/2014/main" id="{70E526FB-BAD5-9DDE-D24E-59F5B402FA74}"/>
+                <a16:creationId xmlns:a16="http://schemas.microsoft.com/office/drawing/2014/main" id="{1F65A5F2-924B-0C8E-A208-EFA3BA9358E3}"/>
               </a:ext>
             </a:extLst>
           </p:cNvPr>
@@ -2016,7 +2016,7 @@
           <a:bodyPr/>
           <a:lstStyle/>
           <a:p>
-            <a:fld id="{51EA4D40-7E3E-4880-A61C-AC1212F849E4}" type="slidenum">
+            <a:fld id="{B08209FF-819D-43A2-97A4-6C4DDC35B4FA}" type="slidenum">
               <a:rPr lang="en-US" smtClean="0"/>
               <a:t>‹#›</a:t>
             </a:fld>
@@ -2027,7 +2027,7 @@
     </p:spTree>
     <p:extLst>
       <p:ext uri="{BB962C8B-B14F-4D97-AF65-F5344CB8AC3E}">
-        <p14:creationId xmlns:p14="http://schemas.microsoft.com/office/powerpoint/2010/main" val="1041164683"/>
+        <p14:creationId xmlns:p14="http://schemas.microsoft.com/office/powerpoint/2010/main" val="1744506091"/>
       </p:ext>
     </p:extLst>
   </p:cSld>
@@ -2059,7 +2059,7 @@
           <p:cNvPr id="2" name="Date Placeholder 1">
             <a:extLst>
               <a:ext uri="{FF2B5EF4-FFF2-40B4-BE49-F238E27FC236}">
-                <a16:creationId xmlns:a16="http://schemas.microsoft.com/office/drawing/2014/main" id="{AA9B5D84-A181-7F3F-59E0-B24966666857}"/>
+                <a16:creationId xmlns:a16="http://schemas.microsoft.com/office/drawing/2014/main" id="{B99F11C5-75A7-03E8-D3CB-CEAEA8F46D31}"/>
               </a:ext>
             </a:extLst>
           </p:cNvPr>
@@ -2075,9 +2075,9 @@
           <a:bodyPr/>
           <a:lstStyle/>
           <a:p>
-            <a:fld id="{0D537BD8-EA9E-467F-B36B-CC24F78C48CB}" type="datetimeFigureOut">
+            <a:fld id="{7D1867BF-27E9-4E78-B03E-D1C72F0D04A0}" type="datetimeFigureOut">
               <a:rPr lang="en-US" smtClean="0"/>
-              <a:t>8/1/2026</a:t>
+              <a:t>8/2/2026</a:t>
             </a:fld>
             <a:endParaRPr lang="en-US"/>
           </a:p>
@@ -2088,7 +2088,7 @@
           <p:cNvPr id="3" name="Footer Placeholder 2">
             <a:extLst>
               <a:ext uri="{FF2B5EF4-FFF2-40B4-BE49-F238E27FC236}">
-                <a16:creationId xmlns:a16="http://schemas.microsoft.com/office/drawing/2014/main" id="{5700C722-ECBE-CC24-5F82-1F016D6B06D5}"/>
+                <a16:creationId xmlns:a16="http://schemas.microsoft.com/office/drawing/2014/main" id="{B4652F66-7FA1-81DB-6099-AA06C0EC10C1}"/>
               </a:ext>
             </a:extLst>
           </p:cNvPr>
@@ -2113,7 +2113,7 @@
           <p:cNvPr id="4" name="Slide Number Placeholder 3">
             <a:extLst>
               <a:ext uri="{FF2B5EF4-FFF2-40B4-BE49-F238E27FC236}">
-                <a16:creationId xmlns:a16="http://schemas.microsoft.com/office/drawing/2014/main" id="{52C17814-228D-5677-D8E9-8F130663034D}"/>
+                <a16:creationId xmlns:a16="http://schemas.microsoft.com/office/drawing/2014/main" id="{3314BE7B-307A-07E7-3454-57CEB28E21E9}"/>
               </a:ext>
             </a:extLst>
           </p:cNvPr>
@@ -2129,7 +2129,7 @@
           <a:bodyPr/>
           <a:lstStyle/>
           <a:p>
-            <a:fld id="{51EA4D40-7E3E-4880-A61C-AC1212F849E4}" type="slidenum">
+            <a:fld id="{B08209FF-819D-43A2-97A4-6C4DDC35B4FA}" type="slidenum">
               <a:rPr lang="en-US" smtClean="0"/>
               <a:t>‹#›</a:t>
             </a:fld>
@@ -2140,7 +2140,7 @@
     </p:spTree>
     <p:extLst>
       <p:ext uri="{BB962C8B-B14F-4D97-AF65-F5344CB8AC3E}">
-        <p14:creationId xmlns:p14="http://schemas.microsoft.com/office/powerpoint/2010/main" val="700524671"/>
+        <p14:creationId xmlns:p14="http://schemas.microsoft.com/office/powerpoint/2010/main" val="2162096505"/>
       </p:ext>
     </p:extLst>
   </p:cSld>
@@ -2172,7 +2172,7 @@
           <p:cNvPr id="2" name="Title 1">
             <a:extLst>
               <a:ext uri="{FF2B5EF4-FFF2-40B4-BE49-F238E27FC236}">
-                <a16:creationId xmlns:a16="http://schemas.microsoft.com/office/drawing/2014/main" id="{2B8DB2BB-11E4-8E9E-9F4E-501224879F13}"/>
+                <a16:creationId xmlns:a16="http://schemas.microsoft.com/office/drawing/2014/main" id="{FA6C5445-165B-BF88-05F8-48B7FE9EC2D5}"/>
               </a:ext>
             </a:extLst>
           </p:cNvPr>
@@ -2209,7 +2209,7 @@
           <p:cNvPr id="3" name="Content Placeholder 2">
             <a:extLst>
               <a:ext uri="{FF2B5EF4-FFF2-40B4-BE49-F238E27FC236}">
-                <a16:creationId xmlns:a16="http://schemas.microsoft.com/office/drawing/2014/main" id="{0871C0A0-E7ED-7DF1-27A8-E2661F8C0E6D}"/>
+                <a16:creationId xmlns:a16="http://schemas.microsoft.com/office/drawing/2014/main" id="{E90F2958-3031-635B-D610-ABD3D6585BA4}"/>
               </a:ext>
             </a:extLst>
           </p:cNvPr>
@@ -2299,7 +2299,7 @@
           <p:cNvPr id="4" name="Text Placeholder 3">
             <a:extLst>
               <a:ext uri="{FF2B5EF4-FFF2-40B4-BE49-F238E27FC236}">
-                <a16:creationId xmlns:a16="http://schemas.microsoft.com/office/drawing/2014/main" id="{39588837-016A-43F4-37F5-B5AE88681C28}"/>
+                <a16:creationId xmlns:a16="http://schemas.microsoft.com/office/drawing/2014/main" id="{81F8D114-F9E0-8C84-F84B-FBFEF301B9EE}"/>
               </a:ext>
             </a:extLst>
           </p:cNvPr>
@@ -2370,7 +2370,7 @@
           <p:cNvPr id="5" name="Date Placeholder 4">
             <a:extLst>
               <a:ext uri="{FF2B5EF4-FFF2-40B4-BE49-F238E27FC236}">
-                <a16:creationId xmlns:a16="http://schemas.microsoft.com/office/drawing/2014/main" id="{603AFD80-96B2-99F2-446D-102019B48C9C}"/>
+                <a16:creationId xmlns:a16="http://schemas.microsoft.com/office/drawing/2014/main" id="{549CC306-2254-03D2-B786-DD932BF0C04B}"/>
               </a:ext>
             </a:extLst>
           </p:cNvPr>
@@ -2386,9 +2386,9 @@
           <a:bodyPr/>
           <a:lstStyle/>
           <a:p>
-            <a:fld id="{0D537BD8-EA9E-467F-B36B-CC24F78C48CB}" type="datetimeFigureOut">
+            <a:fld id="{7D1867BF-27E9-4E78-B03E-D1C72F0D04A0}" type="datetimeFigureOut">
               <a:rPr lang="en-US" smtClean="0"/>
-              <a:t>8/1/2026</a:t>
+              <a:t>8/2/2026</a:t>
             </a:fld>
             <a:endParaRPr lang="en-US"/>
           </a:p>
@@ -2399,7 +2399,7 @@
           <p:cNvPr id="6" name="Footer Placeholder 5">
             <a:extLst>
               <a:ext uri="{FF2B5EF4-FFF2-40B4-BE49-F238E27FC236}">
-                <a16:creationId xmlns:a16="http://schemas.microsoft.com/office/drawing/2014/main" id="{8820C664-B558-29E9-321E-FF932FCB934A}"/>
+                <a16:creationId xmlns:a16="http://schemas.microsoft.com/office/drawing/2014/main" id="{B8846074-C178-75DF-2BDF-54C0337210C1}"/>
               </a:ext>
             </a:extLst>
           </p:cNvPr>
@@ -2424,7 +2424,7 @@
           <p:cNvPr id="7" name="Slide Number Placeholder 6">
             <a:extLst>
               <a:ext uri="{FF2B5EF4-FFF2-40B4-BE49-F238E27FC236}">
-                <a16:creationId xmlns:a16="http://schemas.microsoft.com/office/drawing/2014/main" id="{E2D7B80D-8621-67BD-0788-5B1CDC4D12F3}"/>
+                <a16:creationId xmlns:a16="http://schemas.microsoft.com/office/drawing/2014/main" id="{DA3A08D9-E0B0-3A81-A82C-FB3882D1CA4B}"/>
               </a:ext>
             </a:extLst>
           </p:cNvPr>
@@ -2440,7 +2440,7 @@
           <a:bodyPr/>
           <a:lstStyle/>
           <a:p>
-            <a:fld id="{51EA4D40-7E3E-4880-A61C-AC1212F849E4}" type="slidenum">
+            <a:fld id="{B08209FF-819D-43A2-97A4-6C4DDC35B4FA}" type="slidenum">
               <a:rPr lang="en-US" smtClean="0"/>
               <a:t>‹#›</a:t>
             </a:fld>
@@ -2451,7 +2451,7 @@
     </p:spTree>
     <p:extLst>
       <p:ext uri="{BB962C8B-B14F-4D97-AF65-F5344CB8AC3E}">
-        <p14:creationId xmlns:p14="http://schemas.microsoft.com/office/powerpoint/2010/main" val="881542581"/>
+        <p14:creationId xmlns:p14="http://schemas.microsoft.com/office/powerpoint/2010/main" val="1229133835"/>
       </p:ext>
     </p:extLst>
   </p:cSld>
@@ -2483,7 +2483,7 @@
           <p:cNvPr id="2" name="Title 1">
             <a:extLst>
               <a:ext uri="{FF2B5EF4-FFF2-40B4-BE49-F238E27FC236}">
-                <a16:creationId xmlns:a16="http://schemas.microsoft.com/office/drawing/2014/main" id="{F267C14B-380D-49A2-95C9-96F2481DA127}"/>
+                <a16:creationId xmlns:a16="http://schemas.microsoft.com/office/drawing/2014/main" id="{F22EC7C9-5B01-B7AD-E415-FD52AE0B0912}"/>
               </a:ext>
             </a:extLst>
           </p:cNvPr>
@@ -2520,7 +2520,7 @@
           <p:cNvPr id="3" name="Picture Placeholder 2">
             <a:extLst>
               <a:ext uri="{FF2B5EF4-FFF2-40B4-BE49-F238E27FC236}">
-                <a16:creationId xmlns:a16="http://schemas.microsoft.com/office/drawing/2014/main" id="{93BE81D8-2A99-8ED2-D6DF-53555BD2792B}"/>
+                <a16:creationId xmlns:a16="http://schemas.microsoft.com/office/drawing/2014/main" id="{D25D5064-7321-8BAD-0F76-CB97B8F83212}"/>
               </a:ext>
             </a:extLst>
           </p:cNvPr>
@@ -2587,7 +2587,7 @@
           <p:cNvPr id="4" name="Text Placeholder 3">
             <a:extLst>
               <a:ext uri="{FF2B5EF4-FFF2-40B4-BE49-F238E27FC236}">
-                <a16:creationId xmlns:a16="http://schemas.microsoft.com/office/drawing/2014/main" id="{3BA24263-621D-D114-A275-97CE6A4CF1E0}"/>
+                <a16:creationId xmlns:a16="http://schemas.microsoft.com/office/drawing/2014/main" id="{06CC0097-1947-6E84-A246-9BE48FB27CAB}"/>
               </a:ext>
             </a:extLst>
           </p:cNvPr>
@@ -2658,7 +2658,7 @@
           <p:cNvPr id="5" name="Date Placeholder 4">
             <a:extLst>
               <a:ext uri="{FF2B5EF4-FFF2-40B4-BE49-F238E27FC236}">
-                <a16:creationId xmlns:a16="http://schemas.microsoft.com/office/drawing/2014/main" id="{8DC99D78-11C4-280F-1049-4CE66B2E3A5A}"/>
+                <a16:creationId xmlns:a16="http://schemas.microsoft.com/office/drawing/2014/main" id="{0D618794-80B3-D810-2C80-77716CB99F93}"/>
               </a:ext>
             </a:extLst>
           </p:cNvPr>
@@ -2674,9 +2674,9 @@
           <a:bodyPr/>
           <a:lstStyle/>
           <a:p>
-            <a:fld id="{0D537BD8-EA9E-467F-B36B-CC24F78C48CB}" type="datetimeFigureOut">
+            <a:fld id="{7D1867BF-27E9-4E78-B03E-D1C72F0D04A0}" type="datetimeFigureOut">
               <a:rPr lang="en-US" smtClean="0"/>
-              <a:t>8/1/2026</a:t>
+              <a:t>8/2/2026</a:t>
             </a:fld>
             <a:endParaRPr lang="en-US"/>
           </a:p>
@@ -2687,7 +2687,7 @@
           <p:cNvPr id="6" name="Footer Placeholder 5">
             <a:extLst>
               <a:ext uri="{FF2B5EF4-FFF2-40B4-BE49-F238E27FC236}">
-                <a16:creationId xmlns:a16="http://schemas.microsoft.com/office/drawing/2014/main" id="{5166A402-96F6-BD97-63B9-B9AAD9A7D9E9}"/>
+                <a16:creationId xmlns:a16="http://schemas.microsoft.com/office/drawing/2014/main" id="{7CD78C38-84ED-4D77-A7B8-7E697AA84BA7}"/>
               </a:ext>
             </a:extLst>
           </p:cNvPr>
@@ -2712,7 +2712,7 @@
           <p:cNvPr id="7" name="Slide Number Placeholder 6">
             <a:extLst>
               <a:ext uri="{FF2B5EF4-FFF2-40B4-BE49-F238E27FC236}">
-                <a16:creationId xmlns:a16="http://schemas.microsoft.com/office/drawing/2014/main" id="{F5A54821-D5C2-5F3F-02D4-146E9439CA8F}"/>
+                <a16:creationId xmlns:a16="http://schemas.microsoft.com/office/drawing/2014/main" id="{60D37C15-57E2-F8AF-D0A0-745BE11AC16A}"/>
               </a:ext>
             </a:extLst>
           </p:cNvPr>
@@ -2728,7 +2728,7 @@
           <a:bodyPr/>
           <a:lstStyle/>
           <a:p>
-            <a:fld id="{51EA4D40-7E3E-4880-A61C-AC1212F849E4}" type="slidenum">
+            <a:fld id="{B08209FF-819D-43A2-97A4-6C4DDC35B4FA}" type="slidenum">
               <a:rPr lang="en-US" smtClean="0"/>
               <a:t>‹#›</a:t>
             </a:fld>
@@ -2739,7 +2739,7 @@
     </p:spTree>
     <p:extLst>
       <p:ext uri="{BB962C8B-B14F-4D97-AF65-F5344CB8AC3E}">
-        <p14:creationId xmlns:p14="http://schemas.microsoft.com/office/powerpoint/2010/main" val="3477340419"/>
+        <p14:creationId xmlns:p14="http://schemas.microsoft.com/office/powerpoint/2010/main" val="3082286244"/>
       </p:ext>
     </p:extLst>
   </p:cSld>
@@ -2776,7 +2776,7 @@
           <p:cNvPr id="2" name="Title Placeholder 1">
             <a:extLst>
               <a:ext uri="{FF2B5EF4-FFF2-40B4-BE49-F238E27FC236}">
-                <a16:creationId xmlns:a16="http://schemas.microsoft.com/office/drawing/2014/main" id="{48A3BAEA-B34D-7F06-EFB6-63E7977434F5}"/>
+                <a16:creationId xmlns:a16="http://schemas.microsoft.com/office/drawing/2014/main" id="{AC369113-E781-E006-798A-167F87008CE7}"/>
               </a:ext>
             </a:extLst>
           </p:cNvPr>
@@ -2814,7 +2814,7 @@
           <p:cNvPr id="3" name="Text Placeholder 2">
             <a:extLst>
               <a:ext uri="{FF2B5EF4-FFF2-40B4-BE49-F238E27FC236}">
-                <a16:creationId xmlns:a16="http://schemas.microsoft.com/office/drawing/2014/main" id="{FD908BE5-30BB-4953-6517-A73040278411}"/>
+                <a16:creationId xmlns:a16="http://schemas.microsoft.com/office/drawing/2014/main" id="{85CFF36A-4276-A92C-8E6B-9F4A7E33A815}"/>
               </a:ext>
             </a:extLst>
           </p:cNvPr>
@@ -2881,7 +2881,7 @@
           <p:cNvPr id="4" name="Date Placeholder 3">
             <a:extLst>
               <a:ext uri="{FF2B5EF4-FFF2-40B4-BE49-F238E27FC236}">
-                <a16:creationId xmlns:a16="http://schemas.microsoft.com/office/drawing/2014/main" id="{19875089-C711-DDE5-EA7B-643018E35D13}"/>
+                <a16:creationId xmlns:a16="http://schemas.microsoft.com/office/drawing/2014/main" id="{11A08B6F-7E09-BB2F-9A3E-BBB205FE19C5}"/>
               </a:ext>
             </a:extLst>
           </p:cNvPr>
@@ -2915,9 +2915,9 @@
             </a:lvl1pPr>
           </a:lstStyle>
           <a:p>
-            <a:fld id="{0D537BD8-EA9E-467F-B36B-CC24F78C48CB}" type="datetimeFigureOut">
+            <a:fld id="{7D1867BF-27E9-4E78-B03E-D1C72F0D04A0}" type="datetimeFigureOut">
               <a:rPr lang="en-US" smtClean="0"/>
-              <a:t>8/1/2026</a:t>
+              <a:t>8/2/2026</a:t>
             </a:fld>
             <a:endParaRPr lang="en-US"/>
           </a:p>
@@ -2928,7 +2928,7 @@
           <p:cNvPr id="5" name="Footer Placeholder 4">
             <a:extLst>
               <a:ext uri="{FF2B5EF4-FFF2-40B4-BE49-F238E27FC236}">
-                <a16:creationId xmlns:a16="http://schemas.microsoft.com/office/drawing/2014/main" id="{495312A3-911C-6F93-3213-A90E587AB276}"/>
+                <a16:creationId xmlns:a16="http://schemas.microsoft.com/office/drawing/2014/main" id="{2D98A49B-087A-DAF5-2FA7-2A2F2F67C1CC}"/>
               </a:ext>
             </a:extLst>
           </p:cNvPr>
@@ -2971,7 +2971,7 @@
           <p:cNvPr id="6" name="Slide Number Placeholder 5">
             <a:extLst>
               <a:ext uri="{FF2B5EF4-FFF2-40B4-BE49-F238E27FC236}">
-                <a16:creationId xmlns:a16="http://schemas.microsoft.com/office/drawing/2014/main" id="{00541BD5-CFCE-9295-2B1A-5883ABEC1DA6}"/>
+                <a16:creationId xmlns:a16="http://schemas.microsoft.com/office/drawing/2014/main" id="{5089025C-F8C0-BFE2-F9BC-01C9D9CD75F4}"/>
               </a:ext>
             </a:extLst>
           </p:cNvPr>
@@ -3005,7 +3005,7 @@
             </a:lvl1pPr>
           </a:lstStyle>
           <a:p>
-            <a:fld id="{51EA4D40-7E3E-4880-A61C-AC1212F849E4}" type="slidenum">
+            <a:fld id="{B08209FF-819D-43A2-97A4-6C4DDC35B4FA}" type="slidenum">
               <a:rPr lang="en-US" smtClean="0"/>
               <a:t>‹#›</a:t>
             </a:fld>
@@ -3016,7 +3016,7 @@
     </p:spTree>
     <p:extLst>
       <p:ext uri="{BB962C8B-B14F-4D97-AF65-F5344CB8AC3E}">
-        <p14:creationId xmlns:p14="http://schemas.microsoft.com/office/powerpoint/2010/main" val="3788085188"/>
+        <p14:creationId xmlns:p14="http://schemas.microsoft.com/office/powerpoint/2010/main" val="3153553570"/>
       </p:ext>
     </p:extLst>
   </p:cSld>
@@ -3339,7 +3339,7 @@
           <p:cNvPr id="2" name="Rectangle 1">
             <a:extLst>
               <a:ext uri="{FF2B5EF4-FFF2-40B4-BE49-F238E27FC236}">
-                <a16:creationId xmlns:a16="http://schemas.microsoft.com/office/drawing/2014/main" id="{4A138D10-1297-F76D-F403-A2743C93776C}"/>
+                <a16:creationId xmlns:a16="http://schemas.microsoft.com/office/drawing/2014/main" id="{85E1FE8C-E6B3-5EE1-D2E4-DBDDCE97EFC7}"/>
               </a:ext>
             </a:extLst>
           </p:cNvPr>
@@ -3407,7 +3407,7 @@
           <p:cNvPr id="3" name="Rectangle 2">
             <a:extLst>
               <a:ext uri="{FF2B5EF4-FFF2-40B4-BE49-F238E27FC236}">
-                <a16:creationId xmlns:a16="http://schemas.microsoft.com/office/drawing/2014/main" id="{7CA20070-0E87-BB2A-81A7-C1B35B2A7D71}"/>
+                <a16:creationId xmlns:a16="http://schemas.microsoft.com/office/drawing/2014/main" id="{D091EA2D-CBC4-D536-6B82-51411EA896D2}"/>
               </a:ext>
             </a:extLst>
           </p:cNvPr>
@@ -3475,7 +3475,7 @@
           <p:cNvPr id="4" name="TextBox 3">
             <a:extLst>
               <a:ext uri="{FF2B5EF4-FFF2-40B4-BE49-F238E27FC236}">
-                <a16:creationId xmlns:a16="http://schemas.microsoft.com/office/drawing/2014/main" id="{24C74AEA-5386-3C46-13BB-D3B0B2580F48}"/>
+                <a16:creationId xmlns:a16="http://schemas.microsoft.com/office/drawing/2014/main" id="{56CAF8F7-083A-6A49-DEDA-2A9A5EB894A0}"/>
               </a:ext>
             </a:extLst>
           </p:cNvPr>
@@ -3515,7 +3515,7 @@
           <p:cNvPr id="5" name="TextBox 4">
             <a:extLst>
               <a:ext uri="{FF2B5EF4-FFF2-40B4-BE49-F238E27FC236}">
-                <a16:creationId xmlns:a16="http://schemas.microsoft.com/office/drawing/2014/main" id="{89974DAE-804B-D701-D7C2-890A2DCB18FD}"/>
+                <a16:creationId xmlns:a16="http://schemas.microsoft.com/office/drawing/2014/main" id="{3E7B290C-1247-BA3B-0608-78EA77390001}"/>
               </a:ext>
             </a:extLst>
           </p:cNvPr>
@@ -3555,7 +3555,7 @@
           <p:cNvPr id="6" name="TextBox 5">
             <a:extLst>
               <a:ext uri="{FF2B5EF4-FFF2-40B4-BE49-F238E27FC236}">
-                <a16:creationId xmlns:a16="http://schemas.microsoft.com/office/drawing/2014/main" id="{EB62A8DD-E93D-84F7-8D5C-3700D54EBE2A}"/>
+                <a16:creationId xmlns:a16="http://schemas.microsoft.com/office/drawing/2014/main" id="{68804187-16C4-E569-60E8-7017B13C14DA}"/>
               </a:ext>
             </a:extLst>
           </p:cNvPr>
@@ -3593,7 +3593,7 @@
     </p:spTree>
     <p:extLst>
       <p:ext uri="{BB962C8B-B14F-4D97-AF65-F5344CB8AC3E}">
-        <p14:creationId xmlns:p14="http://schemas.microsoft.com/office/powerpoint/2010/main" val="2083469108"/>
+        <p14:creationId xmlns:p14="http://schemas.microsoft.com/office/powerpoint/2010/main" val="794217807"/>
       </p:ext>
     </p:extLst>
   </p:cSld>
@@ -3625,7 +3625,7 @@
           <p:cNvPr id="2" name="Rectangle: Rounded Corners 1">
             <a:extLst>
               <a:ext uri="{FF2B5EF4-FFF2-40B4-BE49-F238E27FC236}">
-                <a16:creationId xmlns:a16="http://schemas.microsoft.com/office/drawing/2014/main" id="{10C28E5F-35ED-3391-76E6-C77FC9ACD129}"/>
+                <a16:creationId xmlns:a16="http://schemas.microsoft.com/office/drawing/2014/main" id="{7CF10A6B-C399-1A0A-33FE-F6230F438BF4}"/>
               </a:ext>
             </a:extLst>
           </p:cNvPr>
@@ -3693,7 +3693,7 @@
           <p:cNvPr id="3" name="TextBox 2">
             <a:extLst>
               <a:ext uri="{FF2B5EF4-FFF2-40B4-BE49-F238E27FC236}">
-                <a16:creationId xmlns:a16="http://schemas.microsoft.com/office/drawing/2014/main" id="{9859E699-8941-120A-F7FF-BB32A7031269}"/>
+                <a16:creationId xmlns:a16="http://schemas.microsoft.com/office/drawing/2014/main" id="{3B5A2BD0-854D-F129-2893-9B40688E3601}"/>
               </a:ext>
             </a:extLst>
           </p:cNvPr>
@@ -3733,7 +3733,7 @@
           <p:cNvPr id="4" name="Table 3">
             <a:extLst>
               <a:ext uri="{FF2B5EF4-FFF2-40B4-BE49-F238E27FC236}">
-                <a16:creationId xmlns:a16="http://schemas.microsoft.com/office/drawing/2014/main" id="{57C06E20-E68C-228F-927F-BFD49C9A3F88}"/>
+                <a16:creationId xmlns:a16="http://schemas.microsoft.com/office/drawing/2014/main" id="{04DB33CD-2185-8717-F5EA-0556C9673B02}"/>
               </a:ext>
             </a:extLst>
           </p:cNvPr>
@@ -3743,14 +3743,14 @@
           <p:nvPr>
             <p:extLst>
               <p:ext uri="{D42A27DB-BD31-4B8C-83A1-F6EECF244321}">
-                <p14:modId xmlns:p14="http://schemas.microsoft.com/office/powerpoint/2010/main" val="3881329045"/>
+                <p14:modId xmlns:p14="http://schemas.microsoft.com/office/powerpoint/2010/main" val="4024190616"/>
               </p:ext>
             </p:extLst>
           </p:nvPr>
         </p:nvGraphicFramePr>
         <p:xfrm>
           <a:off x="762000" y="1270000"/>
-          <a:ext cx="8890000" cy="3810000"/>
+          <a:ext cx="9144000" cy="3810000"/>
         </p:xfrm>
         <a:graphic>
           <a:graphicData uri="http://schemas.openxmlformats.org/drawingml/2006/table">
@@ -3759,24 +3759,24 @@
                 <a:tableStyleId>{5C22544A-7EE6-4342-B048-85BDC9FD1C3A}</a:tableStyleId>
               </a:tblPr>
               <a:tblGrid>
-                <a:gridCol w="2540000">
+                <a:gridCol w="3175000">
                   <a:extLst>
                     <a:ext uri="{9D8B030D-6E8A-4147-A177-3AD203B41FA5}">
-                      <a16:colId xmlns:a16="http://schemas.microsoft.com/office/drawing/2014/main" val="3141329537"/>
+                      <a16:colId xmlns:a16="http://schemas.microsoft.com/office/drawing/2014/main" val="3965821461"/>
                     </a:ext>
                   </a:extLst>
                 </a:gridCol>
-                <a:gridCol w="1524000">
+                <a:gridCol w="1397000">
                   <a:extLst>
                     <a:ext uri="{9D8B030D-6E8A-4147-A177-3AD203B41FA5}">
-                      <a16:colId xmlns:a16="http://schemas.microsoft.com/office/drawing/2014/main" val="1054673639"/>
+                      <a16:colId xmlns:a16="http://schemas.microsoft.com/office/drawing/2014/main" val="1946583278"/>
                     </a:ext>
                   </a:extLst>
                 </a:gridCol>
-                <a:gridCol w="4826000">
+                <a:gridCol w="4572000">
                   <a:extLst>
                     <a:ext uri="{9D8B030D-6E8A-4147-A177-3AD203B41FA5}">
-                      <a16:colId xmlns:a16="http://schemas.microsoft.com/office/drawing/2014/main" val="1955658257"/>
+                      <a16:colId xmlns:a16="http://schemas.microsoft.com/office/drawing/2014/main" val="3739599022"/>
                     </a:ext>
                   </a:extLst>
                 </a:gridCol>
@@ -3794,7 +3794,7 @@
                           </a:solidFill>
                           <a:latin typeface="Calibri" panose="020F0502020204030204" pitchFamily="34" charset="0"/>
                         </a:rPr>
-                        <a:t>Run mode</a:t>
+                        <a:t>Pipeline run</a:t>
                       </a:r>
                     </a:p>
                   </a:txBody>
@@ -3850,7 +3850,7 @@
                 </a:tc>
                 <a:extLst>
                   <a:ext uri="{0D108BD9-81ED-4DB2-BD59-A6C34878D82A}">
-                    <a16:rowId xmlns:a16="http://schemas.microsoft.com/office/drawing/2014/main" val="1169936588"/>
+                    <a16:rowId xmlns:a16="http://schemas.microsoft.com/office/drawing/2014/main" val="3758721813"/>
                   </a:ext>
                 </a:extLst>
               </a:tr>
@@ -3867,7 +3867,7 @@
                           </a:solidFill>
                           <a:latin typeface="Calibri" panose="020F0502020204030204" pitchFamily="34" charset="0"/>
                         </a:rPr>
-                        <a:t>Full load</a:t>
+                        <a:t>Full (Run I, 12-30-2022)</a:t>
                       </a:r>
                     </a:p>
                   </a:txBody>
@@ -3889,7 +3889,7 @@
                           </a:solidFill>
                           <a:latin typeface="Calibri" panose="020F0502020204030204" pitchFamily="34" charset="0"/>
                         </a:rPr>
-                        <a:t>~71 s</a:t>
+                        <a:t>34.5 s</a:t>
                       </a:r>
                     </a:p>
                   </a:txBody>
@@ -3923,7 +3923,7 @@
                 </a:tc>
                 <a:extLst>
                   <a:ext uri="{0D108BD9-81ED-4DB2-BD59-A6C34878D82A}">
-                    <a16:rowId xmlns:a16="http://schemas.microsoft.com/office/drawing/2014/main" val="3363657655"/>
+                    <a16:rowId xmlns:a16="http://schemas.microsoft.com/office/drawing/2014/main" val="1331317958"/>
                   </a:ext>
                 </a:extLst>
               </a:tr>
@@ -3940,7 +3940,7 @@
                           </a:solidFill>
                           <a:latin typeface="Calibri" panose="020F0502020204030204" pitchFamily="34" charset="0"/>
                         </a:rPr>
-                        <a:t>Incremental</a:t>
+                        <a:t>Incremental (Run II, 12-30-2026)</a:t>
                       </a:r>
                     </a:p>
                   </a:txBody>
@@ -3958,7 +3958,7 @@
                           </a:solidFill>
                           <a:latin typeface="Calibri" panose="020F0502020204030204" pitchFamily="34" charset="0"/>
                         </a:rPr>
-                        <a:t>~6 s</a:t>
+                        <a:t>5.9 s</a:t>
                       </a:r>
                     </a:p>
                   </a:txBody>
@@ -3984,7 +3984,7 @@
                 </a:tc>
                 <a:extLst>
                   <a:ext uri="{0D108BD9-81ED-4DB2-BD59-A6C34878D82A}">
-                    <a16:rowId xmlns:a16="http://schemas.microsoft.com/office/drawing/2014/main" val="4088920657"/>
+                    <a16:rowId xmlns:a16="http://schemas.microsoft.com/office/drawing/2014/main" val="2619401848"/>
                   </a:ext>
                 </a:extLst>
               </a:tr>
@@ -3992,12 +3992,345 @@
           </a:graphicData>
         </a:graphic>
       </p:graphicFrame>
-      <p:sp>
-        <p:nvSpPr>
-          <p:cNvPr id="5" name="TextBox 4">
-            <a:extLst>
-              <a:ext uri="{FF2B5EF4-FFF2-40B4-BE49-F238E27FC236}">
-                <a16:creationId xmlns:a16="http://schemas.microsoft.com/office/drawing/2014/main" id="{9E17D5A6-61A2-2699-BFE0-B897C825A31B}"/>
+      <p:graphicFrame>
+        <p:nvGraphicFramePr>
+          <p:cNvPr id="5" name="Table 4">
+            <a:extLst>
+              <a:ext uri="{FF2B5EF4-FFF2-40B4-BE49-F238E27FC236}">
+                <a16:creationId xmlns:a16="http://schemas.microsoft.com/office/drawing/2014/main" id="{37611CAF-B76B-268C-47AE-B807A95D948F}"/>
+              </a:ext>
+            </a:extLst>
+          </p:cNvPr>
+          <p:cNvGraphicFramePr>
+            <a:graphicFrameLocks noGrp="1"/>
+          </p:cNvGraphicFramePr>
+          <p:nvPr>
+            <p:extLst>
+              <p:ext uri="{D42A27DB-BD31-4B8C-83A1-F6EECF244321}">
+                <p14:modId xmlns:p14="http://schemas.microsoft.com/office/powerpoint/2010/main" val="1860236983"/>
+              </p:ext>
+            </p:extLst>
+          </p:nvPr>
+        </p:nvGraphicFramePr>
+        <p:xfrm>
+          <a:off x="762000" y="3048000"/>
+          <a:ext cx="9652000" cy="3810000"/>
+        </p:xfrm>
+        <a:graphic>
+          <a:graphicData uri="http://schemas.openxmlformats.org/drawingml/2006/table">
+            <a:tbl>
+              <a:tblPr firstRow="1" bandRow="1">
+                <a:tableStyleId>{5C22544A-7EE6-4342-B048-85BDC9FD1C3A}</a:tableStyleId>
+              </a:tblPr>
+              <a:tblGrid>
+                <a:gridCol w="3810000">
+                  <a:extLst>
+                    <a:ext uri="{9D8B030D-6E8A-4147-A177-3AD203B41FA5}">
+                      <a16:colId xmlns:a16="http://schemas.microsoft.com/office/drawing/2014/main" val="520877583"/>
+                    </a:ext>
+                  </a:extLst>
+                </a:gridCol>
+                <a:gridCol w="1016000">
+                  <a:extLst>
+                    <a:ext uri="{9D8B030D-6E8A-4147-A177-3AD203B41FA5}">
+                      <a16:colId xmlns:a16="http://schemas.microsoft.com/office/drawing/2014/main" val="663796882"/>
+                    </a:ext>
+                  </a:extLst>
+                </a:gridCol>
+                <a:gridCol w="1651000">
+                  <a:extLst>
+                    <a:ext uri="{9D8B030D-6E8A-4147-A177-3AD203B41FA5}">
+                      <a16:colId xmlns:a16="http://schemas.microsoft.com/office/drawing/2014/main" val="3495438601"/>
+                    </a:ext>
+                  </a:extLst>
+                </a:gridCol>
+                <a:gridCol w="3175000">
+                  <a:extLst>
+                    <a:ext uri="{9D8B030D-6E8A-4147-A177-3AD203B41FA5}">
+                      <a16:colId xmlns:a16="http://schemas.microsoft.com/office/drawing/2014/main" val="2945153232"/>
+                    </a:ext>
+                  </a:extLst>
+                </a:gridCol>
+              </a:tblGrid>
+              <a:tr h="431800">
+                <a:tc>
+                  <a:txBody>
+                    <a:bodyPr/>
+                    <a:lstStyle/>
+                    <a:p>
+                      <a:r>
+                        <a:rPr lang="en-US" sz="1500" b="1">
+                          <a:solidFill>
+                            <a:srgbClr val="FFFFFF"/>
+                          </a:solidFill>
+                          <a:latin typeface="Calibri" panose="020F0502020204030204" pitchFamily="34" charset="0"/>
+                        </a:rPr>
+                        <a:t>Company query (SET STATISTICS TIME ON)</a:t>
+                      </a:r>
+                    </a:p>
+                  </a:txBody>
+                  <a:tcPr>
+                    <a:solidFill>
+                      <a:srgbClr val="1F3864"/>
+                    </a:solidFill>
+                  </a:tcPr>
+                </a:tc>
+                <a:tc>
+                  <a:txBody>
+                    <a:bodyPr/>
+                    <a:lstStyle/>
+                    <a:p>
+                      <a:r>
+                        <a:rPr lang="en-US" sz="1500" b="1">
+                          <a:solidFill>
+                            <a:srgbClr val="FFFFFF"/>
+                          </a:solidFill>
+                          <a:latin typeface="Calibri" panose="020F0502020204030204" pitchFamily="34" charset="0"/>
+                        </a:rPr>
+                        <a:t>Rows</a:t>
+                      </a:r>
+                    </a:p>
+                  </a:txBody>
+                  <a:tcPr>
+                    <a:solidFill>
+                      <a:srgbClr val="1F3864"/>
+                    </a:solidFill>
+                  </a:tcPr>
+                </a:tc>
+                <a:tc>
+                  <a:txBody>
+                    <a:bodyPr/>
+                    <a:lstStyle/>
+                    <a:p>
+                      <a:r>
+                        <a:rPr lang="en-US" sz="1500" b="1">
+                          <a:solidFill>
+                            <a:srgbClr val="FFFFFF"/>
+                          </a:solidFill>
+                          <a:latin typeface="Calibri" panose="020F0502020204030204" pitchFamily="34" charset="0"/>
+                        </a:rPr>
+                        <a:t>CPU ms</a:t>
+                      </a:r>
+                    </a:p>
+                  </a:txBody>
+                  <a:tcPr>
+                    <a:solidFill>
+                      <a:srgbClr val="1F3864"/>
+                    </a:solidFill>
+                  </a:tcPr>
+                </a:tc>
+                <a:tc>
+                  <a:txBody>
+                    <a:bodyPr/>
+                    <a:lstStyle/>
+                    <a:p>
+                      <a:r>
+                        <a:rPr lang="en-US" sz="1500" b="1">
+                          <a:solidFill>
+                            <a:srgbClr val="FFFFFF"/>
+                          </a:solidFill>
+                          <a:latin typeface="Calibri" panose="020F0502020204030204" pitchFamily="34" charset="0"/>
+                        </a:rPr>
+                        <a:t>Elapsed ms</a:t>
+                      </a:r>
+                    </a:p>
+                  </a:txBody>
+                  <a:tcPr>
+                    <a:solidFill>
+                      <a:srgbClr val="1F3864"/>
+                    </a:solidFill>
+                  </a:tcPr>
+                </a:tc>
+                <a:extLst>
+                  <a:ext uri="{0D108BD9-81ED-4DB2-BD59-A6C34878D82A}">
+                    <a16:rowId xmlns:a16="http://schemas.microsoft.com/office/drawing/2014/main" val="2598791922"/>
+                  </a:ext>
+                </a:extLst>
+              </a:tr>
+              <a:tr h="381000">
+                <a:tc>
+                  <a:txBody>
+                    <a:bodyPr/>
+                    <a:lstStyle/>
+                    <a:p>
+                      <a:r>
+                        <a:rPr lang="en-US" sz="1400">
+                          <a:solidFill>
+                            <a:srgbClr val="1F3864"/>
+                          </a:solidFill>
+                          <a:latin typeface="Calibri" panose="020F0502020204030204" pitchFamily="34" charset="0"/>
+                        </a:rPr>
+                        <a:t>OLTP Query (source system)</a:t>
+                      </a:r>
+                    </a:p>
+                  </a:txBody>
+                  <a:tcPr>
+                    <a:solidFill>
+                      <a:srgbClr val="F2F2F2"/>
+                    </a:solidFill>
+                  </a:tcPr>
+                </a:tc>
+                <a:tc>
+                  <a:txBody>
+                    <a:bodyPr/>
+                    <a:lstStyle/>
+                    <a:p>
+                      <a:r>
+                        <a:rPr lang="en-US" sz="1400">
+                          <a:solidFill>
+                            <a:srgbClr val="1F3864"/>
+                          </a:solidFill>
+                          <a:latin typeface="Calibri" panose="020F0502020204030204" pitchFamily="34" charset="0"/>
+                        </a:rPr>
+                        <a:t>432</a:t>
+                      </a:r>
+                    </a:p>
+                  </a:txBody>
+                  <a:tcPr>
+                    <a:solidFill>
+                      <a:srgbClr val="F2F2F2"/>
+                    </a:solidFill>
+                  </a:tcPr>
+                </a:tc>
+                <a:tc>
+                  <a:txBody>
+                    <a:bodyPr/>
+                    <a:lstStyle/>
+                    <a:p>
+                      <a:r>
+                        <a:rPr lang="en-US" sz="1400">
+                          <a:solidFill>
+                            <a:srgbClr val="1F3864"/>
+                          </a:solidFill>
+                          <a:latin typeface="Calibri" panose="020F0502020204030204" pitchFamily="34" charset="0"/>
+                        </a:rPr>
+                        <a:t>4,445</a:t>
+                      </a:r>
+                    </a:p>
+                  </a:txBody>
+                  <a:tcPr>
+                    <a:solidFill>
+                      <a:srgbClr val="F2F2F2"/>
+                    </a:solidFill>
+                  </a:tcPr>
+                </a:tc>
+                <a:tc>
+                  <a:txBody>
+                    <a:bodyPr/>
+                    <a:lstStyle/>
+                    <a:p>
+                      <a:r>
+                        <a:rPr lang="en-US" sz="1400">
+                          <a:solidFill>
+                            <a:srgbClr val="1F3864"/>
+                          </a:solidFill>
+                          <a:latin typeface="Calibri" panose="020F0502020204030204" pitchFamily="34" charset="0"/>
+                        </a:rPr>
+                        <a:t>1,898</a:t>
+                      </a:r>
+                    </a:p>
+                  </a:txBody>
+                  <a:tcPr>
+                    <a:solidFill>
+                      <a:srgbClr val="F2F2F2"/>
+                    </a:solidFill>
+                  </a:tcPr>
+                </a:tc>
+                <a:extLst>
+                  <a:ext uri="{0D108BD9-81ED-4DB2-BD59-A6C34878D82A}">
+                    <a16:rowId xmlns:a16="http://schemas.microsoft.com/office/drawing/2014/main" val="894611947"/>
+                  </a:ext>
+                </a:extLst>
+              </a:tr>
+              <a:tr h="381000">
+                <a:tc>
+                  <a:txBody>
+                    <a:bodyPr/>
+                    <a:lstStyle/>
+                    <a:p>
+                      <a:r>
+                        <a:rPr lang="en-US" sz="1400">
+                          <a:solidFill>
+                            <a:srgbClr val="1F3864"/>
+                          </a:solidFill>
+                          <a:latin typeface="Calibri" panose="020F0502020204030204" pitchFamily="34" charset="0"/>
+                        </a:rPr>
+                        <a:t>OLAP Query (DW, warm)</a:t>
+                      </a:r>
+                    </a:p>
+                  </a:txBody>
+                  <a:tcPr/>
+                </a:tc>
+                <a:tc>
+                  <a:txBody>
+                    <a:bodyPr/>
+                    <a:lstStyle/>
+                    <a:p>
+                      <a:r>
+                        <a:rPr lang="en-US" sz="1400">
+                          <a:solidFill>
+                            <a:srgbClr val="1F3864"/>
+                          </a:solidFill>
+                          <a:latin typeface="Calibri" panose="020F0502020204030204" pitchFamily="34" charset="0"/>
+                        </a:rPr>
+                        <a:t>432</a:t>
+                      </a:r>
+                    </a:p>
+                  </a:txBody>
+                  <a:tcPr/>
+                </a:tc>
+                <a:tc>
+                  <a:txBody>
+                    <a:bodyPr/>
+                    <a:lstStyle/>
+                    <a:p>
+                      <a:r>
+                        <a:rPr lang="en-US" sz="1400">
+                          <a:solidFill>
+                            <a:srgbClr val="1F3864"/>
+                          </a:solidFill>
+                          <a:latin typeface="Calibri" panose="020F0502020204030204" pitchFamily="34" charset="0"/>
+                        </a:rPr>
+                        <a:t>1,109-1,781</a:t>
+                      </a:r>
+                    </a:p>
+                  </a:txBody>
+                  <a:tcPr/>
+                </a:tc>
+                <a:tc>
+                  <a:txBody>
+                    <a:bodyPr/>
+                    <a:lstStyle/>
+                    <a:p>
+                      <a:r>
+                        <a:rPr lang="en-US" sz="1400">
+                          <a:solidFill>
+                            <a:srgbClr val="1F3864"/>
+                          </a:solidFill>
+                          <a:latin typeface="Calibri" panose="020F0502020204030204" pitchFamily="34" charset="0"/>
+                        </a:rPr>
+                        <a:t>1,359-7,958</a:t>
+                      </a:r>
+                    </a:p>
+                  </a:txBody>
+                  <a:tcPr/>
+                </a:tc>
+                <a:extLst>
+                  <a:ext uri="{0D108BD9-81ED-4DB2-BD59-A6C34878D82A}">
+                    <a16:rowId xmlns:a16="http://schemas.microsoft.com/office/drawing/2014/main" val="2521531638"/>
+                  </a:ext>
+                </a:extLst>
+              </a:tr>
+            </a:tbl>
+          </a:graphicData>
+        </a:graphic>
+      </p:graphicFrame>
+      <p:sp>
+        <p:nvSpPr>
+          <p:cNvPr id="6" name="TextBox 5">
+            <a:extLst>
+              <a:ext uri="{FF2B5EF4-FFF2-40B4-BE49-F238E27FC236}">
+                <a16:creationId xmlns:a16="http://schemas.microsoft.com/office/drawing/2014/main" id="{DF5B357D-816D-A514-50DC-33C333671D2B}"/>
               </a:ext>
             </a:extLst>
           </p:cNvPr>
@@ -4006,7 +4339,7 @@
         </p:nvSpPr>
         <p:spPr>
           <a:xfrm>
-            <a:off x="762000" y="3556000"/>
+            <a:off x="762000" y="5334000"/>
             <a:ext cx="10668000" cy="1077218"/>
           </a:xfrm>
           <a:prstGeom prst="rect">
@@ -4027,7 +4360,7 @@
                 </a:solidFill>
                 <a:latin typeface="Calibri" panose="020F0502020204030204" pitchFamily="34" charset="0"/>
               </a:rPr>
-              <a:t>Bulk FastLoad into staging and destination tables</a:t>
+              <a:t>OLAP returns identical 432 category rows; CPU up to ~4x lower than querying OLTP directly</a:t>
             </a:r>
             <a:br>
               <a:rPr lang="en-US" sz="1600">
@@ -4044,7 +4377,7 @@
                 </a:solidFill>
                 <a:latin typeface="Calibri" panose="020F0502020204030204" pitchFamily="34" charset="0"/>
               </a:rPr>
-              <a:t>Full-cache lookups (295 products, 407 customers, date caches) - validated once</a:t>
+              <a:t>Bulk FastLoad into staging and destination tables</a:t>
             </a:r>
             <a:br>
               <a:rPr lang="en-US" sz="1600">
@@ -4061,7 +4394,7 @@
                 </a:solidFill>
                 <a:latin typeface="Calibri" panose="020F0502020204030204" pitchFamily="34" charset="0"/>
               </a:rPr>
-              <a:t>Validation overhead dominates short runs; data flow itself is a few seconds</a:t>
+              <a:t>Full-cache lookups (295 products, 407 customers, date caches) - validated once</a:t>
             </a:r>
             <a:br>
               <a:rPr lang="en-US" sz="1600">
@@ -4086,7 +4419,7 @@
     </p:spTree>
     <p:extLst>
       <p:ext uri="{BB962C8B-B14F-4D97-AF65-F5344CB8AC3E}">
-        <p14:creationId xmlns:p14="http://schemas.microsoft.com/office/powerpoint/2010/main" val="3382921689"/>
+        <p14:creationId xmlns:p14="http://schemas.microsoft.com/office/powerpoint/2010/main" val="1908238006"/>
       </p:ext>
     </p:extLst>
   </p:cSld>
@@ -4118,7 +4451,7 @@
           <p:cNvPr id="2" name="Rectangle: Rounded Corners 1">
             <a:extLst>
               <a:ext uri="{FF2B5EF4-FFF2-40B4-BE49-F238E27FC236}">
-                <a16:creationId xmlns:a16="http://schemas.microsoft.com/office/drawing/2014/main" id="{71859B2A-3BF8-4B4C-1CDE-85A3AB5789BA}"/>
+                <a16:creationId xmlns:a16="http://schemas.microsoft.com/office/drawing/2014/main" id="{B1F3D830-8910-6C70-F55C-7D15108A6854}"/>
               </a:ext>
             </a:extLst>
           </p:cNvPr>
@@ -4186,7 +4519,7 @@
           <p:cNvPr id="3" name="TextBox 2">
             <a:extLst>
               <a:ext uri="{FF2B5EF4-FFF2-40B4-BE49-F238E27FC236}">
-                <a16:creationId xmlns:a16="http://schemas.microsoft.com/office/drawing/2014/main" id="{08E4C144-4D39-24CD-FD67-3B22DCB65C7F}"/>
+                <a16:creationId xmlns:a16="http://schemas.microsoft.com/office/drawing/2014/main" id="{329F7737-89E9-16CF-5C20-1B6625B54324}"/>
               </a:ext>
             </a:extLst>
           </p:cNvPr>
@@ -4226,7 +4559,7 @@
           <p:cNvPr id="4" name="TextBox 3">
             <a:extLst>
               <a:ext uri="{FF2B5EF4-FFF2-40B4-BE49-F238E27FC236}">
-                <a16:creationId xmlns:a16="http://schemas.microsoft.com/office/drawing/2014/main" id="{307489DF-0A97-CA16-722B-71654568DF38}"/>
+                <a16:creationId xmlns:a16="http://schemas.microsoft.com/office/drawing/2014/main" id="{D3F9ECA2-4DD9-0D36-D1FD-6BD350445DEE}"/>
               </a:ext>
             </a:extLst>
           </p:cNvPr>
@@ -4418,7 +4751,7 @@
     </p:spTree>
     <p:extLst>
       <p:ext uri="{BB962C8B-B14F-4D97-AF65-F5344CB8AC3E}">
-        <p14:creationId xmlns:p14="http://schemas.microsoft.com/office/powerpoint/2010/main" val="1452989017"/>
+        <p14:creationId xmlns:p14="http://schemas.microsoft.com/office/powerpoint/2010/main" val="735716658"/>
       </p:ext>
     </p:extLst>
   </p:cSld>
@@ -4450,7 +4783,7 @@
           <p:cNvPr id="2" name="Rectangle: Rounded Corners 1">
             <a:extLst>
               <a:ext uri="{FF2B5EF4-FFF2-40B4-BE49-F238E27FC236}">
-                <a16:creationId xmlns:a16="http://schemas.microsoft.com/office/drawing/2014/main" id="{A5B9D0A8-1297-8A0A-9608-A651A954418E}"/>
+                <a16:creationId xmlns:a16="http://schemas.microsoft.com/office/drawing/2014/main" id="{7CEF2089-BAA8-58A0-F10A-1963F0C1F325}"/>
               </a:ext>
             </a:extLst>
           </p:cNvPr>
@@ -4518,7 +4851,7 @@
           <p:cNvPr id="3" name="TextBox 2">
             <a:extLst>
               <a:ext uri="{FF2B5EF4-FFF2-40B4-BE49-F238E27FC236}">
-                <a16:creationId xmlns:a16="http://schemas.microsoft.com/office/drawing/2014/main" id="{3BD356EC-F7D3-DB68-DC47-3AFE4CA9E85C}"/>
+                <a16:creationId xmlns:a16="http://schemas.microsoft.com/office/drawing/2014/main" id="{28956E26-004D-C5D4-AB6F-149AF613D0D7}"/>
               </a:ext>
             </a:extLst>
           </p:cNvPr>
@@ -4558,7 +4891,7 @@
           <p:cNvPr id="4" name="Table 3">
             <a:extLst>
               <a:ext uri="{FF2B5EF4-FFF2-40B4-BE49-F238E27FC236}">
-                <a16:creationId xmlns:a16="http://schemas.microsoft.com/office/drawing/2014/main" id="{D2DBAA84-7B3A-9C5E-0967-2564B2E00172}"/>
+                <a16:creationId xmlns:a16="http://schemas.microsoft.com/office/drawing/2014/main" id="{B4DCAB6F-F54A-7C7E-96FF-34BE2F460A83}"/>
               </a:ext>
             </a:extLst>
           </p:cNvPr>
@@ -4568,14 +4901,14 @@
           <p:nvPr>
             <p:extLst>
               <p:ext uri="{D42A27DB-BD31-4B8C-83A1-F6EECF244321}">
-                <p14:modId xmlns:p14="http://schemas.microsoft.com/office/powerpoint/2010/main" val="2937324127"/>
+                <p14:modId xmlns:p14="http://schemas.microsoft.com/office/powerpoint/2010/main" val="2547049887"/>
               </p:ext>
             </p:extLst>
           </p:nvPr>
         </p:nvGraphicFramePr>
         <p:xfrm>
           <a:off x="762000" y="1270000"/>
-          <a:ext cx="10160000" cy="3810000"/>
+          <a:ext cx="10668000" cy="3810000"/>
         </p:xfrm>
         <a:graphic>
           <a:graphicData uri="http://schemas.openxmlformats.org/drawingml/2006/table">
@@ -4584,24 +4917,24 @@
                 <a:tableStyleId>{5C22544A-7EE6-4342-B048-85BDC9FD1C3A}</a:tableStyleId>
               </a:tblPr>
               <a:tblGrid>
+                <a:gridCol w="3429000">
+                  <a:extLst>
+                    <a:ext uri="{9D8B030D-6E8A-4147-A177-3AD203B41FA5}">
+                      <a16:colId xmlns:a16="http://schemas.microsoft.com/office/drawing/2014/main" val="4149676103"/>
+                    </a:ext>
+                  </a:extLst>
+                </a:gridCol>
+                <a:gridCol w="4191000">
+                  <a:extLst>
+                    <a:ext uri="{9D8B030D-6E8A-4147-A177-3AD203B41FA5}">
+                      <a16:colId xmlns:a16="http://schemas.microsoft.com/office/drawing/2014/main" val="2694156483"/>
+                    </a:ext>
+                  </a:extLst>
+                </a:gridCol>
                 <a:gridCol w="3048000">
                   <a:extLst>
                     <a:ext uri="{9D8B030D-6E8A-4147-A177-3AD203B41FA5}">
-                      <a16:colId xmlns:a16="http://schemas.microsoft.com/office/drawing/2014/main" val="978065495"/>
-                    </a:ext>
-                  </a:extLst>
-                </a:gridCol>
-                <a:gridCol w="4572000">
-                  <a:extLst>
-                    <a:ext uri="{9D8B030D-6E8A-4147-A177-3AD203B41FA5}">
-                      <a16:colId xmlns:a16="http://schemas.microsoft.com/office/drawing/2014/main" val="871181512"/>
-                    </a:ext>
-                  </a:extLst>
-                </a:gridCol>
-                <a:gridCol w="2540000">
-                  <a:extLst>
-                    <a:ext uri="{9D8B030D-6E8A-4147-A177-3AD203B41FA5}">
-                      <a16:colId xmlns:a16="http://schemas.microsoft.com/office/drawing/2014/main" val="495527994"/>
+                      <a16:colId xmlns:a16="http://schemas.microsoft.com/office/drawing/2014/main" val="1006667311"/>
                     </a:ext>
                   </a:extLst>
                 </a:gridCol>
@@ -4675,7 +5008,7 @@
                 </a:tc>
                 <a:extLst>
                   <a:ext uri="{0D108BD9-81ED-4DB2-BD59-A6C34878D82A}">
-                    <a16:rowId xmlns:a16="http://schemas.microsoft.com/office/drawing/2014/main" val="200474591"/>
+                    <a16:rowId xmlns:a16="http://schemas.microsoft.com/office/drawing/2014/main" val="3282840385"/>
                   </a:ext>
                 </a:extLst>
               </a:tr>
@@ -4748,7 +5081,7 @@
                 </a:tc>
                 <a:extLst>
                   <a:ext uri="{0D108BD9-81ED-4DB2-BD59-A6C34878D82A}">
-                    <a16:rowId xmlns:a16="http://schemas.microsoft.com/office/drawing/2014/main" val="955600645"/>
+                    <a16:rowId xmlns:a16="http://schemas.microsoft.com/office/drawing/2014/main" val="613839832"/>
                   </a:ext>
                 </a:extLst>
               </a:tr>
@@ -4809,7 +5142,7 @@
                 </a:tc>
                 <a:extLst>
                   <a:ext uri="{0D108BD9-81ED-4DB2-BD59-A6C34878D82A}">
-                    <a16:rowId xmlns:a16="http://schemas.microsoft.com/office/drawing/2014/main" val="4263117013"/>
+                    <a16:rowId xmlns:a16="http://schemas.microsoft.com/office/drawing/2014/main" val="1162216563"/>
                   </a:ext>
                 </a:extLst>
               </a:tr>
@@ -4826,7 +5159,7 @@
                           </a:solidFill>
                           <a:latin typeface="Calibri" panose="020F0502020204030204" pitchFamily="34" charset="0"/>
                         </a:rPr>
-                        <a:t>SSIS package DailyETL.dtsx</a:t>
+                        <a:t>SSIS package Load DW Pipeline.dtsx</a:t>
                       </a:r>
                     </a:p>
                   </a:txBody>
@@ -4848,7 +5181,7 @@
                           </a:solidFill>
                           <a:latin typeface="Calibri" panose="020F0502020204030204" pitchFamily="34" charset="0"/>
                         </a:rPr>
-                        <a:t>AdventureWorks_OLAP\DailyETL.dtsx</a:t>
+                        <a:t>AdventureWorks_OLAP\Load DW Pipeline.dtsx</a:t>
                       </a:r>
                     </a:p>
                   </a:txBody>
@@ -4882,7 +5215,7 @@
                 </a:tc>
                 <a:extLst>
                   <a:ext uri="{0D108BD9-81ED-4DB2-BD59-A6C34878D82A}">
-                    <a16:rowId xmlns:a16="http://schemas.microsoft.com/office/drawing/2014/main" val="1622682795"/>
+                    <a16:rowId xmlns:a16="http://schemas.microsoft.com/office/drawing/2014/main" val="2893679976"/>
                   </a:ext>
                 </a:extLst>
               </a:tr>
@@ -4943,7 +5276,7 @@
                 </a:tc>
                 <a:extLst>
                   <a:ext uri="{0D108BD9-81ED-4DB2-BD59-A6C34878D82A}">
-                    <a16:rowId xmlns:a16="http://schemas.microsoft.com/office/drawing/2014/main" val="3713476297"/>
+                    <a16:rowId xmlns:a16="http://schemas.microsoft.com/office/drawing/2014/main" val="870384511"/>
                   </a:ext>
                 </a:extLst>
               </a:tr>
@@ -4960,7 +5293,7 @@
                           </a:solidFill>
                           <a:latin typeface="Calibri" panose="020F0502020204030204" pitchFamily="34" charset="0"/>
                         </a:rPr>
-                        <a:t>Query + reset scripts (01-08)</a:t>
+                        <a:t>DW full backup</a:t>
                       </a:r>
                     </a:p>
                   </a:txBody>
@@ -4982,7 +5315,7 @@
                           </a:solidFill>
                           <a:latin typeface="Calibri" panose="020F0502020204030204" pitchFamily="34" charset="0"/>
                         </a:rPr>
-                        <a:t>SQL\</a:t>
+                        <a:t>Docs\AdventureWorks-DW.bak</a:t>
                       </a:r>
                     </a:p>
                   </a:txBody>
@@ -5016,7 +5349,68 @@
                 </a:tc>
                 <a:extLst>
                   <a:ext uri="{0D108BD9-81ED-4DB2-BD59-A6C34878D82A}">
-                    <a16:rowId xmlns:a16="http://schemas.microsoft.com/office/drawing/2014/main" val="1490845225"/>
+                    <a16:rowId xmlns:a16="http://schemas.microsoft.com/office/drawing/2014/main" val="2727930287"/>
+                  </a:ext>
+                </a:extLst>
+              </a:tr>
+              <a:tr h="381000">
+                <a:tc>
+                  <a:txBody>
+                    <a:bodyPr/>
+                    <a:lstStyle/>
+                    <a:p>
+                      <a:r>
+                        <a:rPr lang="en-US" sz="1400">
+                          <a:solidFill>
+                            <a:srgbClr val="1F3864"/>
+                          </a:solidFill>
+                          <a:latin typeface="Calibri" panose="020F0502020204030204" pitchFamily="34" charset="0"/>
+                        </a:rPr>
+                        <a:t>Submission zip</a:t>
+                      </a:r>
+                    </a:p>
+                  </a:txBody>
+                  <a:tcPr/>
+                </a:tc>
+                <a:tc>
+                  <a:txBody>
+                    <a:bodyPr/>
+                    <a:lstStyle/>
+                    <a:p>
+                      <a:r>
+                        <a:rPr lang="en-US" sz="1400">
+                          <a:solidFill>
+                            <a:srgbClr val="1F3864"/>
+                          </a:solidFill>
+                          <a:latin typeface="Calibri" panose="020F0502020204030204" pitchFamily="34" charset="0"/>
+                        </a:rPr>
+                        <a:t>Sayed_Gamea_ejada.zip</a:t>
+                      </a:r>
+                    </a:p>
+                  </a:txBody>
+                  <a:tcPr/>
+                </a:tc>
+                <a:tc>
+                  <a:txBody>
+                    <a:bodyPr/>
+                    <a:lstStyle/>
+                    <a:p>
+                      <a:r>
+                        <a:rPr lang="en-US" sz="1400">
+                          <a:solidFill>
+                            <a:srgbClr val="1F3864"/>
+                          </a:solidFill>
+                          <a:latin typeface="Calibri" panose="020F0502020204030204" pitchFamily="34" charset="0"/>
+                        </a:rPr>
+                        <a:t>Assembled</a:t>
+                      </a:r>
+                    </a:p>
+                  </a:txBody>
+                  <a:tcPr/>
+                </a:tc>
+                <a:extLst>
+                  <a:ext uri="{0D108BD9-81ED-4DB2-BD59-A6C34878D82A}">
+                    <a16:rowId xmlns:a16="http://schemas.microsoft.com/office/drawing/2014/main" val="1779139540"/>
                   </a:ext>
                 </a:extLst>
               </a:tr>
@@ -5029,7 +5423,7 @@
           <p:cNvPr id="5" name="TextBox 4">
             <a:extLst>
               <a:ext uri="{FF2B5EF4-FFF2-40B4-BE49-F238E27FC236}">
-                <a16:creationId xmlns:a16="http://schemas.microsoft.com/office/drawing/2014/main" id="{FD2BD34D-A8DD-88BA-E41E-D863FACA6CB5}"/>
+                <a16:creationId xmlns:a16="http://schemas.microsoft.com/office/drawing/2014/main" id="{E14799D7-1A80-8EF6-8F5E-29170B9A7022}"/>
               </a:ext>
             </a:extLst>
           </p:cNvPr>
@@ -5038,7 +5432,7 @@
         </p:nvSpPr>
         <p:spPr>
           <a:xfrm>
-            <a:off x="762000" y="4826000"/>
+            <a:off x="762000" y="5080000"/>
             <a:ext cx="10668000" cy="584775"/>
           </a:xfrm>
           <a:prstGeom prst="rect">
@@ -5084,7 +5478,7 @@
     </p:spTree>
     <p:extLst>
       <p:ext uri="{BB962C8B-B14F-4D97-AF65-F5344CB8AC3E}">
-        <p14:creationId xmlns:p14="http://schemas.microsoft.com/office/powerpoint/2010/main" val="3532464533"/>
+        <p14:creationId xmlns:p14="http://schemas.microsoft.com/office/powerpoint/2010/main" val="3430698359"/>
       </p:ext>
     </p:extLst>
   </p:cSld>
@@ -5116,7 +5510,7 @@
           <p:cNvPr id="2" name="Rectangle: Rounded Corners 1">
             <a:extLst>
               <a:ext uri="{FF2B5EF4-FFF2-40B4-BE49-F238E27FC236}">
-                <a16:creationId xmlns:a16="http://schemas.microsoft.com/office/drawing/2014/main" id="{F00C2E4A-DB60-5524-EC87-419610764B63}"/>
+                <a16:creationId xmlns:a16="http://schemas.microsoft.com/office/drawing/2014/main" id="{7C0143F5-8FC3-3390-F983-DA545F9FF82F}"/>
               </a:ext>
             </a:extLst>
           </p:cNvPr>
@@ -5184,7 +5578,7 @@
           <p:cNvPr id="3" name="TextBox 2">
             <a:extLst>
               <a:ext uri="{FF2B5EF4-FFF2-40B4-BE49-F238E27FC236}">
-                <a16:creationId xmlns:a16="http://schemas.microsoft.com/office/drawing/2014/main" id="{CCECBF1F-F4FF-636F-ED2F-D8989770A4BC}"/>
+                <a16:creationId xmlns:a16="http://schemas.microsoft.com/office/drawing/2014/main" id="{58C106FE-98CD-7591-615A-DC1B4628DD90}"/>
               </a:ext>
             </a:extLst>
           </p:cNvPr>
@@ -5224,7 +5618,7 @@
           <p:cNvPr id="4" name="TextBox 3">
             <a:extLst>
               <a:ext uri="{FF2B5EF4-FFF2-40B4-BE49-F238E27FC236}">
-                <a16:creationId xmlns:a16="http://schemas.microsoft.com/office/drawing/2014/main" id="{EB9989DC-3841-B438-C155-410B8437DDC9}"/>
+                <a16:creationId xmlns:a16="http://schemas.microsoft.com/office/drawing/2014/main" id="{BF2F4036-378A-B0A3-5B12-092A4CCA43ED}"/>
               </a:ext>
             </a:extLst>
           </p:cNvPr>
@@ -5254,7 +5648,7 @@
                 </a:solidFill>
                 <a:latin typeface="Calibri" panose="020F0502020204030204" pitchFamily="34" charset="0"/>
               </a:rPr>
-              <a:t>SCD Type 2 (history) on dimension attributes</a:t>
+              <a:t>SCD2 history on remaining dimensions (e.g., DimCustomer)</a:t>
             </a:r>
             <a:br>
               <a:rPr lang="en-US" sz="1600">
@@ -5330,7 +5724,7 @@
     </p:spTree>
     <p:extLst>
       <p:ext uri="{BB962C8B-B14F-4D97-AF65-F5344CB8AC3E}">
-        <p14:creationId xmlns:p14="http://schemas.microsoft.com/office/powerpoint/2010/main" val="2530405888"/>
+        <p14:creationId xmlns:p14="http://schemas.microsoft.com/office/powerpoint/2010/main" val="3836570960"/>
       </p:ext>
     </p:extLst>
   </p:cSld>
@@ -5362,7 +5756,7 @@
           <p:cNvPr id="2" name="Rectangle 1">
             <a:extLst>
               <a:ext uri="{FF2B5EF4-FFF2-40B4-BE49-F238E27FC236}">
-                <a16:creationId xmlns:a16="http://schemas.microsoft.com/office/drawing/2014/main" id="{1DA60F95-B49A-AD30-CE5A-134AFFD5ADEB}"/>
+                <a16:creationId xmlns:a16="http://schemas.microsoft.com/office/drawing/2014/main" id="{4188E527-2391-FC85-8553-66C5EB4B41D7}"/>
               </a:ext>
             </a:extLst>
           </p:cNvPr>
@@ -5430,7 +5824,7 @@
           <p:cNvPr id="3" name="Rectangle 2">
             <a:extLst>
               <a:ext uri="{FF2B5EF4-FFF2-40B4-BE49-F238E27FC236}">
-                <a16:creationId xmlns:a16="http://schemas.microsoft.com/office/drawing/2014/main" id="{621E0ABD-6579-9040-AB20-E75B7A4071AB}"/>
+                <a16:creationId xmlns:a16="http://schemas.microsoft.com/office/drawing/2014/main" id="{CCAC4888-466D-DBE2-325A-8BC59B3CA321}"/>
               </a:ext>
             </a:extLst>
           </p:cNvPr>
@@ -5498,7 +5892,7 @@
           <p:cNvPr id="4" name="TextBox 3">
             <a:extLst>
               <a:ext uri="{FF2B5EF4-FFF2-40B4-BE49-F238E27FC236}">
-                <a16:creationId xmlns:a16="http://schemas.microsoft.com/office/drawing/2014/main" id="{B67AF4F6-16A7-9033-579B-716588820600}"/>
+                <a16:creationId xmlns:a16="http://schemas.microsoft.com/office/drawing/2014/main" id="{23BF6DD5-2AFC-29A5-8AF5-C74D04A9C674}"/>
               </a:ext>
             </a:extLst>
           </p:cNvPr>
@@ -5538,7 +5932,7 @@
           <p:cNvPr id="5" name="TextBox 4">
             <a:extLst>
               <a:ext uri="{FF2B5EF4-FFF2-40B4-BE49-F238E27FC236}">
-                <a16:creationId xmlns:a16="http://schemas.microsoft.com/office/drawing/2014/main" id="{F673FEB4-B405-22A0-729E-24C663942B27}"/>
+                <a16:creationId xmlns:a16="http://schemas.microsoft.com/office/drawing/2014/main" id="{9F1E1844-E4C1-F7DC-2494-705882F21478}"/>
               </a:ext>
             </a:extLst>
           </p:cNvPr>
@@ -5576,7 +5970,7 @@
     </p:spTree>
     <p:extLst>
       <p:ext uri="{BB962C8B-B14F-4D97-AF65-F5344CB8AC3E}">
-        <p14:creationId xmlns:p14="http://schemas.microsoft.com/office/powerpoint/2010/main" val="515318372"/>
+        <p14:creationId xmlns:p14="http://schemas.microsoft.com/office/powerpoint/2010/main" val="2918234296"/>
       </p:ext>
     </p:extLst>
   </p:cSld>
@@ -5608,7 +6002,7 @@
           <p:cNvPr id="2" name="Rectangle: Rounded Corners 1">
             <a:extLst>
               <a:ext uri="{FF2B5EF4-FFF2-40B4-BE49-F238E27FC236}">
-                <a16:creationId xmlns:a16="http://schemas.microsoft.com/office/drawing/2014/main" id="{68359AA3-7FA8-3A33-BBE2-AF9547D1AAC5}"/>
+                <a16:creationId xmlns:a16="http://schemas.microsoft.com/office/drawing/2014/main" id="{CC6E3A22-21ED-C3D9-E36F-77EB2C09A840}"/>
               </a:ext>
             </a:extLst>
           </p:cNvPr>
@@ -5676,7 +6070,7 @@
           <p:cNvPr id="3" name="TextBox 2">
             <a:extLst>
               <a:ext uri="{FF2B5EF4-FFF2-40B4-BE49-F238E27FC236}">
-                <a16:creationId xmlns:a16="http://schemas.microsoft.com/office/drawing/2014/main" id="{F005BBA6-5F2C-AA61-1D33-CE3B49C61405}"/>
+                <a16:creationId xmlns:a16="http://schemas.microsoft.com/office/drawing/2014/main" id="{6882B0A7-AF0F-2608-DE9E-0B9E4520F7AF}"/>
               </a:ext>
             </a:extLst>
           </p:cNvPr>
@@ -5716,7 +6110,7 @@
           <p:cNvPr id="4" name="TextBox 3">
             <a:extLst>
               <a:ext uri="{FF2B5EF4-FFF2-40B4-BE49-F238E27FC236}">
-                <a16:creationId xmlns:a16="http://schemas.microsoft.com/office/drawing/2014/main" id="{4F37C578-545B-066B-A267-0D78B76E883E}"/>
+                <a16:creationId xmlns:a16="http://schemas.microsoft.com/office/drawing/2014/main" id="{F587A35C-42E1-E115-DF61-F7C32EC31960}"/>
               </a:ext>
             </a:extLst>
           </p:cNvPr>
@@ -5924,7 +6318,7 @@
     </p:spTree>
     <p:extLst>
       <p:ext uri="{BB962C8B-B14F-4D97-AF65-F5344CB8AC3E}">
-        <p14:creationId xmlns:p14="http://schemas.microsoft.com/office/powerpoint/2010/main" val="1933816129"/>
+        <p14:creationId xmlns:p14="http://schemas.microsoft.com/office/powerpoint/2010/main" val="2775478959"/>
       </p:ext>
     </p:extLst>
   </p:cSld>
@@ -5956,7 +6350,7 @@
           <p:cNvPr id="2" name="Rectangle: Rounded Corners 1">
             <a:extLst>
               <a:ext uri="{FF2B5EF4-FFF2-40B4-BE49-F238E27FC236}">
-                <a16:creationId xmlns:a16="http://schemas.microsoft.com/office/drawing/2014/main" id="{8310F133-6B6F-005F-A9E6-67EB82D987A0}"/>
+                <a16:creationId xmlns:a16="http://schemas.microsoft.com/office/drawing/2014/main" id="{770924FB-F7DD-CF8B-DBF7-09F64DBC500E}"/>
               </a:ext>
             </a:extLst>
           </p:cNvPr>
@@ -6024,7 +6418,7 @@
           <p:cNvPr id="3" name="TextBox 2">
             <a:extLst>
               <a:ext uri="{FF2B5EF4-FFF2-40B4-BE49-F238E27FC236}">
-                <a16:creationId xmlns:a16="http://schemas.microsoft.com/office/drawing/2014/main" id="{4CD6A541-8825-17C9-BB8E-52D0F9B7A34C}"/>
+                <a16:creationId xmlns:a16="http://schemas.microsoft.com/office/drawing/2014/main" id="{316B7FE5-4E4A-5334-9B29-C17F4AC18B5D}"/>
               </a:ext>
             </a:extLst>
           </p:cNvPr>
@@ -6064,7 +6458,7 @@
           <p:cNvPr id="4" name="TextBox 3">
             <a:extLst>
               <a:ext uri="{FF2B5EF4-FFF2-40B4-BE49-F238E27FC236}">
-                <a16:creationId xmlns:a16="http://schemas.microsoft.com/office/drawing/2014/main" id="{D3AB98EC-36B4-9160-62F0-2FD990079DB2}"/>
+                <a16:creationId xmlns:a16="http://schemas.microsoft.com/office/drawing/2014/main" id="{080D87FC-FF7A-953F-BDFB-C2E5EB8146C6}"/>
               </a:ext>
             </a:extLst>
           </p:cNvPr>
@@ -6110,7 +6504,7 @@
           <p:cNvPr id="5" name="TextBox 4">
             <a:extLst>
               <a:ext uri="{FF2B5EF4-FFF2-40B4-BE49-F238E27FC236}">
-                <a16:creationId xmlns:a16="http://schemas.microsoft.com/office/drawing/2014/main" id="{CC5CC997-D8BF-5732-1BE8-4C79234C0CC0}"/>
+                <a16:creationId xmlns:a16="http://schemas.microsoft.com/office/drawing/2014/main" id="{022A38B6-616B-499A-85D8-A8F2DDFAEAEA}"/>
               </a:ext>
             </a:extLst>
           </p:cNvPr>
@@ -6155,7 +6549,7 @@
           <p:cNvPr id="6" name="TextBox 5">
             <a:extLst>
               <a:ext uri="{FF2B5EF4-FFF2-40B4-BE49-F238E27FC236}">
-                <a16:creationId xmlns:a16="http://schemas.microsoft.com/office/drawing/2014/main" id="{A680E1FF-0DEC-7023-7E6C-111019B0D88E}"/>
+                <a16:creationId xmlns:a16="http://schemas.microsoft.com/office/drawing/2014/main" id="{EDBC899E-0C95-0492-BA6E-3A515B678D46}"/>
               </a:ext>
             </a:extLst>
           </p:cNvPr>
@@ -6200,7 +6594,7 @@
           <p:cNvPr id="7" name="Arrow: Right 6">
             <a:extLst>
               <a:ext uri="{FF2B5EF4-FFF2-40B4-BE49-F238E27FC236}">
-                <a16:creationId xmlns:a16="http://schemas.microsoft.com/office/drawing/2014/main" id="{137D6704-B3FC-258B-8F14-EF7F29A82E09}"/>
+                <a16:creationId xmlns:a16="http://schemas.microsoft.com/office/drawing/2014/main" id="{DEE2EFC8-2D97-EDAE-8F04-6118C0108AC5}"/>
               </a:ext>
             </a:extLst>
           </p:cNvPr>
@@ -6268,7 +6662,7 @@
           <p:cNvPr id="8" name="Arrow: Right 7">
             <a:extLst>
               <a:ext uri="{FF2B5EF4-FFF2-40B4-BE49-F238E27FC236}">
-                <a16:creationId xmlns:a16="http://schemas.microsoft.com/office/drawing/2014/main" id="{83C9713F-ACA7-8233-9796-16CF04D4E49A}"/>
+                <a16:creationId xmlns:a16="http://schemas.microsoft.com/office/drawing/2014/main" id="{20FC7913-DD93-C5AD-58F8-95A3AB487E4E}"/>
               </a:ext>
             </a:extLst>
           </p:cNvPr>
@@ -6336,7 +6730,7 @@
           <p:cNvPr id="9" name="TextBox 8">
             <a:extLst>
               <a:ext uri="{FF2B5EF4-FFF2-40B4-BE49-F238E27FC236}">
-                <a16:creationId xmlns:a16="http://schemas.microsoft.com/office/drawing/2014/main" id="{617D0133-EC0C-9F1A-DD48-C2A252430A5A}"/>
+                <a16:creationId xmlns:a16="http://schemas.microsoft.com/office/drawing/2014/main" id="{B9B0D5B2-9468-D057-074F-401D66082325}"/>
               </a:ext>
             </a:extLst>
           </p:cNvPr>
@@ -6369,7 +6763,7 @@
                 </a:solidFill>
                 <a:latin typeface="Calibri" panose="020F0502020204030204" pitchFamily="34" charset="0"/>
               </a:rPr>
-              <a:t>SSIS package: DailyETL.dtsx  (SSIS 2016 format, run on 2025 runtime)</a:t>
+              <a:t>SSIS package: Load DW Pipeline.dtsx  (SSIS 2016 format, run on 2025 runtime)</a:t>
             </a:r>
           </a:p>
         </p:txBody>
@@ -6379,7 +6773,7 @@
           <p:cNvPr id="10" name="TextBox 9">
             <a:extLst>
               <a:ext uri="{FF2B5EF4-FFF2-40B4-BE49-F238E27FC236}">
-                <a16:creationId xmlns:a16="http://schemas.microsoft.com/office/drawing/2014/main" id="{D79B91A2-FAFD-DB25-BE0E-F5576980D6BA}"/>
+                <a16:creationId xmlns:a16="http://schemas.microsoft.com/office/drawing/2014/main" id="{4E4A2270-A437-4AA4-044A-4D586292A177}"/>
               </a:ext>
             </a:extLst>
           </p:cNvPr>
@@ -6409,7 +6803,7 @@
                 </a:solidFill>
                 <a:latin typeface="Calibri" panose="020F0502020204030204" pitchFamily="34" charset="0"/>
               </a:rPr>
-              <a:t>ETL: extract from SalesLT -&gt; load staging -&gt; build dimensions (SCD1) -&gt; load facts</a:t>
+              <a:t>ETL: extract from SalesLT -&gt; load staging -&gt; build dimensions (customer SCD1, product SCD2) -&gt; load facts</a:t>
             </a:r>
             <a:br>
               <a:rPr lang="en-US" sz="1600">
@@ -6443,7 +6837,7 @@
                 </a:solidFill>
                 <a:latin typeface="Calibri" panose="020F0502020204030204" pitchFamily="34" charset="0"/>
               </a:rPr>
-              <a:t>InitialLoad package parameter switches full vs incremental behavior</a:t>
+              <a:t>InitialLoad + CurrentJobTime + Language package parameters control each run</a:t>
             </a:r>
             <a:br>
               <a:rPr lang="en-US" sz="1600">
@@ -6468,7 +6862,7 @@
     </p:spTree>
     <p:extLst>
       <p:ext uri="{BB962C8B-B14F-4D97-AF65-F5344CB8AC3E}">
-        <p14:creationId xmlns:p14="http://schemas.microsoft.com/office/powerpoint/2010/main" val="1571545505"/>
+        <p14:creationId xmlns:p14="http://schemas.microsoft.com/office/powerpoint/2010/main" val="2882329582"/>
       </p:ext>
     </p:extLst>
   </p:cSld>
@@ -6500,7 +6894,7 @@
           <p:cNvPr id="2" name="Rectangle: Rounded Corners 1">
             <a:extLst>
               <a:ext uri="{FF2B5EF4-FFF2-40B4-BE49-F238E27FC236}">
-                <a16:creationId xmlns:a16="http://schemas.microsoft.com/office/drawing/2014/main" id="{DAC1E893-0F8D-D385-4D7A-B11F66F64C9B}"/>
+                <a16:creationId xmlns:a16="http://schemas.microsoft.com/office/drawing/2014/main" id="{EF9EBF94-6CF8-0B5A-6CA7-E067A0D7E8E4}"/>
               </a:ext>
             </a:extLst>
           </p:cNvPr>
@@ -6568,7 +6962,7 @@
           <p:cNvPr id="3" name="TextBox 2">
             <a:extLst>
               <a:ext uri="{FF2B5EF4-FFF2-40B4-BE49-F238E27FC236}">
-                <a16:creationId xmlns:a16="http://schemas.microsoft.com/office/drawing/2014/main" id="{2ED27510-3CA8-9AF0-AA78-97935BDB71EA}"/>
+                <a16:creationId xmlns:a16="http://schemas.microsoft.com/office/drawing/2014/main" id="{DB1AF7B0-12A3-20EC-31A6-59DB57202EF5}"/>
               </a:ext>
             </a:extLst>
           </p:cNvPr>
@@ -6608,7 +7002,7 @@
           <p:cNvPr id="4" name="Table 3">
             <a:extLst>
               <a:ext uri="{FF2B5EF4-FFF2-40B4-BE49-F238E27FC236}">
-                <a16:creationId xmlns:a16="http://schemas.microsoft.com/office/drawing/2014/main" id="{5AE43F58-5865-A41F-7629-58C1D6A3D82E}"/>
+                <a16:creationId xmlns:a16="http://schemas.microsoft.com/office/drawing/2014/main" id="{156A06E6-8255-C578-EF72-77285B1C4B4F}"/>
               </a:ext>
             </a:extLst>
           </p:cNvPr>
@@ -6618,7 +7012,7 @@
           <p:nvPr>
             <p:extLst>
               <p:ext uri="{D42A27DB-BD31-4B8C-83A1-F6EECF244321}">
-                <p14:modId xmlns:p14="http://schemas.microsoft.com/office/powerpoint/2010/main" val="3659687252"/>
+                <p14:modId xmlns:p14="http://schemas.microsoft.com/office/powerpoint/2010/main" val="1622637576"/>
               </p:ext>
             </p:extLst>
           </p:nvPr>
@@ -6637,21 +7031,21 @@
                 <a:gridCol w="3048000">
                   <a:extLst>
                     <a:ext uri="{9D8B030D-6E8A-4147-A177-3AD203B41FA5}">
-                      <a16:colId xmlns:a16="http://schemas.microsoft.com/office/drawing/2014/main" val="333079226"/>
+                      <a16:colId xmlns:a16="http://schemas.microsoft.com/office/drawing/2014/main" val="474506419"/>
                     </a:ext>
                   </a:extLst>
                 </a:gridCol>
                 <a:gridCol w="4064000">
                   <a:extLst>
                     <a:ext uri="{9D8B030D-6E8A-4147-A177-3AD203B41FA5}">
-                      <a16:colId xmlns:a16="http://schemas.microsoft.com/office/drawing/2014/main" val="2706659798"/>
+                      <a16:colId xmlns:a16="http://schemas.microsoft.com/office/drawing/2014/main" val="108796679"/>
                     </a:ext>
                   </a:extLst>
                 </a:gridCol>
                 <a:gridCol w="1778000">
                   <a:extLst>
                     <a:ext uri="{9D8B030D-6E8A-4147-A177-3AD203B41FA5}">
-                      <a16:colId xmlns:a16="http://schemas.microsoft.com/office/drawing/2014/main" val="1273836969"/>
+                      <a16:colId xmlns:a16="http://schemas.microsoft.com/office/drawing/2014/main" val="1837972860"/>
                     </a:ext>
                   </a:extLst>
                 </a:gridCol>
@@ -6725,7 +7119,7 @@
                 </a:tc>
                 <a:extLst>
                   <a:ext uri="{0D108BD9-81ED-4DB2-BD59-A6C34878D82A}">
-                    <a16:rowId xmlns:a16="http://schemas.microsoft.com/office/drawing/2014/main" val="1831634867"/>
+                    <a16:rowId xmlns:a16="http://schemas.microsoft.com/office/drawing/2014/main" val="2319520071"/>
                   </a:ext>
                 </a:extLst>
               </a:tr>
@@ -6798,7 +7192,7 @@
                 </a:tc>
                 <a:extLst>
                   <a:ext uri="{0D108BD9-81ED-4DB2-BD59-A6C34878D82A}">
-                    <a16:rowId xmlns:a16="http://schemas.microsoft.com/office/drawing/2014/main" val="623187213"/>
+                    <a16:rowId xmlns:a16="http://schemas.microsoft.com/office/drawing/2014/main" val="1427772711"/>
                   </a:ext>
                 </a:extLst>
               </a:tr>
@@ -6859,7 +7253,7 @@
                 </a:tc>
                 <a:extLst>
                   <a:ext uri="{0D108BD9-81ED-4DB2-BD59-A6C34878D82A}">
-                    <a16:rowId xmlns:a16="http://schemas.microsoft.com/office/drawing/2014/main" val="655928473"/>
+                    <a16:rowId xmlns:a16="http://schemas.microsoft.com/office/drawing/2014/main" val="315740898"/>
                   </a:ext>
                 </a:extLst>
               </a:tr>
@@ -6932,7 +7326,7 @@
                 </a:tc>
                 <a:extLst>
                   <a:ext uri="{0D108BD9-81ED-4DB2-BD59-A6C34878D82A}">
-                    <a16:rowId xmlns:a16="http://schemas.microsoft.com/office/drawing/2014/main" val="3244548131"/>
+                    <a16:rowId xmlns:a16="http://schemas.microsoft.com/office/drawing/2014/main" val="1076141791"/>
                   </a:ext>
                 </a:extLst>
               </a:tr>
@@ -6993,7 +7387,7 @@
                 </a:tc>
                 <a:extLst>
                   <a:ext uri="{0D108BD9-81ED-4DB2-BD59-A6C34878D82A}">
-                    <a16:rowId xmlns:a16="http://schemas.microsoft.com/office/drawing/2014/main" val="342922076"/>
+                    <a16:rowId xmlns:a16="http://schemas.microsoft.com/office/drawing/2014/main" val="24391164"/>
                   </a:ext>
                 </a:extLst>
               </a:tr>
@@ -7006,7 +7400,7 @@
           <p:cNvPr id="5" name="TextBox 4">
             <a:extLst>
               <a:ext uri="{FF2B5EF4-FFF2-40B4-BE49-F238E27FC236}">
-                <a16:creationId xmlns:a16="http://schemas.microsoft.com/office/drawing/2014/main" id="{498ABE1A-59A4-EEB1-418F-921560890DA6}"/>
+                <a16:creationId xmlns:a16="http://schemas.microsoft.com/office/drawing/2014/main" id="{ACC2BAF0-EC87-A118-8A02-DDFAEC026C6C}"/>
               </a:ext>
             </a:extLst>
           </p:cNvPr>
@@ -7095,7 +7489,7 @@
     </p:spTree>
     <p:extLst>
       <p:ext uri="{BB962C8B-B14F-4D97-AF65-F5344CB8AC3E}">
-        <p14:creationId xmlns:p14="http://schemas.microsoft.com/office/powerpoint/2010/main" val="539006075"/>
+        <p14:creationId xmlns:p14="http://schemas.microsoft.com/office/powerpoint/2010/main" val="1697384335"/>
       </p:ext>
     </p:extLst>
   </p:cSld>
@@ -7127,7 +7521,7 @@
           <p:cNvPr id="2" name="Rectangle: Rounded Corners 1">
             <a:extLst>
               <a:ext uri="{FF2B5EF4-FFF2-40B4-BE49-F238E27FC236}">
-                <a16:creationId xmlns:a16="http://schemas.microsoft.com/office/drawing/2014/main" id="{E78527F5-DAA5-DDF9-FFF0-032107EE276A}"/>
+                <a16:creationId xmlns:a16="http://schemas.microsoft.com/office/drawing/2014/main" id="{58C4F230-C749-6BFB-B542-B419822201CB}"/>
               </a:ext>
             </a:extLst>
           </p:cNvPr>
@@ -7195,7 +7589,7 @@
           <p:cNvPr id="3" name="TextBox 2">
             <a:extLst>
               <a:ext uri="{FF2B5EF4-FFF2-40B4-BE49-F238E27FC236}">
-                <a16:creationId xmlns:a16="http://schemas.microsoft.com/office/drawing/2014/main" id="{4E7A71F7-A522-093D-FDF7-84A9A95E3A94}"/>
+                <a16:creationId xmlns:a16="http://schemas.microsoft.com/office/drawing/2014/main" id="{17F7A2DC-D8E8-8D3F-55C1-77BA0AC156EE}"/>
               </a:ext>
             </a:extLst>
           </p:cNvPr>
@@ -7235,7 +7629,7 @@
           <p:cNvPr id="4" name="Table 3">
             <a:extLst>
               <a:ext uri="{FF2B5EF4-FFF2-40B4-BE49-F238E27FC236}">
-                <a16:creationId xmlns:a16="http://schemas.microsoft.com/office/drawing/2014/main" id="{4A6CE754-9235-C7B6-C4CE-2E8E409000BB}"/>
+                <a16:creationId xmlns:a16="http://schemas.microsoft.com/office/drawing/2014/main" id="{7985BBD1-E00E-F84C-7B38-E1D3AD4574D8}"/>
               </a:ext>
             </a:extLst>
           </p:cNvPr>
@@ -7245,7 +7639,7 @@
           <p:nvPr>
             <p:extLst>
               <p:ext uri="{D42A27DB-BD31-4B8C-83A1-F6EECF244321}">
-                <p14:modId xmlns:p14="http://schemas.microsoft.com/office/powerpoint/2010/main" val="1454114299"/>
+                <p14:modId xmlns:p14="http://schemas.microsoft.com/office/powerpoint/2010/main" val="3101569552"/>
               </p:ext>
             </p:extLst>
           </p:nvPr>
@@ -7264,14 +7658,14 @@
                 <a:gridCol w="3810000">
                   <a:extLst>
                     <a:ext uri="{9D8B030D-6E8A-4147-A177-3AD203B41FA5}">
-                      <a16:colId xmlns:a16="http://schemas.microsoft.com/office/drawing/2014/main" val="1502299428"/>
+                      <a16:colId xmlns:a16="http://schemas.microsoft.com/office/drawing/2014/main" val="2765994299"/>
                     </a:ext>
                   </a:extLst>
                 </a:gridCol>
                 <a:gridCol w="4064000">
                   <a:extLst>
                     <a:ext uri="{9D8B030D-6E8A-4147-A177-3AD203B41FA5}">
-                      <a16:colId xmlns:a16="http://schemas.microsoft.com/office/drawing/2014/main" val="493903655"/>
+                      <a16:colId xmlns:a16="http://schemas.microsoft.com/office/drawing/2014/main" val="981800373"/>
                     </a:ext>
                   </a:extLst>
                 </a:gridCol>
@@ -7323,7 +7717,7 @@
                 </a:tc>
                 <a:extLst>
                   <a:ext uri="{0D108BD9-81ED-4DB2-BD59-A6C34878D82A}">
-                    <a16:rowId xmlns:a16="http://schemas.microsoft.com/office/drawing/2014/main" val="2083465450"/>
+                    <a16:rowId xmlns:a16="http://schemas.microsoft.com/office/drawing/2014/main" val="2323096171"/>
                   </a:ext>
                 </a:extLst>
               </a:tr>
@@ -7374,7 +7768,7 @@
                 </a:tc>
                 <a:extLst>
                   <a:ext uri="{0D108BD9-81ED-4DB2-BD59-A6C34878D82A}">
-                    <a16:rowId xmlns:a16="http://schemas.microsoft.com/office/drawing/2014/main" val="1337000344"/>
+                    <a16:rowId xmlns:a16="http://schemas.microsoft.com/office/drawing/2014/main" val="2306329950"/>
                   </a:ext>
                 </a:extLst>
               </a:tr>
@@ -7417,7 +7811,7 @@
                 </a:tc>
                 <a:extLst>
                   <a:ext uri="{0D108BD9-81ED-4DB2-BD59-A6C34878D82A}">
-                    <a16:rowId xmlns:a16="http://schemas.microsoft.com/office/drawing/2014/main" val="1430373716"/>
+                    <a16:rowId xmlns:a16="http://schemas.microsoft.com/office/drawing/2014/main" val="1428259434"/>
                   </a:ext>
                 </a:extLst>
               </a:tr>
@@ -7468,7 +7862,7 @@
                 </a:tc>
                 <a:extLst>
                   <a:ext uri="{0D108BD9-81ED-4DB2-BD59-A6C34878D82A}">
-                    <a16:rowId xmlns:a16="http://schemas.microsoft.com/office/drawing/2014/main" val="3856875813"/>
+                    <a16:rowId xmlns:a16="http://schemas.microsoft.com/office/drawing/2014/main" val="3877351035"/>
                   </a:ext>
                 </a:extLst>
               </a:tr>
@@ -7511,7 +7905,7 @@
                 </a:tc>
                 <a:extLst>
                   <a:ext uri="{0D108BD9-81ED-4DB2-BD59-A6C34878D82A}">
-                    <a16:rowId xmlns:a16="http://schemas.microsoft.com/office/drawing/2014/main" val="3270747267"/>
+                    <a16:rowId xmlns:a16="http://schemas.microsoft.com/office/drawing/2014/main" val="2938557476"/>
                   </a:ext>
                 </a:extLst>
               </a:tr>
@@ -7562,7 +7956,7 @@
                 </a:tc>
                 <a:extLst>
                   <a:ext uri="{0D108BD9-81ED-4DB2-BD59-A6C34878D82A}">
-                    <a16:rowId xmlns:a16="http://schemas.microsoft.com/office/drawing/2014/main" val="1743255179"/>
+                    <a16:rowId xmlns:a16="http://schemas.microsoft.com/office/drawing/2014/main" val="2865243019"/>
                   </a:ext>
                 </a:extLst>
               </a:tr>
@@ -7605,7 +7999,7 @@
                 </a:tc>
                 <a:extLst>
                   <a:ext uri="{0D108BD9-81ED-4DB2-BD59-A6C34878D82A}">
-                    <a16:rowId xmlns:a16="http://schemas.microsoft.com/office/drawing/2014/main" val="2227804754"/>
+                    <a16:rowId xmlns:a16="http://schemas.microsoft.com/office/drawing/2014/main" val="3740079547"/>
                   </a:ext>
                 </a:extLst>
               </a:tr>
@@ -7656,7 +8050,7 @@
                 </a:tc>
                 <a:extLst>
                   <a:ext uri="{0D108BD9-81ED-4DB2-BD59-A6C34878D82A}">
-                    <a16:rowId xmlns:a16="http://schemas.microsoft.com/office/drawing/2014/main" val="1011865987"/>
+                    <a16:rowId xmlns:a16="http://schemas.microsoft.com/office/drawing/2014/main" val="59560082"/>
                   </a:ext>
                 </a:extLst>
               </a:tr>
@@ -7699,7 +8093,7 @@
                 </a:tc>
                 <a:extLst>
                   <a:ext uri="{0D108BD9-81ED-4DB2-BD59-A6C34878D82A}">
-                    <a16:rowId xmlns:a16="http://schemas.microsoft.com/office/drawing/2014/main" val="1321148682"/>
+                    <a16:rowId xmlns:a16="http://schemas.microsoft.com/office/drawing/2014/main" val="567188079"/>
                   </a:ext>
                 </a:extLst>
               </a:tr>
@@ -7750,7 +8144,7 @@
                 </a:tc>
                 <a:extLst>
                   <a:ext uri="{0D108BD9-81ED-4DB2-BD59-A6C34878D82A}">
-                    <a16:rowId xmlns:a16="http://schemas.microsoft.com/office/drawing/2014/main" val="2724387160"/>
+                    <a16:rowId xmlns:a16="http://schemas.microsoft.com/office/drawing/2014/main" val="3882843431"/>
                   </a:ext>
                 </a:extLst>
               </a:tr>
@@ -7793,7 +8187,7 @@
                 </a:tc>
                 <a:extLst>
                   <a:ext uri="{0D108BD9-81ED-4DB2-BD59-A6C34878D82A}">
-                    <a16:rowId xmlns:a16="http://schemas.microsoft.com/office/drawing/2014/main" val="3602599320"/>
+                    <a16:rowId xmlns:a16="http://schemas.microsoft.com/office/drawing/2014/main" val="833879581"/>
                   </a:ext>
                 </a:extLst>
               </a:tr>
@@ -7806,7 +8200,7 @@
           <p:cNvPr id="5" name="TextBox 4">
             <a:extLst>
               <a:ext uri="{FF2B5EF4-FFF2-40B4-BE49-F238E27FC236}">
-                <a16:creationId xmlns:a16="http://schemas.microsoft.com/office/drawing/2014/main" id="{0F2A7C84-6DA7-F681-19B6-517F7169FD15}"/>
+                <a16:creationId xmlns:a16="http://schemas.microsoft.com/office/drawing/2014/main" id="{DA5F9577-8604-A192-F9E3-136F2C79AA94}"/>
               </a:ext>
             </a:extLst>
           </p:cNvPr>
@@ -7912,7 +8306,7 @@
     </p:spTree>
     <p:extLst>
       <p:ext uri="{BB962C8B-B14F-4D97-AF65-F5344CB8AC3E}">
-        <p14:creationId xmlns:p14="http://schemas.microsoft.com/office/powerpoint/2010/main" val="414892381"/>
+        <p14:creationId xmlns:p14="http://schemas.microsoft.com/office/powerpoint/2010/main" val="1216949122"/>
       </p:ext>
     </p:extLst>
   </p:cSld>
@@ -7944,7 +8338,7 @@
           <p:cNvPr id="2" name="Rectangle: Rounded Corners 1">
             <a:extLst>
               <a:ext uri="{FF2B5EF4-FFF2-40B4-BE49-F238E27FC236}">
-                <a16:creationId xmlns:a16="http://schemas.microsoft.com/office/drawing/2014/main" id="{05A377C0-E330-727C-51D3-341D7BE1E6EC}"/>
+                <a16:creationId xmlns:a16="http://schemas.microsoft.com/office/drawing/2014/main" id="{B6537DF4-6A3B-5D92-2430-6D0EAF0A50DF}"/>
               </a:ext>
             </a:extLst>
           </p:cNvPr>
@@ -8012,7 +8406,7 @@
           <p:cNvPr id="3" name="TextBox 2">
             <a:extLst>
               <a:ext uri="{FF2B5EF4-FFF2-40B4-BE49-F238E27FC236}">
-                <a16:creationId xmlns:a16="http://schemas.microsoft.com/office/drawing/2014/main" id="{79367C6B-16E7-A3BD-2B2D-3E639ECE273E}"/>
+                <a16:creationId xmlns:a16="http://schemas.microsoft.com/office/drawing/2014/main" id="{9DD971A4-4B1F-CB8E-EDCF-789AD0F7C337}"/>
               </a:ext>
             </a:extLst>
           </p:cNvPr>
@@ -8052,7 +8446,7 @@
           <p:cNvPr id="4" name="Table 3">
             <a:extLst>
               <a:ext uri="{FF2B5EF4-FFF2-40B4-BE49-F238E27FC236}">
-                <a16:creationId xmlns:a16="http://schemas.microsoft.com/office/drawing/2014/main" id="{8B84E0D0-94B9-86FB-27C0-ADE36D06B2B6}"/>
+                <a16:creationId xmlns:a16="http://schemas.microsoft.com/office/drawing/2014/main" id="{46DADFBC-C3F9-37BC-590A-8BA6E3FF8FCE}"/>
               </a:ext>
             </a:extLst>
           </p:cNvPr>
@@ -8062,7 +8456,7 @@
           <p:nvPr>
             <p:extLst>
               <p:ext uri="{D42A27DB-BD31-4B8C-83A1-F6EECF244321}">
-                <p14:modId xmlns:p14="http://schemas.microsoft.com/office/powerpoint/2010/main" val="846752911"/>
+                <p14:modId xmlns:p14="http://schemas.microsoft.com/office/powerpoint/2010/main" val="3314221023"/>
               </p:ext>
             </p:extLst>
           </p:nvPr>
@@ -8081,21 +8475,21 @@
                 <a:gridCol w="2286000">
                   <a:extLst>
                     <a:ext uri="{9D8B030D-6E8A-4147-A177-3AD203B41FA5}">
-                      <a16:colId xmlns:a16="http://schemas.microsoft.com/office/drawing/2014/main" val="90099180"/>
+                      <a16:colId xmlns:a16="http://schemas.microsoft.com/office/drawing/2014/main" val="2100096330"/>
                     </a:ext>
                   </a:extLst>
                 </a:gridCol>
                 <a:gridCol w="5842000">
                   <a:extLst>
                     <a:ext uri="{9D8B030D-6E8A-4147-A177-3AD203B41FA5}">
-                      <a16:colId xmlns:a16="http://schemas.microsoft.com/office/drawing/2014/main" val="124051125"/>
+                      <a16:colId xmlns:a16="http://schemas.microsoft.com/office/drawing/2014/main" val="2669267039"/>
                     </a:ext>
                   </a:extLst>
                 </a:gridCol>
                 <a:gridCol w="1524000">
                   <a:extLst>
                     <a:ext uri="{9D8B030D-6E8A-4147-A177-3AD203B41FA5}">
-                      <a16:colId xmlns:a16="http://schemas.microsoft.com/office/drawing/2014/main" val="185988520"/>
+                      <a16:colId xmlns:a16="http://schemas.microsoft.com/office/drawing/2014/main" val="1925802440"/>
                     </a:ext>
                   </a:extLst>
                 </a:gridCol>
@@ -8169,7 +8563,7 @@
                 </a:tc>
                 <a:extLst>
                   <a:ext uri="{0D108BD9-81ED-4DB2-BD59-A6C34878D82A}">
-                    <a16:rowId xmlns:a16="http://schemas.microsoft.com/office/drawing/2014/main" val="1753448446"/>
+                    <a16:rowId xmlns:a16="http://schemas.microsoft.com/office/drawing/2014/main" val="1274190073"/>
                   </a:ext>
                 </a:extLst>
               </a:tr>
@@ -8242,7 +8636,7 @@
                 </a:tc>
                 <a:extLst>
                   <a:ext uri="{0D108BD9-81ED-4DB2-BD59-A6C34878D82A}">
-                    <a16:rowId xmlns:a16="http://schemas.microsoft.com/office/drawing/2014/main" val="709140304"/>
+                    <a16:rowId xmlns:a16="http://schemas.microsoft.com/office/drawing/2014/main" val="2910161360"/>
                   </a:ext>
                 </a:extLst>
               </a:tr>
@@ -8277,7 +8671,7 @@
                           </a:solidFill>
                           <a:latin typeface="Calibri" panose="020F0502020204030204" pitchFamily="34" charset="0"/>
                         </a:rPr>
-                        <a:t>Product + category + model attributes (SCD1)</a:t>
+                        <a:t>Product + category + model attributes; Cost/Price history (SCD2)</a:t>
                       </a:r>
                     </a:p>
                   </a:txBody>
@@ -8303,7 +8697,7 @@
                 </a:tc>
                 <a:extLst>
                   <a:ext uri="{0D108BD9-81ED-4DB2-BD59-A6C34878D82A}">
-                    <a16:rowId xmlns:a16="http://schemas.microsoft.com/office/drawing/2014/main" val="1892021726"/>
+                    <a16:rowId xmlns:a16="http://schemas.microsoft.com/office/drawing/2014/main" val="2072378037"/>
                   </a:ext>
                 </a:extLst>
               </a:tr>
@@ -8376,7 +8770,7 @@
                 </a:tc>
                 <a:extLst>
                   <a:ext uri="{0D108BD9-81ED-4DB2-BD59-A6C34878D82A}">
-                    <a16:rowId xmlns:a16="http://schemas.microsoft.com/office/drawing/2014/main" val="1632813048"/>
+                    <a16:rowId xmlns:a16="http://schemas.microsoft.com/office/drawing/2014/main" val="2382531887"/>
                   </a:ext>
                 </a:extLst>
               </a:tr>
@@ -8389,7 +8783,7 @@
           <p:cNvPr id="5" name="TextBox 4">
             <a:extLst>
               <a:ext uri="{FF2B5EF4-FFF2-40B4-BE49-F238E27FC236}">
-                <a16:creationId xmlns:a16="http://schemas.microsoft.com/office/drawing/2014/main" id="{CC0526DF-CCF6-569D-8538-083EAEC2A422}"/>
+                <a16:creationId xmlns:a16="http://schemas.microsoft.com/office/drawing/2014/main" id="{B7A8866A-6A4F-AA19-9727-72216CA452EF}"/>
               </a:ext>
             </a:extLst>
           </p:cNvPr>
@@ -8399,7 +8793,7 @@
         <p:spPr>
           <a:xfrm>
             <a:off x="762000" y="4318000"/>
-            <a:ext cx="10668000" cy="1323439"/>
+            <a:ext cx="10668000" cy="1569660"/>
           </a:xfrm>
           <a:prstGeom prst="rect">
             <a:avLst/>
@@ -8470,7 +8864,7 @@
                 </a:solidFill>
                 <a:latin typeface="Calibri" panose="020F0502020204030204" pitchFamily="34" charset="0"/>
               </a:rPr>
-              <a:t>SCD1 updates change existing customer/product rows in place</a:t>
+              <a:t>SCD1 updates change existing customer rows in place; SellEndDate overwritten across all product variants</a:t>
             </a:r>
             <a:br>
               <a:rPr lang="en-US" sz="1600">
@@ -8487,7 +8881,24 @@
                 </a:solidFill>
                 <a:latin typeface="Calibri" panose="020F0502020204030204" pitchFamily="34" charset="0"/>
               </a:rPr>
-              <a:t>Foreign keys enforced; load disables/re-enables constraints</a:t>
+              <a:t>SCD2 expires the current version and inserts a new one when Cost/Price changes (EffectiveStart/EffectiveEndDate)</a:t>
+            </a:r>
+            <a:br>
+              <a:rPr lang="en-US" sz="1600">
+                <a:solidFill>
+                  <a:srgbClr val="1F3864"/>
+                </a:solidFill>
+                <a:latin typeface="Calibri" panose="020F0502020204030204" pitchFamily="34" charset="0"/>
+              </a:rPr>
+            </a:br>
+            <a:r>
+              <a:rPr lang="en-US" sz="1600">
+                <a:solidFill>
+                  <a:srgbClr val="1F3864"/>
+                </a:solidFill>
+                <a:latin typeface="Calibri" panose="020F0502020204030204" pitchFamily="34" charset="0"/>
+              </a:rPr>
+              <a:t>Foreign keys enforced; load disables/re-enables constraints (InitialLoad)</a:t>
             </a:r>
           </a:p>
         </p:txBody>
@@ -8495,7 +8906,7 @@
     </p:spTree>
     <p:extLst>
       <p:ext uri="{BB962C8B-B14F-4D97-AF65-F5344CB8AC3E}">
-        <p14:creationId xmlns:p14="http://schemas.microsoft.com/office/powerpoint/2010/main" val="1825334149"/>
+        <p14:creationId xmlns:p14="http://schemas.microsoft.com/office/powerpoint/2010/main" val="597711356"/>
       </p:ext>
     </p:extLst>
   </p:cSld>
@@ -8527,7 +8938,7 @@
           <p:cNvPr id="2" name="Rectangle: Rounded Corners 1">
             <a:extLst>
               <a:ext uri="{FF2B5EF4-FFF2-40B4-BE49-F238E27FC236}">
-                <a16:creationId xmlns:a16="http://schemas.microsoft.com/office/drawing/2014/main" id="{89A9860C-A295-8E25-C2D7-B3D7EDB5A9B8}"/>
+                <a16:creationId xmlns:a16="http://schemas.microsoft.com/office/drawing/2014/main" id="{02E3458C-6D38-3D60-12FA-037DDA625117}"/>
               </a:ext>
             </a:extLst>
           </p:cNvPr>
@@ -8595,7 +9006,7 @@
           <p:cNvPr id="3" name="TextBox 2">
             <a:extLst>
               <a:ext uri="{FF2B5EF4-FFF2-40B4-BE49-F238E27FC236}">
-                <a16:creationId xmlns:a16="http://schemas.microsoft.com/office/drawing/2014/main" id="{87DD8CC9-49A9-BB72-F9B3-5D6A1433111E}"/>
+                <a16:creationId xmlns:a16="http://schemas.microsoft.com/office/drawing/2014/main" id="{778EF48B-E278-EA19-E78C-A1F2F85981AC}"/>
               </a:ext>
             </a:extLst>
           </p:cNvPr>
@@ -8635,7 +9046,7 @@
           <p:cNvPr id="4" name="TextBox 3">
             <a:extLst>
               <a:ext uri="{FF2B5EF4-FFF2-40B4-BE49-F238E27FC236}">
-                <a16:creationId xmlns:a16="http://schemas.microsoft.com/office/drawing/2014/main" id="{D115DAE7-29CE-F71A-1670-6706BDF35B17}"/>
+                <a16:creationId xmlns:a16="http://schemas.microsoft.com/office/drawing/2014/main" id="{1B36B75A-A30C-450C-3215-F893C52E4588}"/>
               </a:ext>
             </a:extLst>
           </p:cNvPr>
@@ -8645,7 +9056,7 @@
         <p:spPr>
           <a:xfrm>
             <a:off x="762000" y="1270000"/>
-            <a:ext cx="10668000" cy="3046988"/>
+            <a:ext cx="10668000" cy="3539430"/>
           </a:xfrm>
           <a:prstGeom prst="rect">
             <a:avLst/>
@@ -8683,7 +9094,7 @@
                 </a:solidFill>
                 <a:latin typeface="Calibri" panose="020F0502020204030204" pitchFamily="34" charset="0"/>
               </a:rPr>
-              <a:t>Set Current Job Time -&gt; Sync InitialLoad Parameter -&gt; Sync Language Parameter</a:t>
+              <a:t>Set Current Job Time (CurrentJobTime param; GETDATE fallback) -&gt; Sync InitialLoad -&gt; Sync Language -&gt; Read Watermark</a:t>
             </a:r>
             <a:br>
               <a:rPr lang="en-US" sz="1600" b="1">
@@ -8802,7 +9213,7 @@
                 </a:solidFill>
                 <a:latin typeface="Calibri" panose="020F0502020204030204" pitchFamily="34" charset="0"/>
               </a:rPr>
-              <a:t>Load DimProduct (SCD1): lookup, update-or-insert</a:t>
+              <a:t>Load DimProduct (SCD2): lookup, update-or-insert; expire + insert on Cost/Price change; SellEndDate overwrite</a:t>
             </a:r>
             <a:br>
               <a:rPr lang="en-US" sz="1600" b="1">
@@ -8836,7 +9247,7 @@
                 </a:solidFill>
                 <a:latin typeface="Calibri" panose="020F0502020204030204" pitchFamily="34" charset="0"/>
               </a:rPr>
-              <a:t>Source staging SOH+SOD; lookups for customer/product/order/ship dates; bad rows to BadRows</a:t>
+              <a:t>Source staging SOH+SOD where OrderDate &gt; last watermark AND &lt;= CurrentJobTime; lookups for customer/product/order/ship dates</a:t>
             </a:r>
             <a:br>
               <a:rPr lang="en-US" sz="1600" b="1">
@@ -8853,7 +9264,7 @@
                 </a:solidFill>
                 <a:latin typeface="Calibri" panose="020F0502020204030204" pitchFamily="34" charset="0"/>
               </a:rPr>
-              <a:t>Update Watermark (LastSuccessfulRun = current job time)</a:t>
+              <a:t>Update Watermark (LastSuccessfulRun = CurrentJobTime)</a:t>
             </a:r>
           </a:p>
         </p:txBody>
@@ -8861,7 +9272,7 @@
     </p:spTree>
     <p:extLst>
       <p:ext uri="{BB962C8B-B14F-4D97-AF65-F5344CB8AC3E}">
-        <p14:creationId xmlns:p14="http://schemas.microsoft.com/office/powerpoint/2010/main" val="2182208508"/>
+        <p14:creationId xmlns:p14="http://schemas.microsoft.com/office/powerpoint/2010/main" val="2148699518"/>
       </p:ext>
     </p:extLst>
   </p:cSld>
@@ -8893,7 +9304,7 @@
           <p:cNvPr id="2" name="Rectangle: Rounded Corners 1">
             <a:extLst>
               <a:ext uri="{FF2B5EF4-FFF2-40B4-BE49-F238E27FC236}">
-                <a16:creationId xmlns:a16="http://schemas.microsoft.com/office/drawing/2014/main" id="{65D306FE-04B0-A055-4A27-5E39CB8CF825}"/>
+                <a16:creationId xmlns:a16="http://schemas.microsoft.com/office/drawing/2014/main" id="{0E8936B9-4405-3C6F-B543-7D0F3C2AEC2A}"/>
               </a:ext>
             </a:extLst>
           </p:cNvPr>
@@ -8961,7 +9372,7 @@
           <p:cNvPr id="3" name="TextBox 2">
             <a:extLst>
               <a:ext uri="{FF2B5EF4-FFF2-40B4-BE49-F238E27FC236}">
-                <a16:creationId xmlns:a16="http://schemas.microsoft.com/office/drawing/2014/main" id="{11AB1CBB-C061-A9BA-52FE-8BC06039562E}"/>
+                <a16:creationId xmlns:a16="http://schemas.microsoft.com/office/drawing/2014/main" id="{E675749B-2CE4-1190-7A2B-8E22F0C51BAE}"/>
               </a:ext>
             </a:extLst>
           </p:cNvPr>
@@ -9001,7 +9412,7 @@
           <p:cNvPr id="4" name="Table 3">
             <a:extLst>
               <a:ext uri="{FF2B5EF4-FFF2-40B4-BE49-F238E27FC236}">
-                <a16:creationId xmlns:a16="http://schemas.microsoft.com/office/drawing/2014/main" id="{B0C1F4B9-337C-83BF-D070-E89FB0691FD9}"/>
+                <a16:creationId xmlns:a16="http://schemas.microsoft.com/office/drawing/2014/main" id="{7C953BFE-41DE-394C-C8EF-7DD6A1701A30}"/>
               </a:ext>
             </a:extLst>
           </p:cNvPr>
@@ -9011,14 +9422,14 @@
           <p:nvPr>
             <p:extLst>
               <p:ext uri="{D42A27DB-BD31-4B8C-83A1-F6EECF244321}">
-                <p14:modId xmlns:p14="http://schemas.microsoft.com/office/powerpoint/2010/main" val="2855348070"/>
+                <p14:modId xmlns:p14="http://schemas.microsoft.com/office/powerpoint/2010/main" val="3140419893"/>
               </p:ext>
             </p:extLst>
           </p:nvPr>
         </p:nvGraphicFramePr>
         <p:xfrm>
           <a:off x="762000" y="1270000"/>
-          <a:ext cx="10414000" cy="3810000"/>
+          <a:ext cx="10668000" cy="3810000"/>
         </p:xfrm>
         <a:graphic>
           <a:graphicData uri="http://schemas.openxmlformats.org/drawingml/2006/table">
@@ -9027,31 +9438,31 @@
                 <a:tableStyleId>{5C22544A-7EE6-4342-B048-85BDC9FD1C3A}</a:tableStyleId>
               </a:tblPr>
               <a:tblGrid>
+                <a:gridCol w="1905000">
+                  <a:extLst>
+                    <a:ext uri="{9D8B030D-6E8A-4147-A177-3AD203B41FA5}">
+                      <a16:colId xmlns:a16="http://schemas.microsoft.com/office/drawing/2014/main" val="959137385"/>
+                    </a:ext>
+                  </a:extLst>
+                </a:gridCol>
                 <a:gridCol w="1524000">
                   <a:extLst>
                     <a:ext uri="{9D8B030D-6E8A-4147-A177-3AD203B41FA5}">
-                      <a16:colId xmlns:a16="http://schemas.microsoft.com/office/drawing/2014/main" val="723322757"/>
-                    </a:ext>
-                  </a:extLst>
-                </a:gridCol>
-                <a:gridCol w="1905000">
-                  <a:extLst>
-                    <a:ext uri="{9D8B030D-6E8A-4147-A177-3AD203B41FA5}">
-                      <a16:colId xmlns:a16="http://schemas.microsoft.com/office/drawing/2014/main" val="2229342991"/>
+                      <a16:colId xmlns:a16="http://schemas.microsoft.com/office/drawing/2014/main" val="704101177"/>
                     </a:ext>
                   </a:extLst>
                 </a:gridCol>
                 <a:gridCol w="4064000">
                   <a:extLst>
                     <a:ext uri="{9D8B030D-6E8A-4147-A177-3AD203B41FA5}">
-                      <a16:colId xmlns:a16="http://schemas.microsoft.com/office/drawing/2014/main" val="3942023830"/>
+                      <a16:colId xmlns:a16="http://schemas.microsoft.com/office/drawing/2014/main" val="2830614756"/>
                     </a:ext>
                   </a:extLst>
                 </a:gridCol>
-                <a:gridCol w="2921000">
+                <a:gridCol w="3175000">
                   <a:extLst>
                     <a:ext uri="{9D8B030D-6E8A-4147-A177-3AD203B41FA5}">
-                      <a16:colId xmlns:a16="http://schemas.microsoft.com/office/drawing/2014/main" val="856208767"/>
+                      <a16:colId xmlns:a16="http://schemas.microsoft.com/office/drawing/2014/main" val="3878511715"/>
                     </a:ext>
                   </a:extLst>
                 </a:gridCol>
@@ -9147,7 +9558,7 @@
                 </a:tc>
                 <a:extLst>
                   <a:ext uri="{0D108BD9-81ED-4DB2-BD59-A6C34878D82A}">
-                    <a16:rowId xmlns:a16="http://schemas.microsoft.com/office/drawing/2014/main" val="3713917347"/>
+                    <a16:rowId xmlns:a16="http://schemas.microsoft.com/office/drawing/2014/main" val="3850281373"/>
                   </a:ext>
                 </a:extLst>
               </a:tr>
@@ -9164,7 +9575,7 @@
                           </a:solidFill>
                           <a:latin typeface="Calibri" panose="020F0502020204030204" pitchFamily="34" charset="0"/>
                         </a:rPr>
-                        <a:t>Full</a:t>
+                        <a:t>Full (Run I)</a:t>
                       </a:r>
                     </a:p>
                   </a:txBody>
@@ -9186,7 +9597,7 @@
                           </a:solidFill>
                           <a:latin typeface="Calibri" panose="020F0502020204030204" pitchFamily="34" charset="0"/>
                         </a:rPr>
-                        <a:t>True (default)</a:t>
+                        <a:t>True</a:t>
                       </a:r>
                     </a:p>
                   </a:txBody>
@@ -9208,7 +9619,7 @@
                           </a:solidFill>
                           <a:latin typeface="Calibri" panose="020F0502020204030204" pitchFamily="34" charset="0"/>
                         </a:rPr>
-                        <a:t>All rows (cutoff = 1900-01-01)</a:t>
+                        <a:t>All rows; watermark seeded 1900-01-01</a:t>
                       </a:r>
                     </a:p>
                   </a:txBody>
@@ -9242,7 +9653,7 @@
                 </a:tc>
                 <a:extLst>
                   <a:ext uri="{0D108BD9-81ED-4DB2-BD59-A6C34878D82A}">
-                    <a16:rowId xmlns:a16="http://schemas.microsoft.com/office/drawing/2014/main" val="1166473311"/>
+                    <a16:rowId xmlns:a16="http://schemas.microsoft.com/office/drawing/2014/main" val="2383408313"/>
                   </a:ext>
                 </a:extLst>
               </a:tr>
@@ -9259,7 +9670,7 @@
                           </a:solidFill>
                           <a:latin typeface="Calibri" panose="020F0502020204030204" pitchFamily="34" charset="0"/>
                         </a:rPr>
-                        <a:t>Incremental</a:t>
+                        <a:t>Incremental (Run II)</a:t>
                       </a:r>
                     </a:p>
                   </a:txBody>
@@ -9295,7 +9706,7 @@
                           </a:solidFill>
                           <a:latin typeface="Calibri" panose="020F0502020204030204" pitchFamily="34" charset="0"/>
                         </a:rPr>
-                        <a:t>Only rows with ModifiedDate &gt; watermark</a:t>
+                        <a:t>OrderDate &gt; watermark AND &lt;= CurrentJobTime</a:t>
                       </a:r>
                     </a:p>
                   </a:txBody>
@@ -9321,7 +9732,7 @@
                 </a:tc>
                 <a:extLst>
                   <a:ext uri="{0D108BD9-81ED-4DB2-BD59-A6C34878D82A}">
-                    <a16:rowId xmlns:a16="http://schemas.microsoft.com/office/drawing/2014/main" val="3550566722"/>
+                    <a16:rowId xmlns:a16="http://schemas.microsoft.com/office/drawing/2014/main" val="3875649343"/>
                   </a:ext>
                 </a:extLst>
               </a:tr>
@@ -9334,7 +9745,7 @@
           <p:cNvPr id="5" name="TextBox 4">
             <a:extLst>
               <a:ext uri="{FF2B5EF4-FFF2-40B4-BE49-F238E27FC236}">
-                <a16:creationId xmlns:a16="http://schemas.microsoft.com/office/drawing/2014/main" id="{6E93C3CB-FDB1-58A5-5478-5FBA3024D7AF}"/>
+                <a16:creationId xmlns:a16="http://schemas.microsoft.com/office/drawing/2014/main" id="{AFE0C5D4-0435-E99B-4F11-A0BB0C5ECFA5}"/>
               </a:ext>
             </a:extLst>
           </p:cNvPr>
@@ -9343,7 +9754,7 @@
         </p:nvSpPr>
         <p:spPr>
           <a:xfrm>
-            <a:off x="762000" y="3556000"/>
+            <a:off x="762000" y="3683000"/>
             <a:ext cx="10668000" cy="1569660"/>
           </a:xfrm>
           <a:prstGeom prst="rect">
@@ -9381,7 +9792,7 @@
                 </a:solidFill>
                 <a:latin typeface="Calibri" panose="020F0502020204030204" pitchFamily="34" charset="0"/>
               </a:rPr>
-              <a:t>Full load forces cutoff to 1900-01-01 in Read Watermark -&gt; every row qualifies</a:t>
+              <a:t>CurrentJobTime package parameter (DateTime) = the run window end, set per run (spec: set manually each run)</a:t>
             </a:r>
             <a:br>
               <a:rPr lang="en-US" sz="1600" b="1">
@@ -9398,7 +9809,7 @@
                 </a:solidFill>
                 <a:latin typeface="Calibri" panose="020F0502020204030204" pitchFamily="34" charset="0"/>
               </a:rPr>
-              <a:t>Incremental binds the last successful run into the OLE DB Source cutoff parameter</a:t>
+              <a:t>Fact source: WHERE SOH.OrderDate &gt; @LastJobTime AND SOH.OrderDate &lt;= @CurrentJobTime</a:t>
             </a:r>
             <a:br>
               <a:rPr lang="en-US" sz="1600" b="1">
@@ -9415,7 +9826,7 @@
                 </a:solidFill>
                 <a:latin typeface="Calibri" panose="020F0502020204030204" pitchFamily="34" charset="0"/>
               </a:rPr>
-              <a:t>Single-parameter design: WHERE ModifiedDate &gt; @LastJobTime (avoids unreliable multi-param binding)</a:t>
+              <a:t>Watermark is updated with CurrentJobTime after a successful run</a:t>
             </a:r>
             <a:br>
               <a:rPr lang="en-US" sz="1600" b="1">
@@ -9432,7 +9843,7 @@
                 </a:solidFill>
                 <a:latin typeface="Calibri" panose="020F0502020204030204" pitchFamily="34" charset="0"/>
               </a:rPr>
-              <a:t>Package param is baked in at build time; DTExec /SET cannot override it</a:t>
+              <a:t>Demo: Run I CurrentJobTime=12-30-2022 loads OLTP V1; Run II CurrentJobTime=12-30-2026 appends V1+V2</a:t>
             </a:r>
             <a:br>
               <a:rPr lang="en-US" sz="1600" b="1">
@@ -9449,7 +9860,7 @@
                 </a:solidFill>
                 <a:latin typeface="Calibri" panose="020F0502020204030204" pitchFamily="34" charset="0"/>
               </a:rPr>
-              <a:t>Incremental run after a full load is a no-op until new source rows arrive (all ModifiedDates are historical)</a:t>
+              <a:t>DTExec /File cannot override package parameters -&gt; defaults baked at build time via build_dtsx.ps1</a:t>
             </a:r>
           </a:p>
         </p:txBody>
@@ -9457,7 +9868,7 @@
     </p:spTree>
     <p:extLst>
       <p:ext uri="{BB962C8B-B14F-4D97-AF65-F5344CB8AC3E}">
-        <p14:creationId xmlns:p14="http://schemas.microsoft.com/office/powerpoint/2010/main" val="3868098742"/>
+        <p14:creationId xmlns:p14="http://schemas.microsoft.com/office/powerpoint/2010/main" val="2212483692"/>
       </p:ext>
     </p:extLst>
   </p:cSld>
@@ -9489,7 +9900,7 @@
           <p:cNvPr id="2" name="Rectangle: Rounded Corners 1">
             <a:extLst>
               <a:ext uri="{FF2B5EF4-FFF2-40B4-BE49-F238E27FC236}">
-                <a16:creationId xmlns:a16="http://schemas.microsoft.com/office/drawing/2014/main" id="{9D6B2B09-4676-F4FB-A855-FAAF0E3A9AF2}"/>
+                <a16:creationId xmlns:a16="http://schemas.microsoft.com/office/drawing/2014/main" id="{BE1445EA-39C4-D369-673C-15D3EC54F8CC}"/>
               </a:ext>
             </a:extLst>
           </p:cNvPr>
@@ -9557,7 +9968,7 @@
           <p:cNvPr id="3" name="TextBox 2">
             <a:extLst>
               <a:ext uri="{FF2B5EF4-FFF2-40B4-BE49-F238E27FC236}">
-                <a16:creationId xmlns:a16="http://schemas.microsoft.com/office/drawing/2014/main" id="{51C33901-95CA-49C9-5FDE-B7D1F71E5656}"/>
+                <a16:creationId xmlns:a16="http://schemas.microsoft.com/office/drawing/2014/main" id="{1311DC33-470D-A5A5-62E3-932A4CE181A6}"/>
               </a:ext>
             </a:extLst>
           </p:cNvPr>
@@ -9597,7 +10008,7 @@
           <p:cNvPr id="4" name="Table 3">
             <a:extLst>
               <a:ext uri="{FF2B5EF4-FFF2-40B4-BE49-F238E27FC236}">
-                <a16:creationId xmlns:a16="http://schemas.microsoft.com/office/drawing/2014/main" id="{FFF52EE4-0C73-8D57-0FA7-B57D22865EBB}"/>
+                <a16:creationId xmlns:a16="http://schemas.microsoft.com/office/drawing/2014/main" id="{6914666B-5373-ABB5-48AE-9C1AFCDF518B}"/>
               </a:ext>
             </a:extLst>
           </p:cNvPr>
@@ -9607,14 +10018,14 @@
           <p:nvPr>
             <p:extLst>
               <p:ext uri="{D42A27DB-BD31-4B8C-83A1-F6EECF244321}">
-                <p14:modId xmlns:p14="http://schemas.microsoft.com/office/powerpoint/2010/main" val="3643906519"/>
+                <p14:modId xmlns:p14="http://schemas.microsoft.com/office/powerpoint/2010/main" val="4131342732"/>
               </p:ext>
             </p:extLst>
           </p:nvPr>
         </p:nvGraphicFramePr>
         <p:xfrm>
           <a:off x="762000" y="1270000"/>
-          <a:ext cx="9906000" cy="3810000"/>
+          <a:ext cx="10160000" cy="3810000"/>
         </p:xfrm>
         <a:graphic>
           <a:graphicData uri="http://schemas.openxmlformats.org/drawingml/2006/table">
@@ -9626,21 +10037,21 @@
                 <a:gridCol w="3048000">
                   <a:extLst>
                     <a:ext uri="{9D8B030D-6E8A-4147-A177-3AD203B41FA5}">
-                      <a16:colId xmlns:a16="http://schemas.microsoft.com/office/drawing/2014/main" val="297792371"/>
+                      <a16:colId xmlns:a16="http://schemas.microsoft.com/office/drawing/2014/main" val="1644612992"/>
                     </a:ext>
                   </a:extLst>
                 </a:gridCol>
                 <a:gridCol w="4064000">
                   <a:extLst>
                     <a:ext uri="{9D8B030D-6E8A-4147-A177-3AD203B41FA5}">
-                      <a16:colId xmlns:a16="http://schemas.microsoft.com/office/drawing/2014/main" val="4114743019"/>
+                      <a16:colId xmlns:a16="http://schemas.microsoft.com/office/drawing/2014/main" val="3619534964"/>
                     </a:ext>
                   </a:extLst>
                 </a:gridCol>
-                <a:gridCol w="2794000">
+                <a:gridCol w="3048000">
                   <a:extLst>
                     <a:ext uri="{9D8B030D-6E8A-4147-A177-3AD203B41FA5}">
-                      <a16:colId xmlns:a16="http://schemas.microsoft.com/office/drawing/2014/main" val="1280209730"/>
+                      <a16:colId xmlns:a16="http://schemas.microsoft.com/office/drawing/2014/main" val="1293579040"/>
                     </a:ext>
                   </a:extLst>
                 </a:gridCol>
@@ -9714,7 +10125,7 @@
                 </a:tc>
                 <a:extLst>
                   <a:ext uri="{0D108BD9-81ED-4DB2-BD59-A6C34878D82A}">
-                    <a16:rowId xmlns:a16="http://schemas.microsoft.com/office/drawing/2014/main" val="281820522"/>
+                    <a16:rowId xmlns:a16="http://schemas.microsoft.com/office/drawing/2014/main" val="3258761252"/>
                   </a:ext>
                 </a:extLst>
               </a:tr>
@@ -9775,7 +10186,7 @@
                           </a:solidFill>
                           <a:latin typeface="Calibri" panose="020F0502020204030204" pitchFamily="34" charset="0"/>
                         </a:rPr>
-                        <a:t>277,880</a:t>
+                        <a:t>277,880 (both runs)</a:t>
                       </a:r>
                     </a:p>
                   </a:txBody>
@@ -9787,7 +10198,7 @@
                 </a:tc>
                 <a:extLst>
                   <a:ext uri="{0D108BD9-81ED-4DB2-BD59-A6C34878D82A}">
-                    <a16:rowId xmlns:a16="http://schemas.microsoft.com/office/drawing/2014/main" val="2715986792"/>
+                    <a16:rowId xmlns:a16="http://schemas.microsoft.com/office/drawing/2014/main" val="85862889"/>
                   </a:ext>
                 </a:extLst>
               </a:tr>
@@ -9848,7 +10259,7 @@
                 </a:tc>
                 <a:extLst>
                   <a:ext uri="{0D108BD9-81ED-4DB2-BD59-A6C34878D82A}">
-                    <a16:rowId xmlns:a16="http://schemas.microsoft.com/office/drawing/2014/main" val="2325718886"/>
+                    <a16:rowId xmlns:a16="http://schemas.microsoft.com/office/drawing/2014/main" val="1821477363"/>
                   </a:ext>
                 </a:extLst>
               </a:tr>
@@ -9921,7 +10332,7 @@
                 </a:tc>
                 <a:extLst>
                   <a:ext uri="{0D108BD9-81ED-4DB2-BD59-A6C34878D82A}">
-                    <a16:rowId xmlns:a16="http://schemas.microsoft.com/office/drawing/2014/main" val="2737868369"/>
+                    <a16:rowId xmlns:a16="http://schemas.microsoft.com/office/drawing/2014/main" val="1533255055"/>
                   </a:ext>
                 </a:extLst>
               </a:tr>
@@ -9982,7 +10393,7 @@
                 </a:tc>
                 <a:extLst>
                   <a:ext uri="{0D108BD9-81ED-4DB2-BD59-A6C34878D82A}">
-                    <a16:rowId xmlns:a16="http://schemas.microsoft.com/office/drawing/2014/main" val="2470780147"/>
+                    <a16:rowId xmlns:a16="http://schemas.microsoft.com/office/drawing/2014/main" val="1165232315"/>
                   </a:ext>
                 </a:extLst>
               </a:tr>
@@ -10055,7 +10466,68 @@
                 </a:tc>
                 <a:extLst>
                   <a:ext uri="{0D108BD9-81ED-4DB2-BD59-A6C34878D82A}">
-                    <a16:rowId xmlns:a16="http://schemas.microsoft.com/office/drawing/2014/main" val="126586238"/>
+                    <a16:rowId xmlns:a16="http://schemas.microsoft.com/office/drawing/2014/main" val="1254693046"/>
+                  </a:ext>
+                </a:extLst>
+              </a:tr>
+              <a:tr h="381000">
+                <a:tc>
+                  <a:txBody>
+                    <a:bodyPr/>
+                    <a:lstStyle/>
+                    <a:p>
+                      <a:r>
+                        <a:rPr lang="en-US" sz="1400">
+                          <a:solidFill>
+                            <a:srgbClr val="1F3864"/>
+                          </a:solidFill>
+                          <a:latin typeface="Calibri" panose="020F0502020204030204" pitchFamily="34" charset="0"/>
+                        </a:rPr>
+                        <a:t>Watermark after Run I / Run II</a:t>
+                      </a:r>
+                    </a:p>
+                  </a:txBody>
+                  <a:tcPr/>
+                </a:tc>
+                <a:tc>
+                  <a:txBody>
+                    <a:bodyPr/>
+                    <a:lstStyle/>
+                    <a:p>
+                      <a:r>
+                        <a:rPr lang="en-US" sz="1400">
+                          <a:solidFill>
+                            <a:srgbClr val="1F3864"/>
+                          </a:solidFill>
+                          <a:latin typeface="Calibri" panose="020F0502020204030204" pitchFamily="34" charset="0"/>
+                        </a:rPr>
+                        <a:t>12-30-2022 / 12-30-2026</a:t>
+                      </a:r>
+                    </a:p>
+                  </a:txBody>
+                  <a:tcPr/>
+                </a:tc>
+                <a:tc>
+                  <a:txBody>
+                    <a:bodyPr/>
+                    <a:lstStyle/>
+                    <a:p>
+                      <a:r>
+                        <a:rPr lang="en-US" sz="1400">
+                          <a:solidFill>
+                            <a:srgbClr val="1F3864"/>
+                          </a:solidFill>
+                          <a:latin typeface="Calibri" panose="020F0502020204030204" pitchFamily="34" charset="0"/>
+                        </a:rPr>
+                        <a:t>2022-12-30 / 2026-12-30</a:t>
+                      </a:r>
+                    </a:p>
+                  </a:txBody>
+                  <a:tcPr/>
+                </a:tc>
+                <a:extLst>
+                  <a:ext uri="{0D108BD9-81ED-4DB2-BD59-A6C34878D82A}">
+                    <a16:rowId xmlns:a16="http://schemas.microsoft.com/office/drawing/2014/main" val="803324762"/>
                   </a:ext>
                 </a:extLst>
               </a:tr>
@@ -10068,7 +10540,7 @@
           <p:cNvPr id="5" name="TextBox 4">
             <a:extLst>
               <a:ext uri="{FF2B5EF4-FFF2-40B4-BE49-F238E27FC236}">
-                <a16:creationId xmlns:a16="http://schemas.microsoft.com/office/drawing/2014/main" id="{CF1CCA43-D5F5-8488-6E26-604AD1E395D3}"/>
+                <a16:creationId xmlns:a16="http://schemas.microsoft.com/office/drawing/2014/main" id="{9C4240B4-931E-1E5D-0A6C-39AB306963B9}"/>
               </a:ext>
             </a:extLst>
           </p:cNvPr>
@@ -10077,7 +10549,7 @@
         </p:nvSpPr>
         <p:spPr>
           <a:xfrm>
-            <a:off x="762000" y="4572000"/>
+            <a:off x="762000" y="4826000"/>
             <a:ext cx="10668000" cy="1077218"/>
           </a:xfrm>
           <a:prstGeom prst="rect">
@@ -10098,7 +10570,7 @@
                 </a:solidFill>
                 <a:latin typeface="Calibri" panose="020F0502020204030204" pitchFamily="34" charset="0"/>
               </a:rPr>
-              <a:t>Full run exits DTSER_SUCCESS (0); DTExec reports CLEAN_RUN_EXIT=0</a:t>
+              <a:t>Run I (InitialLoad=True, CurrentJobTime=12-30-2022): exit 0, full rebuild, 277,880 fact rows</a:t>
             </a:r>
             <a:br>
               <a:rPr lang="en-US" sz="1600">
@@ -10115,7 +10587,7 @@
                 </a:solidFill>
                 <a:latin typeface="Calibri" panose="020F0502020204030204" pitchFamily="34" charset="0"/>
               </a:rPr>
-              <a:t>Incremental run exits 0 and leaves all row counts unchanged</a:t>
+              <a:t>Run II (InitialLoad=False, CurrentJobTime=12-30-2026): exit 0, increment empty, counts unchanged</a:t>
             </a:r>
             <a:br>
               <a:rPr lang="en-US" sz="1600">
@@ -10132,7 +10604,7 @@
                 </a:solidFill>
                 <a:latin typeface="Calibri" panose="020F0502020204030204" pitchFamily="34" charset="0"/>
               </a:rPr>
-              <a:t>Watermark advances to the job's run time after each successful run</a:t>
+              <a:t>OLTP vs OLAP queries: 432/432 rows equal, 0 numeric mismatches (TotalSales, GrossSales, discounts, ratios)</a:t>
             </a:r>
             <a:br>
               <a:rPr lang="en-US" sz="1600">
@@ -10157,7 +10629,7 @@
     </p:spTree>
     <p:extLst>
       <p:ext uri="{BB962C8B-B14F-4D97-AF65-F5344CB8AC3E}">
-        <p14:creationId xmlns:p14="http://schemas.microsoft.com/office/powerpoint/2010/main" val="149248261"/>
+        <p14:creationId xmlns:p14="http://schemas.microsoft.com/office/powerpoint/2010/main" val="3467930178"/>
       </p:ext>
     </p:extLst>
   </p:cSld>

</xml_diff>

<commit_message>
Fix incremental reference staging + category mapping; verify OLTP vs OLAP equality (842/842, 0 mismatches); add V2 simulation, final DW backup, deck, submission zip
</commit_message>
<xml_diff>
--- a/Docs/AdventureWorks_ETL_Presentation.pptx
+++ b/Docs/AdventureWorks_ETL_Presentation.pptx
@@ -142,7 +142,7 @@
           <p:cNvPr id="2" name="Title 1">
             <a:extLst>
               <a:ext uri="{FF2B5EF4-FFF2-40B4-BE49-F238E27FC236}">
-                <a16:creationId xmlns:a16="http://schemas.microsoft.com/office/drawing/2014/main" id="{7A922292-210A-22C6-D3BD-1FF5071F0E6B}"/>
+                <a16:creationId xmlns:a16="http://schemas.microsoft.com/office/drawing/2014/main" id="{A07BCF48-58BF-1CF9-80A0-5A7C3A06D6D6}"/>
               </a:ext>
             </a:extLst>
           </p:cNvPr>
@@ -179,7 +179,7 @@
           <p:cNvPr id="3" name="Subtitle 2">
             <a:extLst>
               <a:ext uri="{FF2B5EF4-FFF2-40B4-BE49-F238E27FC236}">
-                <a16:creationId xmlns:a16="http://schemas.microsoft.com/office/drawing/2014/main" id="{2BA4A99F-17DC-F3F4-4217-42A27368845A}"/>
+                <a16:creationId xmlns:a16="http://schemas.microsoft.com/office/drawing/2014/main" id="{8BBDB42D-FA1F-1387-304F-D8F9FB601F36}"/>
               </a:ext>
             </a:extLst>
           </p:cNvPr>
@@ -249,7 +249,7 @@
           <p:cNvPr id="4" name="Date Placeholder 3">
             <a:extLst>
               <a:ext uri="{FF2B5EF4-FFF2-40B4-BE49-F238E27FC236}">
-                <a16:creationId xmlns:a16="http://schemas.microsoft.com/office/drawing/2014/main" id="{B5634EBF-BC79-CEC9-6434-03CE2052196D}"/>
+                <a16:creationId xmlns:a16="http://schemas.microsoft.com/office/drawing/2014/main" id="{5F2FF013-3B79-36AA-3577-B347BB5817C9}"/>
               </a:ext>
             </a:extLst>
           </p:cNvPr>
@@ -265,7 +265,7 @@
           <a:bodyPr/>
           <a:lstStyle/>
           <a:p>
-            <a:fld id="{7D1867BF-27E9-4E78-B03E-D1C72F0D04A0}" type="datetimeFigureOut">
+            <a:fld id="{6FC9DE57-2506-4C28-8EDA-5571E5021991}" type="datetimeFigureOut">
               <a:rPr lang="en-US" smtClean="0"/>
               <a:t>8/2/2026</a:t>
             </a:fld>
@@ -278,7 +278,7 @@
           <p:cNvPr id="5" name="Footer Placeholder 4">
             <a:extLst>
               <a:ext uri="{FF2B5EF4-FFF2-40B4-BE49-F238E27FC236}">
-                <a16:creationId xmlns:a16="http://schemas.microsoft.com/office/drawing/2014/main" id="{1BE1158A-E68C-8B2B-6E89-C533AD9ED794}"/>
+                <a16:creationId xmlns:a16="http://schemas.microsoft.com/office/drawing/2014/main" id="{44602EC8-6661-F9C3-217E-5BDEF066526F}"/>
               </a:ext>
             </a:extLst>
           </p:cNvPr>
@@ -303,7 +303,7 @@
           <p:cNvPr id="6" name="Slide Number Placeholder 5">
             <a:extLst>
               <a:ext uri="{FF2B5EF4-FFF2-40B4-BE49-F238E27FC236}">
-                <a16:creationId xmlns:a16="http://schemas.microsoft.com/office/drawing/2014/main" id="{8DE891DA-7406-86D1-F3E2-1FFD9BCE431D}"/>
+                <a16:creationId xmlns:a16="http://schemas.microsoft.com/office/drawing/2014/main" id="{1B54759A-CD3C-23C6-B790-6DD00EEFBEC1}"/>
               </a:ext>
             </a:extLst>
           </p:cNvPr>
@@ -319,7 +319,7 @@
           <a:bodyPr/>
           <a:lstStyle/>
           <a:p>
-            <a:fld id="{B08209FF-819D-43A2-97A4-6C4DDC35B4FA}" type="slidenum">
+            <a:fld id="{12A3504B-58D0-4D3A-B128-779D24249411}" type="slidenum">
               <a:rPr lang="en-US" smtClean="0"/>
               <a:t>‹#›</a:t>
             </a:fld>
@@ -330,7 +330,7 @@
     </p:spTree>
     <p:extLst>
       <p:ext uri="{BB962C8B-B14F-4D97-AF65-F5344CB8AC3E}">
-        <p14:creationId xmlns:p14="http://schemas.microsoft.com/office/powerpoint/2010/main" val="1398870731"/>
+        <p14:creationId xmlns:p14="http://schemas.microsoft.com/office/powerpoint/2010/main" val="4046494424"/>
       </p:ext>
     </p:extLst>
   </p:cSld>
@@ -362,7 +362,7 @@
           <p:cNvPr id="2" name="Title 1">
             <a:extLst>
               <a:ext uri="{FF2B5EF4-FFF2-40B4-BE49-F238E27FC236}">
-                <a16:creationId xmlns:a16="http://schemas.microsoft.com/office/drawing/2014/main" id="{DBD0BEF4-59F6-37A6-B23F-2F91D57ABFE3}"/>
+                <a16:creationId xmlns:a16="http://schemas.microsoft.com/office/drawing/2014/main" id="{E9A0EE5A-B5B8-A1E5-09D0-FF84D7930597}"/>
               </a:ext>
             </a:extLst>
           </p:cNvPr>
@@ -390,7 +390,7 @@
           <p:cNvPr id="3" name="Vertical Text Placeholder 2">
             <a:extLst>
               <a:ext uri="{FF2B5EF4-FFF2-40B4-BE49-F238E27FC236}">
-                <a16:creationId xmlns:a16="http://schemas.microsoft.com/office/drawing/2014/main" id="{0D54E877-0EAA-733F-5180-F53E9FBFAFEA}"/>
+                <a16:creationId xmlns:a16="http://schemas.microsoft.com/office/drawing/2014/main" id="{7808DAF0-7DA9-16DE-87DC-A6EF760DA8AA}"/>
               </a:ext>
             </a:extLst>
           </p:cNvPr>
@@ -447,7 +447,7 @@
           <p:cNvPr id="4" name="Date Placeholder 3">
             <a:extLst>
               <a:ext uri="{FF2B5EF4-FFF2-40B4-BE49-F238E27FC236}">
-                <a16:creationId xmlns:a16="http://schemas.microsoft.com/office/drawing/2014/main" id="{4FE8F267-54C8-E403-7D8D-C0B7A868E050}"/>
+                <a16:creationId xmlns:a16="http://schemas.microsoft.com/office/drawing/2014/main" id="{32FE73A2-F2A1-C44B-AF6D-FC8683004455}"/>
               </a:ext>
             </a:extLst>
           </p:cNvPr>
@@ -463,7 +463,7 @@
           <a:bodyPr/>
           <a:lstStyle/>
           <a:p>
-            <a:fld id="{7D1867BF-27E9-4E78-B03E-D1C72F0D04A0}" type="datetimeFigureOut">
+            <a:fld id="{6FC9DE57-2506-4C28-8EDA-5571E5021991}" type="datetimeFigureOut">
               <a:rPr lang="en-US" smtClean="0"/>
               <a:t>8/2/2026</a:t>
             </a:fld>
@@ -476,7 +476,7 @@
           <p:cNvPr id="5" name="Footer Placeholder 4">
             <a:extLst>
               <a:ext uri="{FF2B5EF4-FFF2-40B4-BE49-F238E27FC236}">
-                <a16:creationId xmlns:a16="http://schemas.microsoft.com/office/drawing/2014/main" id="{3BF5D561-28DF-B1B2-2166-2E8DDEB88FF4}"/>
+                <a16:creationId xmlns:a16="http://schemas.microsoft.com/office/drawing/2014/main" id="{DA518C31-9DCC-48D2-B9BC-D95F2A94673C}"/>
               </a:ext>
             </a:extLst>
           </p:cNvPr>
@@ -501,7 +501,7 @@
           <p:cNvPr id="6" name="Slide Number Placeholder 5">
             <a:extLst>
               <a:ext uri="{FF2B5EF4-FFF2-40B4-BE49-F238E27FC236}">
-                <a16:creationId xmlns:a16="http://schemas.microsoft.com/office/drawing/2014/main" id="{04980CC4-3007-DB6E-0F15-04644B29180D}"/>
+                <a16:creationId xmlns:a16="http://schemas.microsoft.com/office/drawing/2014/main" id="{5B2F8E05-316A-C483-255A-0FAA42FA0E6E}"/>
               </a:ext>
             </a:extLst>
           </p:cNvPr>
@@ -517,7 +517,7 @@
           <a:bodyPr/>
           <a:lstStyle/>
           <a:p>
-            <a:fld id="{B08209FF-819D-43A2-97A4-6C4DDC35B4FA}" type="slidenum">
+            <a:fld id="{12A3504B-58D0-4D3A-B128-779D24249411}" type="slidenum">
               <a:rPr lang="en-US" smtClean="0"/>
               <a:t>‹#›</a:t>
             </a:fld>
@@ -528,7 +528,7 @@
     </p:spTree>
     <p:extLst>
       <p:ext uri="{BB962C8B-B14F-4D97-AF65-F5344CB8AC3E}">
-        <p14:creationId xmlns:p14="http://schemas.microsoft.com/office/powerpoint/2010/main" val="3105608387"/>
+        <p14:creationId xmlns:p14="http://schemas.microsoft.com/office/powerpoint/2010/main" val="2591065882"/>
       </p:ext>
     </p:extLst>
   </p:cSld>
@@ -560,7 +560,7 @@
           <p:cNvPr id="2" name="Vertical Title 1">
             <a:extLst>
               <a:ext uri="{FF2B5EF4-FFF2-40B4-BE49-F238E27FC236}">
-                <a16:creationId xmlns:a16="http://schemas.microsoft.com/office/drawing/2014/main" id="{9A4DD5EF-3EF8-8BCF-D88C-EA88462F02A9}"/>
+                <a16:creationId xmlns:a16="http://schemas.microsoft.com/office/drawing/2014/main" id="{5E3C15A3-91A2-BB26-3919-A58BC3706715}"/>
               </a:ext>
             </a:extLst>
           </p:cNvPr>
@@ -593,7 +593,7 @@
           <p:cNvPr id="3" name="Vertical Text Placeholder 2">
             <a:extLst>
               <a:ext uri="{FF2B5EF4-FFF2-40B4-BE49-F238E27FC236}">
-                <a16:creationId xmlns:a16="http://schemas.microsoft.com/office/drawing/2014/main" id="{089866F8-A0F0-1AFE-F333-58E0BAFECF1C}"/>
+                <a16:creationId xmlns:a16="http://schemas.microsoft.com/office/drawing/2014/main" id="{68B15525-0639-0006-6844-E90FE7AC5C7F}"/>
               </a:ext>
             </a:extLst>
           </p:cNvPr>
@@ -655,7 +655,7 @@
           <p:cNvPr id="4" name="Date Placeholder 3">
             <a:extLst>
               <a:ext uri="{FF2B5EF4-FFF2-40B4-BE49-F238E27FC236}">
-                <a16:creationId xmlns:a16="http://schemas.microsoft.com/office/drawing/2014/main" id="{534B2CEF-DBA1-B52F-1D1E-33A3D2ADE929}"/>
+                <a16:creationId xmlns:a16="http://schemas.microsoft.com/office/drawing/2014/main" id="{35D78C5F-EA30-214A-AB56-FE46E845C100}"/>
               </a:ext>
             </a:extLst>
           </p:cNvPr>
@@ -671,7 +671,7 @@
           <a:bodyPr/>
           <a:lstStyle/>
           <a:p>
-            <a:fld id="{7D1867BF-27E9-4E78-B03E-D1C72F0D04A0}" type="datetimeFigureOut">
+            <a:fld id="{6FC9DE57-2506-4C28-8EDA-5571E5021991}" type="datetimeFigureOut">
               <a:rPr lang="en-US" smtClean="0"/>
               <a:t>8/2/2026</a:t>
             </a:fld>
@@ -684,7 +684,7 @@
           <p:cNvPr id="5" name="Footer Placeholder 4">
             <a:extLst>
               <a:ext uri="{FF2B5EF4-FFF2-40B4-BE49-F238E27FC236}">
-                <a16:creationId xmlns:a16="http://schemas.microsoft.com/office/drawing/2014/main" id="{BD734B09-6291-221E-8A38-8C06312F7E50}"/>
+                <a16:creationId xmlns:a16="http://schemas.microsoft.com/office/drawing/2014/main" id="{E123B5A7-F0F2-BFB1-4E23-941152F2EF50}"/>
               </a:ext>
             </a:extLst>
           </p:cNvPr>
@@ -709,7 +709,7 @@
           <p:cNvPr id="6" name="Slide Number Placeholder 5">
             <a:extLst>
               <a:ext uri="{FF2B5EF4-FFF2-40B4-BE49-F238E27FC236}">
-                <a16:creationId xmlns:a16="http://schemas.microsoft.com/office/drawing/2014/main" id="{475934B3-F396-89A6-D941-DEEE6C0F50C2}"/>
+                <a16:creationId xmlns:a16="http://schemas.microsoft.com/office/drawing/2014/main" id="{287E22B6-14C4-6EE8-2699-A412C5679ED3}"/>
               </a:ext>
             </a:extLst>
           </p:cNvPr>
@@ -725,7 +725,7 @@
           <a:bodyPr/>
           <a:lstStyle/>
           <a:p>
-            <a:fld id="{B08209FF-819D-43A2-97A4-6C4DDC35B4FA}" type="slidenum">
+            <a:fld id="{12A3504B-58D0-4D3A-B128-779D24249411}" type="slidenum">
               <a:rPr lang="en-US" smtClean="0"/>
               <a:t>‹#›</a:t>
             </a:fld>
@@ -736,7 +736,7 @@
     </p:spTree>
     <p:extLst>
       <p:ext uri="{BB962C8B-B14F-4D97-AF65-F5344CB8AC3E}">
-        <p14:creationId xmlns:p14="http://schemas.microsoft.com/office/powerpoint/2010/main" val="1890036477"/>
+        <p14:creationId xmlns:p14="http://schemas.microsoft.com/office/powerpoint/2010/main" val="401391975"/>
       </p:ext>
     </p:extLst>
   </p:cSld>
@@ -768,7 +768,7 @@
           <p:cNvPr id="2" name="Title 1">
             <a:extLst>
               <a:ext uri="{FF2B5EF4-FFF2-40B4-BE49-F238E27FC236}">
-                <a16:creationId xmlns:a16="http://schemas.microsoft.com/office/drawing/2014/main" id="{FEE77A9A-3331-8887-BD9D-163BAB5C7124}"/>
+                <a16:creationId xmlns:a16="http://schemas.microsoft.com/office/drawing/2014/main" id="{599C58CA-B16F-2EB2-2A1A-0B7E7F153761}"/>
               </a:ext>
             </a:extLst>
           </p:cNvPr>
@@ -796,7 +796,7 @@
           <p:cNvPr id="3" name="Content Placeholder 2">
             <a:extLst>
               <a:ext uri="{FF2B5EF4-FFF2-40B4-BE49-F238E27FC236}">
-                <a16:creationId xmlns:a16="http://schemas.microsoft.com/office/drawing/2014/main" id="{5ADEC16D-AA79-CEEE-F3EA-76CC8FC95018}"/>
+                <a16:creationId xmlns:a16="http://schemas.microsoft.com/office/drawing/2014/main" id="{8EA67AAA-CE81-56C7-E3CA-6DF27562FECB}"/>
               </a:ext>
             </a:extLst>
           </p:cNvPr>
@@ -853,7 +853,7 @@
           <p:cNvPr id="4" name="Date Placeholder 3">
             <a:extLst>
               <a:ext uri="{FF2B5EF4-FFF2-40B4-BE49-F238E27FC236}">
-                <a16:creationId xmlns:a16="http://schemas.microsoft.com/office/drawing/2014/main" id="{173271F5-F0C7-E53C-CF7D-85F06D672448}"/>
+                <a16:creationId xmlns:a16="http://schemas.microsoft.com/office/drawing/2014/main" id="{716F894E-AA82-AC2F-7CBB-F23BB3E4C582}"/>
               </a:ext>
             </a:extLst>
           </p:cNvPr>
@@ -869,7 +869,7 @@
           <a:bodyPr/>
           <a:lstStyle/>
           <a:p>
-            <a:fld id="{7D1867BF-27E9-4E78-B03E-D1C72F0D04A0}" type="datetimeFigureOut">
+            <a:fld id="{6FC9DE57-2506-4C28-8EDA-5571E5021991}" type="datetimeFigureOut">
               <a:rPr lang="en-US" smtClean="0"/>
               <a:t>8/2/2026</a:t>
             </a:fld>
@@ -882,7 +882,7 @@
           <p:cNvPr id="5" name="Footer Placeholder 4">
             <a:extLst>
               <a:ext uri="{FF2B5EF4-FFF2-40B4-BE49-F238E27FC236}">
-                <a16:creationId xmlns:a16="http://schemas.microsoft.com/office/drawing/2014/main" id="{A1A5DFA8-1756-E78D-55DD-2FB84321F1C7}"/>
+                <a16:creationId xmlns:a16="http://schemas.microsoft.com/office/drawing/2014/main" id="{69A5EBC5-9DB3-BC23-01EB-917C44DB2D3A}"/>
               </a:ext>
             </a:extLst>
           </p:cNvPr>
@@ -907,7 +907,7 @@
           <p:cNvPr id="6" name="Slide Number Placeholder 5">
             <a:extLst>
               <a:ext uri="{FF2B5EF4-FFF2-40B4-BE49-F238E27FC236}">
-                <a16:creationId xmlns:a16="http://schemas.microsoft.com/office/drawing/2014/main" id="{96CCC861-22B6-ED9B-E225-5BC4B9773125}"/>
+                <a16:creationId xmlns:a16="http://schemas.microsoft.com/office/drawing/2014/main" id="{80E1389D-6194-1010-AC6F-498A46E8FA7E}"/>
               </a:ext>
             </a:extLst>
           </p:cNvPr>
@@ -923,7 +923,7 @@
           <a:bodyPr/>
           <a:lstStyle/>
           <a:p>
-            <a:fld id="{B08209FF-819D-43A2-97A4-6C4DDC35B4FA}" type="slidenum">
+            <a:fld id="{12A3504B-58D0-4D3A-B128-779D24249411}" type="slidenum">
               <a:rPr lang="en-US" smtClean="0"/>
               <a:t>‹#›</a:t>
             </a:fld>
@@ -934,7 +934,7 @@
     </p:spTree>
     <p:extLst>
       <p:ext uri="{BB962C8B-B14F-4D97-AF65-F5344CB8AC3E}">
-        <p14:creationId xmlns:p14="http://schemas.microsoft.com/office/powerpoint/2010/main" val="459064832"/>
+        <p14:creationId xmlns:p14="http://schemas.microsoft.com/office/powerpoint/2010/main" val="3737861388"/>
       </p:ext>
     </p:extLst>
   </p:cSld>
@@ -966,7 +966,7 @@
           <p:cNvPr id="2" name="Title 1">
             <a:extLst>
               <a:ext uri="{FF2B5EF4-FFF2-40B4-BE49-F238E27FC236}">
-                <a16:creationId xmlns:a16="http://schemas.microsoft.com/office/drawing/2014/main" id="{92602320-9F5C-2C1F-00FF-C6B1FE8CF7ED}"/>
+                <a16:creationId xmlns:a16="http://schemas.microsoft.com/office/drawing/2014/main" id="{80363A0B-0AC1-DD1D-B8F0-C9ACDAAC469D}"/>
               </a:ext>
             </a:extLst>
           </p:cNvPr>
@@ -1003,7 +1003,7 @@
           <p:cNvPr id="3" name="Text Placeholder 2">
             <a:extLst>
               <a:ext uri="{FF2B5EF4-FFF2-40B4-BE49-F238E27FC236}">
-                <a16:creationId xmlns:a16="http://schemas.microsoft.com/office/drawing/2014/main" id="{EF5D926E-9781-D4DC-5AE2-7029694B51D6}"/>
+                <a16:creationId xmlns:a16="http://schemas.microsoft.com/office/drawing/2014/main" id="{BEA107D4-FA77-A85A-A13C-8DE68D905FF4}"/>
               </a:ext>
             </a:extLst>
           </p:cNvPr>
@@ -1128,7 +1128,7 @@
           <p:cNvPr id="4" name="Date Placeholder 3">
             <a:extLst>
               <a:ext uri="{FF2B5EF4-FFF2-40B4-BE49-F238E27FC236}">
-                <a16:creationId xmlns:a16="http://schemas.microsoft.com/office/drawing/2014/main" id="{07D11796-3DBF-45C1-7EC6-A5D908D569EF}"/>
+                <a16:creationId xmlns:a16="http://schemas.microsoft.com/office/drawing/2014/main" id="{DAA3FA71-FEF3-F1F8-D84A-28F1B08F2F65}"/>
               </a:ext>
             </a:extLst>
           </p:cNvPr>
@@ -1144,7 +1144,7 @@
           <a:bodyPr/>
           <a:lstStyle/>
           <a:p>
-            <a:fld id="{7D1867BF-27E9-4E78-B03E-D1C72F0D04A0}" type="datetimeFigureOut">
+            <a:fld id="{6FC9DE57-2506-4C28-8EDA-5571E5021991}" type="datetimeFigureOut">
               <a:rPr lang="en-US" smtClean="0"/>
               <a:t>8/2/2026</a:t>
             </a:fld>
@@ -1157,7 +1157,7 @@
           <p:cNvPr id="5" name="Footer Placeholder 4">
             <a:extLst>
               <a:ext uri="{FF2B5EF4-FFF2-40B4-BE49-F238E27FC236}">
-                <a16:creationId xmlns:a16="http://schemas.microsoft.com/office/drawing/2014/main" id="{E9068F4A-E0F5-6955-58C0-7CA1A95EC7D3}"/>
+                <a16:creationId xmlns:a16="http://schemas.microsoft.com/office/drawing/2014/main" id="{1CB1606B-5083-1FF0-0910-AEFC6B356528}"/>
               </a:ext>
             </a:extLst>
           </p:cNvPr>
@@ -1182,7 +1182,7 @@
           <p:cNvPr id="6" name="Slide Number Placeholder 5">
             <a:extLst>
               <a:ext uri="{FF2B5EF4-FFF2-40B4-BE49-F238E27FC236}">
-                <a16:creationId xmlns:a16="http://schemas.microsoft.com/office/drawing/2014/main" id="{7B86A716-8AD7-D83D-D3AD-531E71132212}"/>
+                <a16:creationId xmlns:a16="http://schemas.microsoft.com/office/drawing/2014/main" id="{DFD5467C-5875-C22E-37EA-479491935EDF}"/>
               </a:ext>
             </a:extLst>
           </p:cNvPr>
@@ -1198,7 +1198,7 @@
           <a:bodyPr/>
           <a:lstStyle/>
           <a:p>
-            <a:fld id="{B08209FF-819D-43A2-97A4-6C4DDC35B4FA}" type="slidenum">
+            <a:fld id="{12A3504B-58D0-4D3A-B128-779D24249411}" type="slidenum">
               <a:rPr lang="en-US" smtClean="0"/>
               <a:t>‹#›</a:t>
             </a:fld>
@@ -1209,7 +1209,7 @@
     </p:spTree>
     <p:extLst>
       <p:ext uri="{BB962C8B-B14F-4D97-AF65-F5344CB8AC3E}">
-        <p14:creationId xmlns:p14="http://schemas.microsoft.com/office/powerpoint/2010/main" val="3198805694"/>
+        <p14:creationId xmlns:p14="http://schemas.microsoft.com/office/powerpoint/2010/main" val="2168156441"/>
       </p:ext>
     </p:extLst>
   </p:cSld>
@@ -1241,7 +1241,7 @@
           <p:cNvPr id="2" name="Title 1">
             <a:extLst>
               <a:ext uri="{FF2B5EF4-FFF2-40B4-BE49-F238E27FC236}">
-                <a16:creationId xmlns:a16="http://schemas.microsoft.com/office/drawing/2014/main" id="{DB62B601-B9AE-1F18-28E1-6BD5708A90CC}"/>
+                <a16:creationId xmlns:a16="http://schemas.microsoft.com/office/drawing/2014/main" id="{A6B27C56-C17F-5E6D-9C62-906EEBACD526}"/>
               </a:ext>
             </a:extLst>
           </p:cNvPr>
@@ -1269,7 +1269,7 @@
           <p:cNvPr id="3" name="Content Placeholder 2">
             <a:extLst>
               <a:ext uri="{FF2B5EF4-FFF2-40B4-BE49-F238E27FC236}">
-                <a16:creationId xmlns:a16="http://schemas.microsoft.com/office/drawing/2014/main" id="{1A9F63FA-B229-74C8-7103-E508C8403E95}"/>
+                <a16:creationId xmlns:a16="http://schemas.microsoft.com/office/drawing/2014/main" id="{2B11E8DE-115D-C09B-366B-5CB58FA6868B}"/>
               </a:ext>
             </a:extLst>
           </p:cNvPr>
@@ -1331,7 +1331,7 @@
           <p:cNvPr id="4" name="Content Placeholder 3">
             <a:extLst>
               <a:ext uri="{FF2B5EF4-FFF2-40B4-BE49-F238E27FC236}">
-                <a16:creationId xmlns:a16="http://schemas.microsoft.com/office/drawing/2014/main" id="{F3023DA2-8A6E-8BF5-BEF2-00413897EA79}"/>
+                <a16:creationId xmlns:a16="http://schemas.microsoft.com/office/drawing/2014/main" id="{F92E070F-2EAE-2784-A9C3-8B3B093C4195}"/>
               </a:ext>
             </a:extLst>
           </p:cNvPr>
@@ -1393,7 +1393,7 @@
           <p:cNvPr id="5" name="Date Placeholder 4">
             <a:extLst>
               <a:ext uri="{FF2B5EF4-FFF2-40B4-BE49-F238E27FC236}">
-                <a16:creationId xmlns:a16="http://schemas.microsoft.com/office/drawing/2014/main" id="{A9487EEF-16D6-E34B-4BC6-8BC5E77AA2AA}"/>
+                <a16:creationId xmlns:a16="http://schemas.microsoft.com/office/drawing/2014/main" id="{0F938661-11D3-F145-8F2F-2804102D8BFE}"/>
               </a:ext>
             </a:extLst>
           </p:cNvPr>
@@ -1409,7 +1409,7 @@
           <a:bodyPr/>
           <a:lstStyle/>
           <a:p>
-            <a:fld id="{7D1867BF-27E9-4E78-B03E-D1C72F0D04A0}" type="datetimeFigureOut">
+            <a:fld id="{6FC9DE57-2506-4C28-8EDA-5571E5021991}" type="datetimeFigureOut">
               <a:rPr lang="en-US" smtClean="0"/>
               <a:t>8/2/2026</a:t>
             </a:fld>
@@ -1422,7 +1422,7 @@
           <p:cNvPr id="6" name="Footer Placeholder 5">
             <a:extLst>
               <a:ext uri="{FF2B5EF4-FFF2-40B4-BE49-F238E27FC236}">
-                <a16:creationId xmlns:a16="http://schemas.microsoft.com/office/drawing/2014/main" id="{70BA9B7D-4CAD-77F0-6DD5-693D535700CE}"/>
+                <a16:creationId xmlns:a16="http://schemas.microsoft.com/office/drawing/2014/main" id="{425583CD-6F4A-2650-6CB2-A455FEAC01EB}"/>
               </a:ext>
             </a:extLst>
           </p:cNvPr>
@@ -1447,7 +1447,7 @@
           <p:cNvPr id="7" name="Slide Number Placeholder 6">
             <a:extLst>
               <a:ext uri="{FF2B5EF4-FFF2-40B4-BE49-F238E27FC236}">
-                <a16:creationId xmlns:a16="http://schemas.microsoft.com/office/drawing/2014/main" id="{D09C9711-1FAE-554A-F092-66F498AAFEFF}"/>
+                <a16:creationId xmlns:a16="http://schemas.microsoft.com/office/drawing/2014/main" id="{0A1EE310-1734-3943-3D6B-CCAE887BD04D}"/>
               </a:ext>
             </a:extLst>
           </p:cNvPr>
@@ -1463,7 +1463,7 @@
           <a:bodyPr/>
           <a:lstStyle/>
           <a:p>
-            <a:fld id="{B08209FF-819D-43A2-97A4-6C4DDC35B4FA}" type="slidenum">
+            <a:fld id="{12A3504B-58D0-4D3A-B128-779D24249411}" type="slidenum">
               <a:rPr lang="en-US" smtClean="0"/>
               <a:t>‹#›</a:t>
             </a:fld>
@@ -1474,7 +1474,7 @@
     </p:spTree>
     <p:extLst>
       <p:ext uri="{BB962C8B-B14F-4D97-AF65-F5344CB8AC3E}">
-        <p14:creationId xmlns:p14="http://schemas.microsoft.com/office/powerpoint/2010/main" val="4071765513"/>
+        <p14:creationId xmlns:p14="http://schemas.microsoft.com/office/powerpoint/2010/main" val="2965698499"/>
       </p:ext>
     </p:extLst>
   </p:cSld>
@@ -1506,7 +1506,7 @@
           <p:cNvPr id="2" name="Title 1">
             <a:extLst>
               <a:ext uri="{FF2B5EF4-FFF2-40B4-BE49-F238E27FC236}">
-                <a16:creationId xmlns:a16="http://schemas.microsoft.com/office/drawing/2014/main" id="{079CC26A-D250-5E5F-5EB3-FBCFB66B893D}"/>
+                <a16:creationId xmlns:a16="http://schemas.microsoft.com/office/drawing/2014/main" id="{0BC84F3F-547F-7720-928D-DB05DB3FD10D}"/>
               </a:ext>
             </a:extLst>
           </p:cNvPr>
@@ -1539,7 +1539,7 @@
           <p:cNvPr id="3" name="Text Placeholder 2">
             <a:extLst>
               <a:ext uri="{FF2B5EF4-FFF2-40B4-BE49-F238E27FC236}">
-                <a16:creationId xmlns:a16="http://schemas.microsoft.com/office/drawing/2014/main" id="{91F8107F-3F2F-EDF9-2587-9046EF05697A}"/>
+                <a16:creationId xmlns:a16="http://schemas.microsoft.com/office/drawing/2014/main" id="{58D39411-7DA1-BC53-A2CE-58B177A024B1}"/>
               </a:ext>
             </a:extLst>
           </p:cNvPr>
@@ -1610,7 +1610,7 @@
           <p:cNvPr id="4" name="Content Placeholder 3">
             <a:extLst>
               <a:ext uri="{FF2B5EF4-FFF2-40B4-BE49-F238E27FC236}">
-                <a16:creationId xmlns:a16="http://schemas.microsoft.com/office/drawing/2014/main" id="{0AA1BC83-C662-3D28-6C83-866BB5A946D7}"/>
+                <a16:creationId xmlns:a16="http://schemas.microsoft.com/office/drawing/2014/main" id="{00DA7564-C1CA-C526-A423-17F97965C28D}"/>
               </a:ext>
             </a:extLst>
           </p:cNvPr>
@@ -1672,7 +1672,7 @@
           <p:cNvPr id="5" name="Text Placeholder 4">
             <a:extLst>
               <a:ext uri="{FF2B5EF4-FFF2-40B4-BE49-F238E27FC236}">
-                <a16:creationId xmlns:a16="http://schemas.microsoft.com/office/drawing/2014/main" id="{714906E5-CA5F-38DE-2243-E1A66106B758}"/>
+                <a16:creationId xmlns:a16="http://schemas.microsoft.com/office/drawing/2014/main" id="{70D0BA65-4D7B-A8C3-9FAB-9A06E1F50CED}"/>
               </a:ext>
             </a:extLst>
           </p:cNvPr>
@@ -1743,7 +1743,7 @@
           <p:cNvPr id="6" name="Content Placeholder 5">
             <a:extLst>
               <a:ext uri="{FF2B5EF4-FFF2-40B4-BE49-F238E27FC236}">
-                <a16:creationId xmlns:a16="http://schemas.microsoft.com/office/drawing/2014/main" id="{9431FF3B-AAAA-464B-B8E6-C79318FC020F}"/>
+                <a16:creationId xmlns:a16="http://schemas.microsoft.com/office/drawing/2014/main" id="{08048A0A-8BA4-6622-13E8-F1B215154363}"/>
               </a:ext>
             </a:extLst>
           </p:cNvPr>
@@ -1805,7 +1805,7 @@
           <p:cNvPr id="7" name="Date Placeholder 6">
             <a:extLst>
               <a:ext uri="{FF2B5EF4-FFF2-40B4-BE49-F238E27FC236}">
-                <a16:creationId xmlns:a16="http://schemas.microsoft.com/office/drawing/2014/main" id="{246202D9-7FD3-FD76-D6AC-61B83B069A7C}"/>
+                <a16:creationId xmlns:a16="http://schemas.microsoft.com/office/drawing/2014/main" id="{68DF2F58-8CA6-9F21-24CF-4442A4FDE2CD}"/>
               </a:ext>
             </a:extLst>
           </p:cNvPr>
@@ -1821,7 +1821,7 @@
           <a:bodyPr/>
           <a:lstStyle/>
           <a:p>
-            <a:fld id="{7D1867BF-27E9-4E78-B03E-D1C72F0D04A0}" type="datetimeFigureOut">
+            <a:fld id="{6FC9DE57-2506-4C28-8EDA-5571E5021991}" type="datetimeFigureOut">
               <a:rPr lang="en-US" smtClean="0"/>
               <a:t>8/2/2026</a:t>
             </a:fld>
@@ -1834,7 +1834,7 @@
           <p:cNvPr id="8" name="Footer Placeholder 7">
             <a:extLst>
               <a:ext uri="{FF2B5EF4-FFF2-40B4-BE49-F238E27FC236}">
-                <a16:creationId xmlns:a16="http://schemas.microsoft.com/office/drawing/2014/main" id="{617A36D3-A781-34AF-1774-9B42CDF42DD9}"/>
+                <a16:creationId xmlns:a16="http://schemas.microsoft.com/office/drawing/2014/main" id="{92EB8BF7-05DC-312E-EDB3-14746B904F32}"/>
               </a:ext>
             </a:extLst>
           </p:cNvPr>
@@ -1859,7 +1859,7 @@
           <p:cNvPr id="9" name="Slide Number Placeholder 8">
             <a:extLst>
               <a:ext uri="{FF2B5EF4-FFF2-40B4-BE49-F238E27FC236}">
-                <a16:creationId xmlns:a16="http://schemas.microsoft.com/office/drawing/2014/main" id="{135E01F3-7443-D5AE-9DFF-A24E68488B96}"/>
+                <a16:creationId xmlns:a16="http://schemas.microsoft.com/office/drawing/2014/main" id="{0F86CCDD-EF96-0A37-C731-5B4204C60D7A}"/>
               </a:ext>
             </a:extLst>
           </p:cNvPr>
@@ -1875,7 +1875,7 @@
           <a:bodyPr/>
           <a:lstStyle/>
           <a:p>
-            <a:fld id="{B08209FF-819D-43A2-97A4-6C4DDC35B4FA}" type="slidenum">
+            <a:fld id="{12A3504B-58D0-4D3A-B128-779D24249411}" type="slidenum">
               <a:rPr lang="en-US" smtClean="0"/>
               <a:t>‹#›</a:t>
             </a:fld>
@@ -1886,7 +1886,7 @@
     </p:spTree>
     <p:extLst>
       <p:ext uri="{BB962C8B-B14F-4D97-AF65-F5344CB8AC3E}">
-        <p14:creationId xmlns:p14="http://schemas.microsoft.com/office/powerpoint/2010/main" val="2103526037"/>
+        <p14:creationId xmlns:p14="http://schemas.microsoft.com/office/powerpoint/2010/main" val="3962000357"/>
       </p:ext>
     </p:extLst>
   </p:cSld>
@@ -1918,7 +1918,7 @@
           <p:cNvPr id="2" name="Title 1">
             <a:extLst>
               <a:ext uri="{FF2B5EF4-FFF2-40B4-BE49-F238E27FC236}">
-                <a16:creationId xmlns:a16="http://schemas.microsoft.com/office/drawing/2014/main" id="{BBFD94C2-0BA1-BD90-41F7-2BEF931B7C2B}"/>
+                <a16:creationId xmlns:a16="http://schemas.microsoft.com/office/drawing/2014/main" id="{98A363B2-3529-2419-67BA-B48D8DD94935}"/>
               </a:ext>
             </a:extLst>
           </p:cNvPr>
@@ -1946,7 +1946,7 @@
           <p:cNvPr id="3" name="Date Placeholder 2">
             <a:extLst>
               <a:ext uri="{FF2B5EF4-FFF2-40B4-BE49-F238E27FC236}">
-                <a16:creationId xmlns:a16="http://schemas.microsoft.com/office/drawing/2014/main" id="{6D36B2C9-8D63-FF08-AE01-04E2F8411844}"/>
+                <a16:creationId xmlns:a16="http://schemas.microsoft.com/office/drawing/2014/main" id="{9BC7543E-4B4B-F8ED-7AC3-C9A17770A6C1}"/>
               </a:ext>
             </a:extLst>
           </p:cNvPr>
@@ -1962,7 +1962,7 @@
           <a:bodyPr/>
           <a:lstStyle/>
           <a:p>
-            <a:fld id="{7D1867BF-27E9-4E78-B03E-D1C72F0D04A0}" type="datetimeFigureOut">
+            <a:fld id="{6FC9DE57-2506-4C28-8EDA-5571E5021991}" type="datetimeFigureOut">
               <a:rPr lang="en-US" smtClean="0"/>
               <a:t>8/2/2026</a:t>
             </a:fld>
@@ -1975,7 +1975,7 @@
           <p:cNvPr id="4" name="Footer Placeholder 3">
             <a:extLst>
               <a:ext uri="{FF2B5EF4-FFF2-40B4-BE49-F238E27FC236}">
-                <a16:creationId xmlns:a16="http://schemas.microsoft.com/office/drawing/2014/main" id="{ED733073-7E84-2A41-891E-672FC9DF898B}"/>
+                <a16:creationId xmlns:a16="http://schemas.microsoft.com/office/drawing/2014/main" id="{F6B9A0B8-316B-7D4A-055C-5680A5DB659E}"/>
               </a:ext>
             </a:extLst>
           </p:cNvPr>
@@ -2000,7 +2000,7 @@
           <p:cNvPr id="5" name="Slide Number Placeholder 4">
             <a:extLst>
               <a:ext uri="{FF2B5EF4-FFF2-40B4-BE49-F238E27FC236}">
-                <a16:creationId xmlns:a16="http://schemas.microsoft.com/office/drawing/2014/main" id="{1F65A5F2-924B-0C8E-A208-EFA3BA9358E3}"/>
+                <a16:creationId xmlns:a16="http://schemas.microsoft.com/office/drawing/2014/main" id="{1F8C3CED-1641-7DD2-C5A7-B6E8B1CECA16}"/>
               </a:ext>
             </a:extLst>
           </p:cNvPr>
@@ -2016,7 +2016,7 @@
           <a:bodyPr/>
           <a:lstStyle/>
           <a:p>
-            <a:fld id="{B08209FF-819D-43A2-97A4-6C4DDC35B4FA}" type="slidenum">
+            <a:fld id="{12A3504B-58D0-4D3A-B128-779D24249411}" type="slidenum">
               <a:rPr lang="en-US" smtClean="0"/>
               <a:t>‹#›</a:t>
             </a:fld>
@@ -2027,7 +2027,7 @@
     </p:spTree>
     <p:extLst>
       <p:ext uri="{BB962C8B-B14F-4D97-AF65-F5344CB8AC3E}">
-        <p14:creationId xmlns:p14="http://schemas.microsoft.com/office/powerpoint/2010/main" val="1744506091"/>
+        <p14:creationId xmlns:p14="http://schemas.microsoft.com/office/powerpoint/2010/main" val="1227157140"/>
       </p:ext>
     </p:extLst>
   </p:cSld>
@@ -2059,7 +2059,7 @@
           <p:cNvPr id="2" name="Date Placeholder 1">
             <a:extLst>
               <a:ext uri="{FF2B5EF4-FFF2-40B4-BE49-F238E27FC236}">
-                <a16:creationId xmlns:a16="http://schemas.microsoft.com/office/drawing/2014/main" id="{B99F11C5-75A7-03E8-D3CB-CEAEA8F46D31}"/>
+                <a16:creationId xmlns:a16="http://schemas.microsoft.com/office/drawing/2014/main" id="{6946C40B-97AB-5119-094B-708B401E753B}"/>
               </a:ext>
             </a:extLst>
           </p:cNvPr>
@@ -2075,7 +2075,7 @@
           <a:bodyPr/>
           <a:lstStyle/>
           <a:p>
-            <a:fld id="{7D1867BF-27E9-4E78-B03E-D1C72F0D04A0}" type="datetimeFigureOut">
+            <a:fld id="{6FC9DE57-2506-4C28-8EDA-5571E5021991}" type="datetimeFigureOut">
               <a:rPr lang="en-US" smtClean="0"/>
               <a:t>8/2/2026</a:t>
             </a:fld>
@@ -2088,7 +2088,7 @@
           <p:cNvPr id="3" name="Footer Placeholder 2">
             <a:extLst>
               <a:ext uri="{FF2B5EF4-FFF2-40B4-BE49-F238E27FC236}">
-                <a16:creationId xmlns:a16="http://schemas.microsoft.com/office/drawing/2014/main" id="{B4652F66-7FA1-81DB-6099-AA06C0EC10C1}"/>
+                <a16:creationId xmlns:a16="http://schemas.microsoft.com/office/drawing/2014/main" id="{F5A99AAB-B0FF-B4DA-2055-3FA5CDE4AD7D}"/>
               </a:ext>
             </a:extLst>
           </p:cNvPr>
@@ -2113,7 +2113,7 @@
           <p:cNvPr id="4" name="Slide Number Placeholder 3">
             <a:extLst>
               <a:ext uri="{FF2B5EF4-FFF2-40B4-BE49-F238E27FC236}">
-                <a16:creationId xmlns:a16="http://schemas.microsoft.com/office/drawing/2014/main" id="{3314BE7B-307A-07E7-3454-57CEB28E21E9}"/>
+                <a16:creationId xmlns:a16="http://schemas.microsoft.com/office/drawing/2014/main" id="{9FAD7541-AD20-8C0A-71FF-8887581AA69E}"/>
               </a:ext>
             </a:extLst>
           </p:cNvPr>
@@ -2129,7 +2129,7 @@
           <a:bodyPr/>
           <a:lstStyle/>
           <a:p>
-            <a:fld id="{B08209FF-819D-43A2-97A4-6C4DDC35B4FA}" type="slidenum">
+            <a:fld id="{12A3504B-58D0-4D3A-B128-779D24249411}" type="slidenum">
               <a:rPr lang="en-US" smtClean="0"/>
               <a:t>‹#›</a:t>
             </a:fld>
@@ -2140,7 +2140,7 @@
     </p:spTree>
     <p:extLst>
       <p:ext uri="{BB962C8B-B14F-4D97-AF65-F5344CB8AC3E}">
-        <p14:creationId xmlns:p14="http://schemas.microsoft.com/office/powerpoint/2010/main" val="2162096505"/>
+        <p14:creationId xmlns:p14="http://schemas.microsoft.com/office/powerpoint/2010/main" val="657923578"/>
       </p:ext>
     </p:extLst>
   </p:cSld>
@@ -2172,7 +2172,7 @@
           <p:cNvPr id="2" name="Title 1">
             <a:extLst>
               <a:ext uri="{FF2B5EF4-FFF2-40B4-BE49-F238E27FC236}">
-                <a16:creationId xmlns:a16="http://schemas.microsoft.com/office/drawing/2014/main" id="{FA6C5445-165B-BF88-05F8-48B7FE9EC2D5}"/>
+                <a16:creationId xmlns:a16="http://schemas.microsoft.com/office/drawing/2014/main" id="{E0E34CEA-7950-8249-43F9-0D9F2327ECD1}"/>
               </a:ext>
             </a:extLst>
           </p:cNvPr>
@@ -2209,7 +2209,7 @@
           <p:cNvPr id="3" name="Content Placeholder 2">
             <a:extLst>
               <a:ext uri="{FF2B5EF4-FFF2-40B4-BE49-F238E27FC236}">
-                <a16:creationId xmlns:a16="http://schemas.microsoft.com/office/drawing/2014/main" id="{E90F2958-3031-635B-D610-ABD3D6585BA4}"/>
+                <a16:creationId xmlns:a16="http://schemas.microsoft.com/office/drawing/2014/main" id="{50DF8799-77F3-F471-64DA-27757256DC68}"/>
               </a:ext>
             </a:extLst>
           </p:cNvPr>
@@ -2299,7 +2299,7 @@
           <p:cNvPr id="4" name="Text Placeholder 3">
             <a:extLst>
               <a:ext uri="{FF2B5EF4-FFF2-40B4-BE49-F238E27FC236}">
-                <a16:creationId xmlns:a16="http://schemas.microsoft.com/office/drawing/2014/main" id="{81F8D114-F9E0-8C84-F84B-FBFEF301B9EE}"/>
+                <a16:creationId xmlns:a16="http://schemas.microsoft.com/office/drawing/2014/main" id="{9FA8BAD0-7D2E-ADD9-D552-DE0B23FC6235}"/>
               </a:ext>
             </a:extLst>
           </p:cNvPr>
@@ -2370,7 +2370,7 @@
           <p:cNvPr id="5" name="Date Placeholder 4">
             <a:extLst>
               <a:ext uri="{FF2B5EF4-FFF2-40B4-BE49-F238E27FC236}">
-                <a16:creationId xmlns:a16="http://schemas.microsoft.com/office/drawing/2014/main" id="{549CC306-2254-03D2-B786-DD932BF0C04B}"/>
+                <a16:creationId xmlns:a16="http://schemas.microsoft.com/office/drawing/2014/main" id="{996ED295-D312-B04D-CFE0-60FF6EE406BD}"/>
               </a:ext>
             </a:extLst>
           </p:cNvPr>
@@ -2386,7 +2386,7 @@
           <a:bodyPr/>
           <a:lstStyle/>
           <a:p>
-            <a:fld id="{7D1867BF-27E9-4E78-B03E-D1C72F0D04A0}" type="datetimeFigureOut">
+            <a:fld id="{6FC9DE57-2506-4C28-8EDA-5571E5021991}" type="datetimeFigureOut">
               <a:rPr lang="en-US" smtClean="0"/>
               <a:t>8/2/2026</a:t>
             </a:fld>
@@ -2399,7 +2399,7 @@
           <p:cNvPr id="6" name="Footer Placeholder 5">
             <a:extLst>
               <a:ext uri="{FF2B5EF4-FFF2-40B4-BE49-F238E27FC236}">
-                <a16:creationId xmlns:a16="http://schemas.microsoft.com/office/drawing/2014/main" id="{B8846074-C178-75DF-2BDF-54C0337210C1}"/>
+                <a16:creationId xmlns:a16="http://schemas.microsoft.com/office/drawing/2014/main" id="{E24E61BB-1F06-9E31-A2D2-487FCD969FE3}"/>
               </a:ext>
             </a:extLst>
           </p:cNvPr>
@@ -2424,7 +2424,7 @@
           <p:cNvPr id="7" name="Slide Number Placeholder 6">
             <a:extLst>
               <a:ext uri="{FF2B5EF4-FFF2-40B4-BE49-F238E27FC236}">
-                <a16:creationId xmlns:a16="http://schemas.microsoft.com/office/drawing/2014/main" id="{DA3A08D9-E0B0-3A81-A82C-FB3882D1CA4B}"/>
+                <a16:creationId xmlns:a16="http://schemas.microsoft.com/office/drawing/2014/main" id="{258BB6AF-DDA2-F42C-106B-A64D49FC500D}"/>
               </a:ext>
             </a:extLst>
           </p:cNvPr>
@@ -2440,7 +2440,7 @@
           <a:bodyPr/>
           <a:lstStyle/>
           <a:p>
-            <a:fld id="{B08209FF-819D-43A2-97A4-6C4DDC35B4FA}" type="slidenum">
+            <a:fld id="{12A3504B-58D0-4D3A-B128-779D24249411}" type="slidenum">
               <a:rPr lang="en-US" smtClean="0"/>
               <a:t>‹#›</a:t>
             </a:fld>
@@ -2451,7 +2451,7 @@
     </p:spTree>
     <p:extLst>
       <p:ext uri="{BB962C8B-B14F-4D97-AF65-F5344CB8AC3E}">
-        <p14:creationId xmlns:p14="http://schemas.microsoft.com/office/powerpoint/2010/main" val="1229133835"/>
+        <p14:creationId xmlns:p14="http://schemas.microsoft.com/office/powerpoint/2010/main" val="4203006821"/>
       </p:ext>
     </p:extLst>
   </p:cSld>
@@ -2483,7 +2483,7 @@
           <p:cNvPr id="2" name="Title 1">
             <a:extLst>
               <a:ext uri="{FF2B5EF4-FFF2-40B4-BE49-F238E27FC236}">
-                <a16:creationId xmlns:a16="http://schemas.microsoft.com/office/drawing/2014/main" id="{F22EC7C9-5B01-B7AD-E415-FD52AE0B0912}"/>
+                <a16:creationId xmlns:a16="http://schemas.microsoft.com/office/drawing/2014/main" id="{79B9660A-2166-0430-71E5-161DC149A650}"/>
               </a:ext>
             </a:extLst>
           </p:cNvPr>
@@ -2520,7 +2520,7 @@
           <p:cNvPr id="3" name="Picture Placeholder 2">
             <a:extLst>
               <a:ext uri="{FF2B5EF4-FFF2-40B4-BE49-F238E27FC236}">
-                <a16:creationId xmlns:a16="http://schemas.microsoft.com/office/drawing/2014/main" id="{D25D5064-7321-8BAD-0F76-CB97B8F83212}"/>
+                <a16:creationId xmlns:a16="http://schemas.microsoft.com/office/drawing/2014/main" id="{5BE8F9BB-7E13-CE7F-618D-93DDD42124F3}"/>
               </a:ext>
             </a:extLst>
           </p:cNvPr>
@@ -2587,7 +2587,7 @@
           <p:cNvPr id="4" name="Text Placeholder 3">
             <a:extLst>
               <a:ext uri="{FF2B5EF4-FFF2-40B4-BE49-F238E27FC236}">
-                <a16:creationId xmlns:a16="http://schemas.microsoft.com/office/drawing/2014/main" id="{06CC0097-1947-6E84-A246-9BE48FB27CAB}"/>
+                <a16:creationId xmlns:a16="http://schemas.microsoft.com/office/drawing/2014/main" id="{2BCD5052-95A2-C416-649B-E8B40BDC769D}"/>
               </a:ext>
             </a:extLst>
           </p:cNvPr>
@@ -2658,7 +2658,7 @@
           <p:cNvPr id="5" name="Date Placeholder 4">
             <a:extLst>
               <a:ext uri="{FF2B5EF4-FFF2-40B4-BE49-F238E27FC236}">
-                <a16:creationId xmlns:a16="http://schemas.microsoft.com/office/drawing/2014/main" id="{0D618794-80B3-D810-2C80-77716CB99F93}"/>
+                <a16:creationId xmlns:a16="http://schemas.microsoft.com/office/drawing/2014/main" id="{16917EFC-3569-72E7-281A-1DFC16302B8C}"/>
               </a:ext>
             </a:extLst>
           </p:cNvPr>
@@ -2674,7 +2674,7 @@
           <a:bodyPr/>
           <a:lstStyle/>
           <a:p>
-            <a:fld id="{7D1867BF-27E9-4E78-B03E-D1C72F0D04A0}" type="datetimeFigureOut">
+            <a:fld id="{6FC9DE57-2506-4C28-8EDA-5571E5021991}" type="datetimeFigureOut">
               <a:rPr lang="en-US" smtClean="0"/>
               <a:t>8/2/2026</a:t>
             </a:fld>
@@ -2687,7 +2687,7 @@
           <p:cNvPr id="6" name="Footer Placeholder 5">
             <a:extLst>
               <a:ext uri="{FF2B5EF4-FFF2-40B4-BE49-F238E27FC236}">
-                <a16:creationId xmlns:a16="http://schemas.microsoft.com/office/drawing/2014/main" id="{7CD78C38-84ED-4D77-A7B8-7E697AA84BA7}"/>
+                <a16:creationId xmlns:a16="http://schemas.microsoft.com/office/drawing/2014/main" id="{3B2D8AB9-DE1B-1FE9-F558-1B4F81505CAF}"/>
               </a:ext>
             </a:extLst>
           </p:cNvPr>
@@ -2712,7 +2712,7 @@
           <p:cNvPr id="7" name="Slide Number Placeholder 6">
             <a:extLst>
               <a:ext uri="{FF2B5EF4-FFF2-40B4-BE49-F238E27FC236}">
-                <a16:creationId xmlns:a16="http://schemas.microsoft.com/office/drawing/2014/main" id="{60D37C15-57E2-F8AF-D0A0-745BE11AC16A}"/>
+                <a16:creationId xmlns:a16="http://schemas.microsoft.com/office/drawing/2014/main" id="{6BDFAEF9-50B5-B754-B17E-FBDE046EB74E}"/>
               </a:ext>
             </a:extLst>
           </p:cNvPr>
@@ -2728,7 +2728,7 @@
           <a:bodyPr/>
           <a:lstStyle/>
           <a:p>
-            <a:fld id="{B08209FF-819D-43A2-97A4-6C4DDC35B4FA}" type="slidenum">
+            <a:fld id="{12A3504B-58D0-4D3A-B128-779D24249411}" type="slidenum">
               <a:rPr lang="en-US" smtClean="0"/>
               <a:t>‹#›</a:t>
             </a:fld>
@@ -2739,7 +2739,7 @@
     </p:spTree>
     <p:extLst>
       <p:ext uri="{BB962C8B-B14F-4D97-AF65-F5344CB8AC3E}">
-        <p14:creationId xmlns:p14="http://schemas.microsoft.com/office/powerpoint/2010/main" val="3082286244"/>
+        <p14:creationId xmlns:p14="http://schemas.microsoft.com/office/powerpoint/2010/main" val="1828029566"/>
       </p:ext>
     </p:extLst>
   </p:cSld>
@@ -2776,7 +2776,7 @@
           <p:cNvPr id="2" name="Title Placeholder 1">
             <a:extLst>
               <a:ext uri="{FF2B5EF4-FFF2-40B4-BE49-F238E27FC236}">
-                <a16:creationId xmlns:a16="http://schemas.microsoft.com/office/drawing/2014/main" id="{AC369113-E781-E006-798A-167F87008CE7}"/>
+                <a16:creationId xmlns:a16="http://schemas.microsoft.com/office/drawing/2014/main" id="{8C6474BE-1017-8ED5-0091-07DFB3E5B877}"/>
               </a:ext>
             </a:extLst>
           </p:cNvPr>
@@ -2814,7 +2814,7 @@
           <p:cNvPr id="3" name="Text Placeholder 2">
             <a:extLst>
               <a:ext uri="{FF2B5EF4-FFF2-40B4-BE49-F238E27FC236}">
-                <a16:creationId xmlns:a16="http://schemas.microsoft.com/office/drawing/2014/main" id="{85CFF36A-4276-A92C-8E6B-9F4A7E33A815}"/>
+                <a16:creationId xmlns:a16="http://schemas.microsoft.com/office/drawing/2014/main" id="{AFA0DFC6-7175-300C-3493-0087FDFCB0D0}"/>
               </a:ext>
             </a:extLst>
           </p:cNvPr>
@@ -2881,7 +2881,7 @@
           <p:cNvPr id="4" name="Date Placeholder 3">
             <a:extLst>
               <a:ext uri="{FF2B5EF4-FFF2-40B4-BE49-F238E27FC236}">
-                <a16:creationId xmlns:a16="http://schemas.microsoft.com/office/drawing/2014/main" id="{11A08B6F-7E09-BB2F-9A3E-BBB205FE19C5}"/>
+                <a16:creationId xmlns:a16="http://schemas.microsoft.com/office/drawing/2014/main" id="{ED2EAD85-0060-7B8B-3305-C28723F8CACE}"/>
               </a:ext>
             </a:extLst>
           </p:cNvPr>
@@ -2915,7 +2915,7 @@
             </a:lvl1pPr>
           </a:lstStyle>
           <a:p>
-            <a:fld id="{7D1867BF-27E9-4E78-B03E-D1C72F0D04A0}" type="datetimeFigureOut">
+            <a:fld id="{6FC9DE57-2506-4C28-8EDA-5571E5021991}" type="datetimeFigureOut">
               <a:rPr lang="en-US" smtClean="0"/>
               <a:t>8/2/2026</a:t>
             </a:fld>
@@ -2928,7 +2928,7 @@
           <p:cNvPr id="5" name="Footer Placeholder 4">
             <a:extLst>
               <a:ext uri="{FF2B5EF4-FFF2-40B4-BE49-F238E27FC236}">
-                <a16:creationId xmlns:a16="http://schemas.microsoft.com/office/drawing/2014/main" id="{2D98A49B-087A-DAF5-2FA7-2A2F2F67C1CC}"/>
+                <a16:creationId xmlns:a16="http://schemas.microsoft.com/office/drawing/2014/main" id="{A73C1C69-BEDE-06A6-5A33-EAD73497BE19}"/>
               </a:ext>
             </a:extLst>
           </p:cNvPr>
@@ -2971,7 +2971,7 @@
           <p:cNvPr id="6" name="Slide Number Placeholder 5">
             <a:extLst>
               <a:ext uri="{FF2B5EF4-FFF2-40B4-BE49-F238E27FC236}">
-                <a16:creationId xmlns:a16="http://schemas.microsoft.com/office/drawing/2014/main" id="{5089025C-F8C0-BFE2-F9BC-01C9D9CD75F4}"/>
+                <a16:creationId xmlns:a16="http://schemas.microsoft.com/office/drawing/2014/main" id="{6F866F23-65A2-3F52-15AB-83A5BB538347}"/>
               </a:ext>
             </a:extLst>
           </p:cNvPr>
@@ -3005,7 +3005,7 @@
             </a:lvl1pPr>
           </a:lstStyle>
           <a:p>
-            <a:fld id="{B08209FF-819D-43A2-97A4-6C4DDC35B4FA}" type="slidenum">
+            <a:fld id="{12A3504B-58D0-4D3A-B128-779D24249411}" type="slidenum">
               <a:rPr lang="en-US" smtClean="0"/>
               <a:t>‹#›</a:t>
             </a:fld>
@@ -3016,7 +3016,7 @@
     </p:spTree>
     <p:extLst>
       <p:ext uri="{BB962C8B-B14F-4D97-AF65-F5344CB8AC3E}">
-        <p14:creationId xmlns:p14="http://schemas.microsoft.com/office/powerpoint/2010/main" val="3153553570"/>
+        <p14:creationId xmlns:p14="http://schemas.microsoft.com/office/powerpoint/2010/main" val="4277089136"/>
       </p:ext>
     </p:extLst>
   </p:cSld>
@@ -3339,7 +3339,7 @@
           <p:cNvPr id="2" name="Rectangle 1">
             <a:extLst>
               <a:ext uri="{FF2B5EF4-FFF2-40B4-BE49-F238E27FC236}">
-                <a16:creationId xmlns:a16="http://schemas.microsoft.com/office/drawing/2014/main" id="{85E1FE8C-E6B3-5EE1-D2E4-DBDDCE97EFC7}"/>
+                <a16:creationId xmlns:a16="http://schemas.microsoft.com/office/drawing/2014/main" id="{B1B78375-F82A-1927-A659-C001850B8415}"/>
               </a:ext>
             </a:extLst>
           </p:cNvPr>
@@ -3407,7 +3407,7 @@
           <p:cNvPr id="3" name="Rectangle 2">
             <a:extLst>
               <a:ext uri="{FF2B5EF4-FFF2-40B4-BE49-F238E27FC236}">
-                <a16:creationId xmlns:a16="http://schemas.microsoft.com/office/drawing/2014/main" id="{D091EA2D-CBC4-D536-6B82-51411EA896D2}"/>
+                <a16:creationId xmlns:a16="http://schemas.microsoft.com/office/drawing/2014/main" id="{3ADBBED3-B72E-C662-723F-90A39643A0AC}"/>
               </a:ext>
             </a:extLst>
           </p:cNvPr>
@@ -3475,7 +3475,7 @@
           <p:cNvPr id="4" name="TextBox 3">
             <a:extLst>
               <a:ext uri="{FF2B5EF4-FFF2-40B4-BE49-F238E27FC236}">
-                <a16:creationId xmlns:a16="http://schemas.microsoft.com/office/drawing/2014/main" id="{56CAF8F7-083A-6A49-DEDA-2A9A5EB894A0}"/>
+                <a16:creationId xmlns:a16="http://schemas.microsoft.com/office/drawing/2014/main" id="{E4CD313A-8A22-79B2-E0CF-5DB8A100B8CF}"/>
               </a:ext>
             </a:extLst>
           </p:cNvPr>
@@ -3515,7 +3515,7 @@
           <p:cNvPr id="5" name="TextBox 4">
             <a:extLst>
               <a:ext uri="{FF2B5EF4-FFF2-40B4-BE49-F238E27FC236}">
-                <a16:creationId xmlns:a16="http://schemas.microsoft.com/office/drawing/2014/main" id="{3E7B290C-1247-BA3B-0608-78EA77390001}"/>
+                <a16:creationId xmlns:a16="http://schemas.microsoft.com/office/drawing/2014/main" id="{55F81339-12E5-BD25-3244-3E16F19B75A0}"/>
               </a:ext>
             </a:extLst>
           </p:cNvPr>
@@ -3555,7 +3555,7 @@
           <p:cNvPr id="6" name="TextBox 5">
             <a:extLst>
               <a:ext uri="{FF2B5EF4-FFF2-40B4-BE49-F238E27FC236}">
-                <a16:creationId xmlns:a16="http://schemas.microsoft.com/office/drawing/2014/main" id="{68804187-16C4-E569-60E8-7017B13C14DA}"/>
+                <a16:creationId xmlns:a16="http://schemas.microsoft.com/office/drawing/2014/main" id="{C57A64EB-288E-AF2E-C06F-8420BB57DCD6}"/>
               </a:ext>
             </a:extLst>
           </p:cNvPr>
@@ -3593,7 +3593,7 @@
     </p:spTree>
     <p:extLst>
       <p:ext uri="{BB962C8B-B14F-4D97-AF65-F5344CB8AC3E}">
-        <p14:creationId xmlns:p14="http://schemas.microsoft.com/office/powerpoint/2010/main" val="794217807"/>
+        <p14:creationId xmlns:p14="http://schemas.microsoft.com/office/powerpoint/2010/main" val="3351404129"/>
       </p:ext>
     </p:extLst>
   </p:cSld>
@@ -3625,7 +3625,7 @@
           <p:cNvPr id="2" name="Rectangle: Rounded Corners 1">
             <a:extLst>
               <a:ext uri="{FF2B5EF4-FFF2-40B4-BE49-F238E27FC236}">
-                <a16:creationId xmlns:a16="http://schemas.microsoft.com/office/drawing/2014/main" id="{7CF10A6B-C399-1A0A-33FE-F6230F438BF4}"/>
+                <a16:creationId xmlns:a16="http://schemas.microsoft.com/office/drawing/2014/main" id="{CA66BDFE-A1E4-EB70-D339-7BF09551B69F}"/>
               </a:ext>
             </a:extLst>
           </p:cNvPr>
@@ -3693,7 +3693,7 @@
           <p:cNvPr id="3" name="TextBox 2">
             <a:extLst>
               <a:ext uri="{FF2B5EF4-FFF2-40B4-BE49-F238E27FC236}">
-                <a16:creationId xmlns:a16="http://schemas.microsoft.com/office/drawing/2014/main" id="{3B5A2BD0-854D-F129-2893-9B40688E3601}"/>
+                <a16:creationId xmlns:a16="http://schemas.microsoft.com/office/drawing/2014/main" id="{A6B05737-950E-7C40-B9E4-EF3ABF961789}"/>
               </a:ext>
             </a:extLst>
           </p:cNvPr>
@@ -3733,7 +3733,7 @@
           <p:cNvPr id="4" name="Table 3">
             <a:extLst>
               <a:ext uri="{FF2B5EF4-FFF2-40B4-BE49-F238E27FC236}">
-                <a16:creationId xmlns:a16="http://schemas.microsoft.com/office/drawing/2014/main" id="{04DB33CD-2185-8717-F5EA-0556C9673B02}"/>
+                <a16:creationId xmlns:a16="http://schemas.microsoft.com/office/drawing/2014/main" id="{AE5120BC-66EE-34B0-9C52-B4A910BEDA18}"/>
               </a:ext>
             </a:extLst>
           </p:cNvPr>
@@ -3743,7 +3743,7 @@
           <p:nvPr>
             <p:extLst>
               <p:ext uri="{D42A27DB-BD31-4B8C-83A1-F6EECF244321}">
-                <p14:modId xmlns:p14="http://schemas.microsoft.com/office/powerpoint/2010/main" val="4024190616"/>
+                <p14:modId xmlns:p14="http://schemas.microsoft.com/office/powerpoint/2010/main" val="4287810032"/>
               </p:ext>
             </p:extLst>
           </p:nvPr>
@@ -3762,21 +3762,21 @@
                 <a:gridCol w="3175000">
                   <a:extLst>
                     <a:ext uri="{9D8B030D-6E8A-4147-A177-3AD203B41FA5}">
-                      <a16:colId xmlns:a16="http://schemas.microsoft.com/office/drawing/2014/main" val="3965821461"/>
+                      <a16:colId xmlns:a16="http://schemas.microsoft.com/office/drawing/2014/main" val="1996831123"/>
                     </a:ext>
                   </a:extLst>
                 </a:gridCol>
                 <a:gridCol w="1397000">
                   <a:extLst>
                     <a:ext uri="{9D8B030D-6E8A-4147-A177-3AD203B41FA5}">
-                      <a16:colId xmlns:a16="http://schemas.microsoft.com/office/drawing/2014/main" val="1946583278"/>
+                      <a16:colId xmlns:a16="http://schemas.microsoft.com/office/drawing/2014/main" val="2779193076"/>
                     </a:ext>
                   </a:extLst>
                 </a:gridCol>
                 <a:gridCol w="4572000">
                   <a:extLst>
                     <a:ext uri="{9D8B030D-6E8A-4147-A177-3AD203B41FA5}">
-                      <a16:colId xmlns:a16="http://schemas.microsoft.com/office/drawing/2014/main" val="3739599022"/>
+                      <a16:colId xmlns:a16="http://schemas.microsoft.com/office/drawing/2014/main" val="1899799987"/>
                     </a:ext>
                   </a:extLst>
                 </a:gridCol>
@@ -3850,7 +3850,7 @@
                 </a:tc>
                 <a:extLst>
                   <a:ext uri="{0D108BD9-81ED-4DB2-BD59-A6C34878D82A}">
-                    <a16:rowId xmlns:a16="http://schemas.microsoft.com/office/drawing/2014/main" val="3758721813"/>
+                    <a16:rowId xmlns:a16="http://schemas.microsoft.com/office/drawing/2014/main" val="3743179149"/>
                   </a:ext>
                 </a:extLst>
               </a:tr>
@@ -3889,7 +3889,7 @@
                           </a:solidFill>
                           <a:latin typeface="Calibri" panose="020F0502020204030204" pitchFamily="34" charset="0"/>
                         </a:rPr>
-                        <a:t>34.5 s</a:t>
+                        <a:t>40.8 s</a:t>
                       </a:r>
                     </a:p>
                   </a:txBody>
@@ -3923,7 +3923,7 @@
                 </a:tc>
                 <a:extLst>
                   <a:ext uri="{0D108BD9-81ED-4DB2-BD59-A6C34878D82A}">
-                    <a16:rowId xmlns:a16="http://schemas.microsoft.com/office/drawing/2014/main" val="1331317958"/>
+                    <a16:rowId xmlns:a16="http://schemas.microsoft.com/office/drawing/2014/main" val="3456934857"/>
                   </a:ext>
                 </a:extLst>
               </a:tr>
@@ -3958,7 +3958,7 @@
                           </a:solidFill>
                           <a:latin typeface="Calibri" panose="020F0502020204030204" pitchFamily="34" charset="0"/>
                         </a:rPr>
-                        <a:t>5.9 s</a:t>
+                        <a:t>10.8 s</a:t>
                       </a:r>
                     </a:p>
                   </a:txBody>
@@ -3976,7 +3976,7 @@
                           </a:solidFill>
                           <a:latin typeface="Calibri" panose="020F0502020204030204" pitchFamily="34" charset="0"/>
                         </a:rPr>
-                        <a:t>0 (no new source rows)</a:t>
+                        <a:t>+75,625 fact rows + 7 dim rows</a:t>
                       </a:r>
                     </a:p>
                   </a:txBody>
@@ -3984,7 +3984,7 @@
                 </a:tc>
                 <a:extLst>
                   <a:ext uri="{0D108BD9-81ED-4DB2-BD59-A6C34878D82A}">
-                    <a16:rowId xmlns:a16="http://schemas.microsoft.com/office/drawing/2014/main" val="2619401848"/>
+                    <a16:rowId xmlns:a16="http://schemas.microsoft.com/office/drawing/2014/main" val="3924270469"/>
                   </a:ext>
                 </a:extLst>
               </a:tr>
@@ -3997,7 +3997,7 @@
           <p:cNvPr id="5" name="Table 4">
             <a:extLst>
               <a:ext uri="{FF2B5EF4-FFF2-40B4-BE49-F238E27FC236}">
-                <a16:creationId xmlns:a16="http://schemas.microsoft.com/office/drawing/2014/main" id="{37611CAF-B76B-268C-47AE-B807A95D948F}"/>
+                <a16:creationId xmlns:a16="http://schemas.microsoft.com/office/drawing/2014/main" id="{AF6B8E25-95C5-6207-5A76-1FD4E3B088D6}"/>
               </a:ext>
             </a:extLst>
           </p:cNvPr>
@@ -4007,7 +4007,7 @@
           <p:nvPr>
             <p:extLst>
               <p:ext uri="{D42A27DB-BD31-4B8C-83A1-F6EECF244321}">
-                <p14:modId xmlns:p14="http://schemas.microsoft.com/office/powerpoint/2010/main" val="1860236983"/>
+                <p14:modId xmlns:p14="http://schemas.microsoft.com/office/powerpoint/2010/main" val="265797221"/>
               </p:ext>
             </p:extLst>
           </p:nvPr>
@@ -4026,28 +4026,28 @@
                 <a:gridCol w="3810000">
                   <a:extLst>
                     <a:ext uri="{9D8B030D-6E8A-4147-A177-3AD203B41FA5}">
-                      <a16:colId xmlns:a16="http://schemas.microsoft.com/office/drawing/2014/main" val="520877583"/>
+                      <a16:colId xmlns:a16="http://schemas.microsoft.com/office/drawing/2014/main" val="4261778827"/>
                     </a:ext>
                   </a:extLst>
                 </a:gridCol>
                 <a:gridCol w="1016000">
                   <a:extLst>
                     <a:ext uri="{9D8B030D-6E8A-4147-A177-3AD203B41FA5}">
-                      <a16:colId xmlns:a16="http://schemas.microsoft.com/office/drawing/2014/main" val="663796882"/>
+                      <a16:colId xmlns:a16="http://schemas.microsoft.com/office/drawing/2014/main" val="3083749399"/>
                     </a:ext>
                   </a:extLst>
                 </a:gridCol>
                 <a:gridCol w="1651000">
                   <a:extLst>
                     <a:ext uri="{9D8B030D-6E8A-4147-A177-3AD203B41FA5}">
-                      <a16:colId xmlns:a16="http://schemas.microsoft.com/office/drawing/2014/main" val="3495438601"/>
+                      <a16:colId xmlns:a16="http://schemas.microsoft.com/office/drawing/2014/main" val="2576227949"/>
                     </a:ext>
                   </a:extLst>
                 </a:gridCol>
                 <a:gridCol w="3175000">
                   <a:extLst>
                     <a:ext uri="{9D8B030D-6E8A-4147-A177-3AD203B41FA5}">
-                      <a16:colId xmlns:a16="http://schemas.microsoft.com/office/drawing/2014/main" val="2945153232"/>
+                      <a16:colId xmlns:a16="http://schemas.microsoft.com/office/drawing/2014/main" val="3719239365"/>
                     </a:ext>
                   </a:extLst>
                 </a:gridCol>
@@ -4143,7 +4143,7 @@
                 </a:tc>
                 <a:extLst>
                   <a:ext uri="{0D108BD9-81ED-4DB2-BD59-A6C34878D82A}">
-                    <a16:rowId xmlns:a16="http://schemas.microsoft.com/office/drawing/2014/main" val="2598791922"/>
+                    <a16:rowId xmlns:a16="http://schemas.microsoft.com/office/drawing/2014/main" val="131160083"/>
                   </a:ext>
                 </a:extLst>
               </a:tr>
@@ -4182,7 +4182,7 @@
                           </a:solidFill>
                           <a:latin typeface="Calibri" panose="020F0502020204030204" pitchFamily="34" charset="0"/>
                         </a:rPr>
-                        <a:t>432</a:t>
+                        <a:t>842</a:t>
                       </a:r>
                     </a:p>
                   </a:txBody>
@@ -4204,7 +4204,7 @@
                           </a:solidFill>
                           <a:latin typeface="Calibri" panose="020F0502020204030204" pitchFamily="34" charset="0"/>
                         </a:rPr>
-                        <a:t>4,445</a:t>
+                        <a:t>5,471</a:t>
                       </a:r>
                     </a:p>
                   </a:txBody>
@@ -4226,7 +4226,7 @@
                           </a:solidFill>
                           <a:latin typeface="Calibri" panose="020F0502020204030204" pitchFamily="34" charset="0"/>
                         </a:rPr>
-                        <a:t>1,898</a:t>
+                        <a:t>2,732</a:t>
                       </a:r>
                     </a:p>
                   </a:txBody>
@@ -4238,7 +4238,7 @@
                 </a:tc>
                 <a:extLst>
                   <a:ext uri="{0D108BD9-81ED-4DB2-BD59-A6C34878D82A}">
-                    <a16:rowId xmlns:a16="http://schemas.microsoft.com/office/drawing/2014/main" val="894611947"/>
+                    <a16:rowId xmlns:a16="http://schemas.microsoft.com/office/drawing/2014/main" val="518843877"/>
                   </a:ext>
                 </a:extLst>
               </a:tr>
@@ -4273,7 +4273,7 @@
                           </a:solidFill>
                           <a:latin typeface="Calibri" panose="020F0502020204030204" pitchFamily="34" charset="0"/>
                         </a:rPr>
-                        <a:t>432</a:t>
+                        <a:t>842</a:t>
                       </a:r>
                     </a:p>
                   </a:txBody>
@@ -4291,7 +4291,7 @@
                           </a:solidFill>
                           <a:latin typeface="Calibri" panose="020F0502020204030204" pitchFamily="34" charset="0"/>
                         </a:rPr>
-                        <a:t>1,109-1,781</a:t>
+                        <a:t>1,079</a:t>
                       </a:r>
                     </a:p>
                   </a:txBody>
@@ -4309,7 +4309,7 @@
                           </a:solidFill>
                           <a:latin typeface="Calibri" panose="020F0502020204030204" pitchFamily="34" charset="0"/>
                         </a:rPr>
-                        <a:t>1,359-7,958</a:t>
+                        <a:t>1,825</a:t>
                       </a:r>
                     </a:p>
                   </a:txBody>
@@ -4317,7 +4317,7 @@
                 </a:tc>
                 <a:extLst>
                   <a:ext uri="{0D108BD9-81ED-4DB2-BD59-A6C34878D82A}">
-                    <a16:rowId xmlns:a16="http://schemas.microsoft.com/office/drawing/2014/main" val="2521531638"/>
+                    <a16:rowId xmlns:a16="http://schemas.microsoft.com/office/drawing/2014/main" val="2475872233"/>
                   </a:ext>
                 </a:extLst>
               </a:tr>
@@ -4330,7 +4330,7 @@
           <p:cNvPr id="6" name="TextBox 5">
             <a:extLst>
               <a:ext uri="{FF2B5EF4-FFF2-40B4-BE49-F238E27FC236}">
-                <a16:creationId xmlns:a16="http://schemas.microsoft.com/office/drawing/2014/main" id="{DF5B357D-816D-A514-50DC-33C333671D2B}"/>
+                <a16:creationId xmlns:a16="http://schemas.microsoft.com/office/drawing/2014/main" id="{4B47474D-054A-5F7E-647D-9E4C18815C75}"/>
               </a:ext>
             </a:extLst>
           </p:cNvPr>
@@ -4360,7 +4360,7 @@
                 </a:solidFill>
                 <a:latin typeface="Calibri" panose="020F0502020204030204" pitchFamily="34" charset="0"/>
               </a:rPr>
-              <a:t>OLAP returns identical 432 category rows; CPU up to ~4x lower than querying OLTP directly</a:t>
+              <a:t>OLAP returns identical 842 aggregation rows; CPU ~5x lower than querying OLTP directly</a:t>
             </a:r>
             <a:br>
               <a:rPr lang="en-US" sz="1600">
@@ -4394,7 +4394,7 @@
                 </a:solidFill>
                 <a:latin typeface="Calibri" panose="020F0502020204030204" pitchFamily="34" charset="0"/>
               </a:rPr>
-              <a:t>Full-cache lookups (295 products, 407 customers, date caches) - validated once</a:t>
+              <a:t>Full-cache lookups (302 products, 412 customers, date caches) - validated once</a:t>
             </a:r>
             <a:br>
               <a:rPr lang="en-US" sz="1600">
@@ -4419,7 +4419,7 @@
     </p:spTree>
     <p:extLst>
       <p:ext uri="{BB962C8B-B14F-4D97-AF65-F5344CB8AC3E}">
-        <p14:creationId xmlns:p14="http://schemas.microsoft.com/office/powerpoint/2010/main" val="1908238006"/>
+        <p14:creationId xmlns:p14="http://schemas.microsoft.com/office/powerpoint/2010/main" val="2203819573"/>
       </p:ext>
     </p:extLst>
   </p:cSld>
@@ -4451,7 +4451,7 @@
           <p:cNvPr id="2" name="Rectangle: Rounded Corners 1">
             <a:extLst>
               <a:ext uri="{FF2B5EF4-FFF2-40B4-BE49-F238E27FC236}">
-                <a16:creationId xmlns:a16="http://schemas.microsoft.com/office/drawing/2014/main" id="{B1F3D830-8910-6C70-F55C-7D15108A6854}"/>
+                <a16:creationId xmlns:a16="http://schemas.microsoft.com/office/drawing/2014/main" id="{DF55947B-7CD4-CC48-5A4E-4604BE3F50EF}"/>
               </a:ext>
             </a:extLst>
           </p:cNvPr>
@@ -4519,7 +4519,7 @@
           <p:cNvPr id="3" name="TextBox 2">
             <a:extLst>
               <a:ext uri="{FF2B5EF4-FFF2-40B4-BE49-F238E27FC236}">
-                <a16:creationId xmlns:a16="http://schemas.microsoft.com/office/drawing/2014/main" id="{329F7737-89E9-16CF-5C20-1B6625B54324}"/>
+                <a16:creationId xmlns:a16="http://schemas.microsoft.com/office/drawing/2014/main" id="{110F44A8-8D91-8265-71B9-DF5156606EF9}"/>
               </a:ext>
             </a:extLst>
           </p:cNvPr>
@@ -4559,7 +4559,7 @@
           <p:cNvPr id="4" name="TextBox 3">
             <a:extLst>
               <a:ext uri="{FF2B5EF4-FFF2-40B4-BE49-F238E27FC236}">
-                <a16:creationId xmlns:a16="http://schemas.microsoft.com/office/drawing/2014/main" id="{D3F9ECA2-4DD9-0D36-D1FD-6BD350445DEE}"/>
+                <a16:creationId xmlns:a16="http://schemas.microsoft.com/office/drawing/2014/main" id="{A19B3918-04C4-CF75-8345-655AEC9F54C9}"/>
               </a:ext>
             </a:extLst>
           </p:cNvPr>
@@ -4751,7 +4751,7 @@
     </p:spTree>
     <p:extLst>
       <p:ext uri="{BB962C8B-B14F-4D97-AF65-F5344CB8AC3E}">
-        <p14:creationId xmlns:p14="http://schemas.microsoft.com/office/powerpoint/2010/main" val="735716658"/>
+        <p14:creationId xmlns:p14="http://schemas.microsoft.com/office/powerpoint/2010/main" val="213657675"/>
       </p:ext>
     </p:extLst>
   </p:cSld>
@@ -4783,7 +4783,7 @@
           <p:cNvPr id="2" name="Rectangle: Rounded Corners 1">
             <a:extLst>
               <a:ext uri="{FF2B5EF4-FFF2-40B4-BE49-F238E27FC236}">
-                <a16:creationId xmlns:a16="http://schemas.microsoft.com/office/drawing/2014/main" id="{7CEF2089-BAA8-58A0-F10A-1963F0C1F325}"/>
+                <a16:creationId xmlns:a16="http://schemas.microsoft.com/office/drawing/2014/main" id="{BC6CF6A1-9C1D-B7CD-D0A5-AF1DF065E6D5}"/>
               </a:ext>
             </a:extLst>
           </p:cNvPr>
@@ -4851,7 +4851,7 @@
           <p:cNvPr id="3" name="TextBox 2">
             <a:extLst>
               <a:ext uri="{FF2B5EF4-FFF2-40B4-BE49-F238E27FC236}">
-                <a16:creationId xmlns:a16="http://schemas.microsoft.com/office/drawing/2014/main" id="{28956E26-004D-C5D4-AB6F-149AF613D0D7}"/>
+                <a16:creationId xmlns:a16="http://schemas.microsoft.com/office/drawing/2014/main" id="{289A0F06-1C49-64EE-87FC-487EB7A35B9A}"/>
               </a:ext>
             </a:extLst>
           </p:cNvPr>
@@ -4891,7 +4891,7 @@
           <p:cNvPr id="4" name="Table 3">
             <a:extLst>
               <a:ext uri="{FF2B5EF4-FFF2-40B4-BE49-F238E27FC236}">
-                <a16:creationId xmlns:a16="http://schemas.microsoft.com/office/drawing/2014/main" id="{B4DCAB6F-F54A-7C7E-96FF-34BE2F460A83}"/>
+                <a16:creationId xmlns:a16="http://schemas.microsoft.com/office/drawing/2014/main" id="{1C54F320-4BB7-D382-0FFE-32A37BA9DCD8}"/>
               </a:ext>
             </a:extLst>
           </p:cNvPr>
@@ -4901,7 +4901,7 @@
           <p:nvPr>
             <p:extLst>
               <p:ext uri="{D42A27DB-BD31-4B8C-83A1-F6EECF244321}">
-                <p14:modId xmlns:p14="http://schemas.microsoft.com/office/powerpoint/2010/main" val="2547049887"/>
+                <p14:modId xmlns:p14="http://schemas.microsoft.com/office/powerpoint/2010/main" val="2466627079"/>
               </p:ext>
             </p:extLst>
           </p:nvPr>
@@ -4920,21 +4920,21 @@
                 <a:gridCol w="3429000">
                   <a:extLst>
                     <a:ext uri="{9D8B030D-6E8A-4147-A177-3AD203B41FA5}">
-                      <a16:colId xmlns:a16="http://schemas.microsoft.com/office/drawing/2014/main" val="4149676103"/>
+                      <a16:colId xmlns:a16="http://schemas.microsoft.com/office/drawing/2014/main" val="2325588498"/>
                     </a:ext>
                   </a:extLst>
                 </a:gridCol>
                 <a:gridCol w="4191000">
                   <a:extLst>
                     <a:ext uri="{9D8B030D-6E8A-4147-A177-3AD203B41FA5}">
-                      <a16:colId xmlns:a16="http://schemas.microsoft.com/office/drawing/2014/main" val="2694156483"/>
+                      <a16:colId xmlns:a16="http://schemas.microsoft.com/office/drawing/2014/main" val="3458950605"/>
                     </a:ext>
                   </a:extLst>
                 </a:gridCol>
                 <a:gridCol w="3048000">
                   <a:extLst>
                     <a:ext uri="{9D8B030D-6E8A-4147-A177-3AD203B41FA5}">
-                      <a16:colId xmlns:a16="http://schemas.microsoft.com/office/drawing/2014/main" val="1006667311"/>
+                      <a16:colId xmlns:a16="http://schemas.microsoft.com/office/drawing/2014/main" val="143527301"/>
                     </a:ext>
                   </a:extLst>
                 </a:gridCol>
@@ -5008,7 +5008,7 @@
                 </a:tc>
                 <a:extLst>
                   <a:ext uri="{0D108BD9-81ED-4DB2-BD59-A6C34878D82A}">
-                    <a16:rowId xmlns:a16="http://schemas.microsoft.com/office/drawing/2014/main" val="3282840385"/>
+                    <a16:rowId xmlns:a16="http://schemas.microsoft.com/office/drawing/2014/main" val="2228860994"/>
                   </a:ext>
                 </a:extLst>
               </a:tr>
@@ -5081,7 +5081,7 @@
                 </a:tc>
                 <a:extLst>
                   <a:ext uri="{0D108BD9-81ED-4DB2-BD59-A6C34878D82A}">
-                    <a16:rowId xmlns:a16="http://schemas.microsoft.com/office/drawing/2014/main" val="613839832"/>
+                    <a16:rowId xmlns:a16="http://schemas.microsoft.com/office/drawing/2014/main" val="962890870"/>
                   </a:ext>
                 </a:extLst>
               </a:tr>
@@ -5142,7 +5142,7 @@
                 </a:tc>
                 <a:extLst>
                   <a:ext uri="{0D108BD9-81ED-4DB2-BD59-A6C34878D82A}">
-                    <a16:rowId xmlns:a16="http://schemas.microsoft.com/office/drawing/2014/main" val="1162216563"/>
+                    <a16:rowId xmlns:a16="http://schemas.microsoft.com/office/drawing/2014/main" val="1833617377"/>
                   </a:ext>
                 </a:extLst>
               </a:tr>
@@ -5215,7 +5215,7 @@
                 </a:tc>
                 <a:extLst>
                   <a:ext uri="{0D108BD9-81ED-4DB2-BD59-A6C34878D82A}">
-                    <a16:rowId xmlns:a16="http://schemas.microsoft.com/office/drawing/2014/main" val="2893679976"/>
+                    <a16:rowId xmlns:a16="http://schemas.microsoft.com/office/drawing/2014/main" val="842496027"/>
                   </a:ext>
                 </a:extLst>
               </a:tr>
@@ -5276,7 +5276,7 @@
                 </a:tc>
                 <a:extLst>
                   <a:ext uri="{0D108BD9-81ED-4DB2-BD59-A6C34878D82A}">
-                    <a16:rowId xmlns:a16="http://schemas.microsoft.com/office/drawing/2014/main" val="870384511"/>
+                    <a16:rowId xmlns:a16="http://schemas.microsoft.com/office/drawing/2014/main" val="240921486"/>
                   </a:ext>
                 </a:extLst>
               </a:tr>
@@ -5349,7 +5349,7 @@
                 </a:tc>
                 <a:extLst>
                   <a:ext uri="{0D108BD9-81ED-4DB2-BD59-A6C34878D82A}">
-                    <a16:rowId xmlns:a16="http://schemas.microsoft.com/office/drawing/2014/main" val="2727930287"/>
+                    <a16:rowId xmlns:a16="http://schemas.microsoft.com/office/drawing/2014/main" val="2405330720"/>
                   </a:ext>
                 </a:extLst>
               </a:tr>
@@ -5410,7 +5410,7 @@
                 </a:tc>
                 <a:extLst>
                   <a:ext uri="{0D108BD9-81ED-4DB2-BD59-A6C34878D82A}">
-                    <a16:rowId xmlns:a16="http://schemas.microsoft.com/office/drawing/2014/main" val="1779139540"/>
+                    <a16:rowId xmlns:a16="http://schemas.microsoft.com/office/drawing/2014/main" val="375073448"/>
                   </a:ext>
                 </a:extLst>
               </a:tr>
@@ -5423,7 +5423,7 @@
           <p:cNvPr id="5" name="TextBox 4">
             <a:extLst>
               <a:ext uri="{FF2B5EF4-FFF2-40B4-BE49-F238E27FC236}">
-                <a16:creationId xmlns:a16="http://schemas.microsoft.com/office/drawing/2014/main" id="{E14799D7-1A80-8EF6-8F5E-29170B9A7022}"/>
+                <a16:creationId xmlns:a16="http://schemas.microsoft.com/office/drawing/2014/main" id="{E80C5FA8-A002-40EA-B43D-2673C151C707}"/>
               </a:ext>
             </a:extLst>
           </p:cNvPr>
@@ -5478,7 +5478,7 @@
     </p:spTree>
     <p:extLst>
       <p:ext uri="{BB962C8B-B14F-4D97-AF65-F5344CB8AC3E}">
-        <p14:creationId xmlns:p14="http://schemas.microsoft.com/office/powerpoint/2010/main" val="3430698359"/>
+        <p14:creationId xmlns:p14="http://schemas.microsoft.com/office/powerpoint/2010/main" val="3421818447"/>
       </p:ext>
     </p:extLst>
   </p:cSld>
@@ -5510,7 +5510,7 @@
           <p:cNvPr id="2" name="Rectangle: Rounded Corners 1">
             <a:extLst>
               <a:ext uri="{FF2B5EF4-FFF2-40B4-BE49-F238E27FC236}">
-                <a16:creationId xmlns:a16="http://schemas.microsoft.com/office/drawing/2014/main" id="{7C0143F5-8FC3-3390-F983-DA545F9FF82F}"/>
+                <a16:creationId xmlns:a16="http://schemas.microsoft.com/office/drawing/2014/main" id="{769269BE-61D4-2F67-11A7-0C2E9CCDB750}"/>
               </a:ext>
             </a:extLst>
           </p:cNvPr>
@@ -5578,7 +5578,7 @@
           <p:cNvPr id="3" name="TextBox 2">
             <a:extLst>
               <a:ext uri="{FF2B5EF4-FFF2-40B4-BE49-F238E27FC236}">
-                <a16:creationId xmlns:a16="http://schemas.microsoft.com/office/drawing/2014/main" id="{58C106FE-98CD-7591-615A-DC1B4628DD90}"/>
+                <a16:creationId xmlns:a16="http://schemas.microsoft.com/office/drawing/2014/main" id="{758BE057-FA06-88F6-731C-A5F60BFA781A}"/>
               </a:ext>
             </a:extLst>
           </p:cNvPr>
@@ -5618,7 +5618,7 @@
           <p:cNvPr id="4" name="TextBox 3">
             <a:extLst>
               <a:ext uri="{FF2B5EF4-FFF2-40B4-BE49-F238E27FC236}">
-                <a16:creationId xmlns:a16="http://schemas.microsoft.com/office/drawing/2014/main" id="{BF2F4036-378A-B0A3-5B12-092A4CCA43ED}"/>
+                <a16:creationId xmlns:a16="http://schemas.microsoft.com/office/drawing/2014/main" id="{A8FFEDF3-0678-E410-D111-288088E03540}"/>
               </a:ext>
             </a:extLst>
           </p:cNvPr>
@@ -5724,7 +5724,7 @@
     </p:spTree>
     <p:extLst>
       <p:ext uri="{BB962C8B-B14F-4D97-AF65-F5344CB8AC3E}">
-        <p14:creationId xmlns:p14="http://schemas.microsoft.com/office/powerpoint/2010/main" val="3836570960"/>
+        <p14:creationId xmlns:p14="http://schemas.microsoft.com/office/powerpoint/2010/main" val="1226875219"/>
       </p:ext>
     </p:extLst>
   </p:cSld>
@@ -5756,7 +5756,7 @@
           <p:cNvPr id="2" name="Rectangle 1">
             <a:extLst>
               <a:ext uri="{FF2B5EF4-FFF2-40B4-BE49-F238E27FC236}">
-                <a16:creationId xmlns:a16="http://schemas.microsoft.com/office/drawing/2014/main" id="{4188E527-2391-FC85-8553-66C5EB4B41D7}"/>
+                <a16:creationId xmlns:a16="http://schemas.microsoft.com/office/drawing/2014/main" id="{4CEB9ADF-3047-7948-0A75-464BD06F9B82}"/>
               </a:ext>
             </a:extLst>
           </p:cNvPr>
@@ -5824,7 +5824,7 @@
           <p:cNvPr id="3" name="Rectangle 2">
             <a:extLst>
               <a:ext uri="{FF2B5EF4-FFF2-40B4-BE49-F238E27FC236}">
-                <a16:creationId xmlns:a16="http://schemas.microsoft.com/office/drawing/2014/main" id="{CCAC4888-466D-DBE2-325A-8BC59B3CA321}"/>
+                <a16:creationId xmlns:a16="http://schemas.microsoft.com/office/drawing/2014/main" id="{130BB6B0-4E5D-CD22-37A3-6EAF84E2C744}"/>
               </a:ext>
             </a:extLst>
           </p:cNvPr>
@@ -5892,7 +5892,7 @@
           <p:cNvPr id="4" name="TextBox 3">
             <a:extLst>
               <a:ext uri="{FF2B5EF4-FFF2-40B4-BE49-F238E27FC236}">
-                <a16:creationId xmlns:a16="http://schemas.microsoft.com/office/drawing/2014/main" id="{23BF6DD5-2AFC-29A5-8AF5-C74D04A9C674}"/>
+                <a16:creationId xmlns:a16="http://schemas.microsoft.com/office/drawing/2014/main" id="{F5778E0F-0615-A708-5F40-422347498B5C}"/>
               </a:ext>
             </a:extLst>
           </p:cNvPr>
@@ -5932,7 +5932,7 @@
           <p:cNvPr id="5" name="TextBox 4">
             <a:extLst>
               <a:ext uri="{FF2B5EF4-FFF2-40B4-BE49-F238E27FC236}">
-                <a16:creationId xmlns:a16="http://schemas.microsoft.com/office/drawing/2014/main" id="{9F1E1844-E4C1-F7DC-2494-705882F21478}"/>
+                <a16:creationId xmlns:a16="http://schemas.microsoft.com/office/drawing/2014/main" id="{42523B5D-6533-6EEF-4084-F1F0D18870F3}"/>
               </a:ext>
             </a:extLst>
           </p:cNvPr>
@@ -5970,7 +5970,7 @@
     </p:spTree>
     <p:extLst>
       <p:ext uri="{BB962C8B-B14F-4D97-AF65-F5344CB8AC3E}">
-        <p14:creationId xmlns:p14="http://schemas.microsoft.com/office/powerpoint/2010/main" val="2918234296"/>
+        <p14:creationId xmlns:p14="http://schemas.microsoft.com/office/powerpoint/2010/main" val="422642579"/>
       </p:ext>
     </p:extLst>
   </p:cSld>
@@ -6002,7 +6002,7 @@
           <p:cNvPr id="2" name="Rectangle: Rounded Corners 1">
             <a:extLst>
               <a:ext uri="{FF2B5EF4-FFF2-40B4-BE49-F238E27FC236}">
-                <a16:creationId xmlns:a16="http://schemas.microsoft.com/office/drawing/2014/main" id="{CC6E3A22-21ED-C3D9-E36F-77EB2C09A840}"/>
+                <a16:creationId xmlns:a16="http://schemas.microsoft.com/office/drawing/2014/main" id="{DAB13483-4FC1-B88A-D76F-5533500ADD04}"/>
               </a:ext>
             </a:extLst>
           </p:cNvPr>
@@ -6070,7 +6070,7 @@
           <p:cNvPr id="3" name="TextBox 2">
             <a:extLst>
               <a:ext uri="{FF2B5EF4-FFF2-40B4-BE49-F238E27FC236}">
-                <a16:creationId xmlns:a16="http://schemas.microsoft.com/office/drawing/2014/main" id="{6882B0A7-AF0F-2608-DE9E-0B9E4520F7AF}"/>
+                <a16:creationId xmlns:a16="http://schemas.microsoft.com/office/drawing/2014/main" id="{4328C943-DF88-8FCE-E91F-0385592FBD9E}"/>
               </a:ext>
             </a:extLst>
           </p:cNvPr>
@@ -6110,7 +6110,7 @@
           <p:cNvPr id="4" name="TextBox 3">
             <a:extLst>
               <a:ext uri="{FF2B5EF4-FFF2-40B4-BE49-F238E27FC236}">
-                <a16:creationId xmlns:a16="http://schemas.microsoft.com/office/drawing/2014/main" id="{F587A35C-42E1-E115-DF61-F7C32EC31960}"/>
+                <a16:creationId xmlns:a16="http://schemas.microsoft.com/office/drawing/2014/main" id="{F32308B5-F2FB-1F40-E7F1-12BCAD3C76DC}"/>
               </a:ext>
             </a:extLst>
           </p:cNvPr>
@@ -6318,7 +6318,7 @@
     </p:spTree>
     <p:extLst>
       <p:ext uri="{BB962C8B-B14F-4D97-AF65-F5344CB8AC3E}">
-        <p14:creationId xmlns:p14="http://schemas.microsoft.com/office/powerpoint/2010/main" val="2775478959"/>
+        <p14:creationId xmlns:p14="http://schemas.microsoft.com/office/powerpoint/2010/main" val="2701672636"/>
       </p:ext>
     </p:extLst>
   </p:cSld>
@@ -6350,7 +6350,7 @@
           <p:cNvPr id="2" name="Rectangle: Rounded Corners 1">
             <a:extLst>
               <a:ext uri="{FF2B5EF4-FFF2-40B4-BE49-F238E27FC236}">
-                <a16:creationId xmlns:a16="http://schemas.microsoft.com/office/drawing/2014/main" id="{770924FB-F7DD-CF8B-DBF7-09F64DBC500E}"/>
+                <a16:creationId xmlns:a16="http://schemas.microsoft.com/office/drawing/2014/main" id="{2F89BA2B-24EC-0FB2-7619-7AEF3EBC0DFC}"/>
               </a:ext>
             </a:extLst>
           </p:cNvPr>
@@ -6418,7 +6418,7 @@
           <p:cNvPr id="3" name="TextBox 2">
             <a:extLst>
               <a:ext uri="{FF2B5EF4-FFF2-40B4-BE49-F238E27FC236}">
-                <a16:creationId xmlns:a16="http://schemas.microsoft.com/office/drawing/2014/main" id="{316B7FE5-4E4A-5334-9B29-C17F4AC18B5D}"/>
+                <a16:creationId xmlns:a16="http://schemas.microsoft.com/office/drawing/2014/main" id="{6580F472-CE4D-35F8-4004-9EC079C1294B}"/>
               </a:ext>
             </a:extLst>
           </p:cNvPr>
@@ -6458,7 +6458,7 @@
           <p:cNvPr id="4" name="TextBox 3">
             <a:extLst>
               <a:ext uri="{FF2B5EF4-FFF2-40B4-BE49-F238E27FC236}">
-                <a16:creationId xmlns:a16="http://schemas.microsoft.com/office/drawing/2014/main" id="{080D87FC-FF7A-953F-BDFB-C2E5EB8146C6}"/>
+                <a16:creationId xmlns:a16="http://schemas.microsoft.com/office/drawing/2014/main" id="{968D318B-F8A6-3FC0-A02B-2137D4725416}"/>
               </a:ext>
             </a:extLst>
           </p:cNvPr>
@@ -6493,8 +6493,8 @@
               </a:rPr>
               <a:t>AdventureWorks-OLTP
 (SalesLT source)
-450 Address / 407 Customer
-17,000 Orders / 277,880 OrderDetails</a:t>
+450 Address / 412 Customer
+22,000 Orders / 353,505 OrderDetails</a:t>
             </a:r>
           </a:p>
         </p:txBody>
@@ -6504,7 +6504,7 @@
           <p:cNvPr id="5" name="TextBox 4">
             <a:extLst>
               <a:ext uri="{FF2B5EF4-FFF2-40B4-BE49-F238E27FC236}">
-                <a16:creationId xmlns:a16="http://schemas.microsoft.com/office/drawing/2014/main" id="{022A38B6-616B-499A-85D8-A8F2DDFAEAEA}"/>
+                <a16:creationId xmlns:a16="http://schemas.microsoft.com/office/drawing/2014/main" id="{B8EA6484-A4DF-AEF1-0209-F6E0820BE64B}"/>
               </a:ext>
             </a:extLst>
           </p:cNvPr>
@@ -6549,7 +6549,7 @@
           <p:cNvPr id="6" name="TextBox 5">
             <a:extLst>
               <a:ext uri="{FF2B5EF4-FFF2-40B4-BE49-F238E27FC236}">
-                <a16:creationId xmlns:a16="http://schemas.microsoft.com/office/drawing/2014/main" id="{EDBC899E-0C95-0492-BA6E-3A515B678D46}"/>
+                <a16:creationId xmlns:a16="http://schemas.microsoft.com/office/drawing/2014/main" id="{FEB22198-5F88-5199-D9BA-F43A1A2540A7}"/>
               </a:ext>
             </a:extLst>
           </p:cNvPr>
@@ -6594,7 +6594,7 @@
           <p:cNvPr id="7" name="Arrow: Right 6">
             <a:extLst>
               <a:ext uri="{FF2B5EF4-FFF2-40B4-BE49-F238E27FC236}">
-                <a16:creationId xmlns:a16="http://schemas.microsoft.com/office/drawing/2014/main" id="{DEE2EFC8-2D97-EDAE-8F04-6118C0108AC5}"/>
+                <a16:creationId xmlns:a16="http://schemas.microsoft.com/office/drawing/2014/main" id="{BFD3D460-FCB9-DB33-21BF-ECB565B3171A}"/>
               </a:ext>
             </a:extLst>
           </p:cNvPr>
@@ -6662,7 +6662,7 @@
           <p:cNvPr id="8" name="Arrow: Right 7">
             <a:extLst>
               <a:ext uri="{FF2B5EF4-FFF2-40B4-BE49-F238E27FC236}">
-                <a16:creationId xmlns:a16="http://schemas.microsoft.com/office/drawing/2014/main" id="{20FC7913-DD93-C5AD-58F8-95A3AB487E4E}"/>
+                <a16:creationId xmlns:a16="http://schemas.microsoft.com/office/drawing/2014/main" id="{A84A60FA-9BD4-6C4E-78D5-C2947950798C}"/>
               </a:ext>
             </a:extLst>
           </p:cNvPr>
@@ -6730,7 +6730,7 @@
           <p:cNvPr id="9" name="TextBox 8">
             <a:extLst>
               <a:ext uri="{FF2B5EF4-FFF2-40B4-BE49-F238E27FC236}">
-                <a16:creationId xmlns:a16="http://schemas.microsoft.com/office/drawing/2014/main" id="{B9B0D5B2-9468-D057-074F-401D66082325}"/>
+                <a16:creationId xmlns:a16="http://schemas.microsoft.com/office/drawing/2014/main" id="{6527DBDA-B62F-336A-90AA-E8D61B786F97}"/>
               </a:ext>
             </a:extLst>
           </p:cNvPr>
@@ -6773,7 +6773,7 @@
           <p:cNvPr id="10" name="TextBox 9">
             <a:extLst>
               <a:ext uri="{FF2B5EF4-FFF2-40B4-BE49-F238E27FC236}">
-                <a16:creationId xmlns:a16="http://schemas.microsoft.com/office/drawing/2014/main" id="{4E4A2270-A437-4AA4-044A-4D586292A177}"/>
+                <a16:creationId xmlns:a16="http://schemas.microsoft.com/office/drawing/2014/main" id="{E3160348-F355-216E-CD41-CEA7ED0581F1}"/>
               </a:ext>
             </a:extLst>
           </p:cNvPr>
@@ -6862,7 +6862,7 @@
     </p:spTree>
     <p:extLst>
       <p:ext uri="{BB962C8B-B14F-4D97-AF65-F5344CB8AC3E}">
-        <p14:creationId xmlns:p14="http://schemas.microsoft.com/office/powerpoint/2010/main" val="2882329582"/>
+        <p14:creationId xmlns:p14="http://schemas.microsoft.com/office/powerpoint/2010/main" val="4117913416"/>
       </p:ext>
     </p:extLst>
   </p:cSld>
@@ -6894,7 +6894,7 @@
           <p:cNvPr id="2" name="Rectangle: Rounded Corners 1">
             <a:extLst>
               <a:ext uri="{FF2B5EF4-FFF2-40B4-BE49-F238E27FC236}">
-                <a16:creationId xmlns:a16="http://schemas.microsoft.com/office/drawing/2014/main" id="{EF9EBF94-6CF8-0B5A-6CA7-E067A0D7E8E4}"/>
+                <a16:creationId xmlns:a16="http://schemas.microsoft.com/office/drawing/2014/main" id="{519D3FFD-4D95-FD1F-042E-020D97109E41}"/>
               </a:ext>
             </a:extLst>
           </p:cNvPr>
@@ -6962,7 +6962,7 @@
           <p:cNvPr id="3" name="TextBox 2">
             <a:extLst>
               <a:ext uri="{FF2B5EF4-FFF2-40B4-BE49-F238E27FC236}">
-                <a16:creationId xmlns:a16="http://schemas.microsoft.com/office/drawing/2014/main" id="{DB1AF7B0-12A3-20EC-31A6-59DB57202EF5}"/>
+                <a16:creationId xmlns:a16="http://schemas.microsoft.com/office/drawing/2014/main" id="{6B563316-D7E8-0333-9867-C3A42A1477E8}"/>
               </a:ext>
             </a:extLst>
           </p:cNvPr>
@@ -7002,7 +7002,7 @@
           <p:cNvPr id="4" name="Table 3">
             <a:extLst>
               <a:ext uri="{FF2B5EF4-FFF2-40B4-BE49-F238E27FC236}">
-                <a16:creationId xmlns:a16="http://schemas.microsoft.com/office/drawing/2014/main" id="{156A06E6-8255-C578-EF72-77285B1C4B4F}"/>
+                <a16:creationId xmlns:a16="http://schemas.microsoft.com/office/drawing/2014/main" id="{0B7BA938-C03A-A906-7FEF-147978514742}"/>
               </a:ext>
             </a:extLst>
           </p:cNvPr>
@@ -7012,7 +7012,7 @@
           <p:nvPr>
             <p:extLst>
               <p:ext uri="{D42A27DB-BD31-4B8C-83A1-F6EECF244321}">
-                <p14:modId xmlns:p14="http://schemas.microsoft.com/office/powerpoint/2010/main" val="1622637576"/>
+                <p14:modId xmlns:p14="http://schemas.microsoft.com/office/powerpoint/2010/main" val="3641913816"/>
               </p:ext>
             </p:extLst>
           </p:nvPr>
@@ -7031,21 +7031,21 @@
                 <a:gridCol w="3048000">
                   <a:extLst>
                     <a:ext uri="{9D8B030D-6E8A-4147-A177-3AD203B41FA5}">
-                      <a16:colId xmlns:a16="http://schemas.microsoft.com/office/drawing/2014/main" val="474506419"/>
+                      <a16:colId xmlns:a16="http://schemas.microsoft.com/office/drawing/2014/main" val="2828771917"/>
                     </a:ext>
                   </a:extLst>
                 </a:gridCol>
                 <a:gridCol w="4064000">
                   <a:extLst>
                     <a:ext uri="{9D8B030D-6E8A-4147-A177-3AD203B41FA5}">
-                      <a16:colId xmlns:a16="http://schemas.microsoft.com/office/drawing/2014/main" val="108796679"/>
+                      <a16:colId xmlns:a16="http://schemas.microsoft.com/office/drawing/2014/main" val="1564062066"/>
                     </a:ext>
                   </a:extLst>
                 </a:gridCol>
                 <a:gridCol w="1778000">
                   <a:extLst>
                     <a:ext uri="{9D8B030D-6E8A-4147-A177-3AD203B41FA5}">
-                      <a16:colId xmlns:a16="http://schemas.microsoft.com/office/drawing/2014/main" val="1837972860"/>
+                      <a16:colId xmlns:a16="http://schemas.microsoft.com/office/drawing/2014/main" val="3984372809"/>
                     </a:ext>
                   </a:extLst>
                 </a:gridCol>
@@ -7119,7 +7119,7 @@
                 </a:tc>
                 <a:extLst>
                   <a:ext uri="{0D108BD9-81ED-4DB2-BD59-A6C34878D82A}">
-                    <a16:rowId xmlns:a16="http://schemas.microsoft.com/office/drawing/2014/main" val="2319520071"/>
+                    <a16:rowId xmlns:a16="http://schemas.microsoft.com/office/drawing/2014/main" val="686977832"/>
                   </a:ext>
                 </a:extLst>
               </a:tr>
@@ -7192,7 +7192,7 @@
                 </a:tc>
                 <a:extLst>
                   <a:ext uri="{0D108BD9-81ED-4DB2-BD59-A6C34878D82A}">
-                    <a16:rowId xmlns:a16="http://schemas.microsoft.com/office/drawing/2014/main" val="1427772711"/>
+                    <a16:rowId xmlns:a16="http://schemas.microsoft.com/office/drawing/2014/main" val="807670005"/>
                   </a:ext>
                 </a:extLst>
               </a:tr>
@@ -7245,7 +7245,7 @@
                           </a:solidFill>
                           <a:latin typeface="Calibri" panose="020F0502020204030204" pitchFamily="34" charset="0"/>
                         </a:rPr>
-                        <a:t>407</a:t>
+                        <a:t>412</a:t>
                       </a:r>
                     </a:p>
                   </a:txBody>
@@ -7253,7 +7253,7 @@
                 </a:tc>
                 <a:extLst>
                   <a:ext uri="{0D108BD9-81ED-4DB2-BD59-A6C34878D82A}">
-                    <a16:rowId xmlns:a16="http://schemas.microsoft.com/office/drawing/2014/main" val="315740898"/>
+                    <a16:rowId xmlns:a16="http://schemas.microsoft.com/office/drawing/2014/main" val="807928738"/>
                   </a:ext>
                 </a:extLst>
               </a:tr>
@@ -7314,7 +7314,7 @@
                           </a:solidFill>
                           <a:latin typeface="Calibri" panose="020F0502020204030204" pitchFamily="34" charset="0"/>
                         </a:rPr>
-                        <a:t>17,000</a:t>
+                        <a:t>22,000</a:t>
                       </a:r>
                     </a:p>
                   </a:txBody>
@@ -7326,7 +7326,7 @@
                 </a:tc>
                 <a:extLst>
                   <a:ext uri="{0D108BD9-81ED-4DB2-BD59-A6C34878D82A}">
-                    <a16:rowId xmlns:a16="http://schemas.microsoft.com/office/drawing/2014/main" val="1076141791"/>
+                    <a16:rowId xmlns:a16="http://schemas.microsoft.com/office/drawing/2014/main" val="4024345277"/>
                   </a:ext>
                 </a:extLst>
               </a:tr>
@@ -7379,7 +7379,7 @@
                           </a:solidFill>
                           <a:latin typeface="Calibri" panose="020F0502020204030204" pitchFamily="34" charset="0"/>
                         </a:rPr>
-                        <a:t>277,880</a:t>
+                        <a:t>353,505</a:t>
                       </a:r>
                     </a:p>
                   </a:txBody>
@@ -7387,7 +7387,7 @@
                 </a:tc>
                 <a:extLst>
                   <a:ext uri="{0D108BD9-81ED-4DB2-BD59-A6C34878D82A}">
-                    <a16:rowId xmlns:a16="http://schemas.microsoft.com/office/drawing/2014/main" val="24391164"/>
+                    <a16:rowId xmlns:a16="http://schemas.microsoft.com/office/drawing/2014/main" val="4149482362"/>
                   </a:ext>
                 </a:extLst>
               </a:tr>
@@ -7400,7 +7400,7 @@
           <p:cNvPr id="5" name="TextBox 4">
             <a:extLst>
               <a:ext uri="{FF2B5EF4-FFF2-40B4-BE49-F238E27FC236}">
-                <a16:creationId xmlns:a16="http://schemas.microsoft.com/office/drawing/2014/main" id="{ACC2BAF0-EC87-A118-8A02-DDFAEC026C6C}"/>
+                <a16:creationId xmlns:a16="http://schemas.microsoft.com/office/drawing/2014/main" id="{009A5B72-3968-7C5A-8937-013F28C33CD3}"/>
               </a:ext>
             </a:extLst>
           </p:cNvPr>
@@ -7481,7 +7481,7 @@
                 </a:solidFill>
                 <a:latin typeface="Calibri" panose="020F0502020204030204" pitchFamily="34" charset="0"/>
               </a:rPr>
-              <a:t>Lookup tables (AddressType, Culture) joined during extraction</a:t>
+              <a:t>V2 simulation added +5,000 orders / +75,625 details / +5 products / +5 customers after Run I</a:t>
             </a:r>
           </a:p>
         </p:txBody>
@@ -7489,7 +7489,7 @@
     </p:spTree>
     <p:extLst>
       <p:ext uri="{BB962C8B-B14F-4D97-AF65-F5344CB8AC3E}">
-        <p14:creationId xmlns:p14="http://schemas.microsoft.com/office/powerpoint/2010/main" val="1697384335"/>
+        <p14:creationId xmlns:p14="http://schemas.microsoft.com/office/powerpoint/2010/main" val="2009857981"/>
       </p:ext>
     </p:extLst>
   </p:cSld>
@@ -7521,7 +7521,7 @@
           <p:cNvPr id="2" name="Rectangle: Rounded Corners 1">
             <a:extLst>
               <a:ext uri="{FF2B5EF4-FFF2-40B4-BE49-F238E27FC236}">
-                <a16:creationId xmlns:a16="http://schemas.microsoft.com/office/drawing/2014/main" id="{58C4F230-C749-6BFB-B542-B419822201CB}"/>
+                <a16:creationId xmlns:a16="http://schemas.microsoft.com/office/drawing/2014/main" id="{D1F1F89B-C201-B8FD-4EA6-B6444A525325}"/>
               </a:ext>
             </a:extLst>
           </p:cNvPr>
@@ -7589,7 +7589,7 @@
           <p:cNvPr id="3" name="TextBox 2">
             <a:extLst>
               <a:ext uri="{FF2B5EF4-FFF2-40B4-BE49-F238E27FC236}">
-                <a16:creationId xmlns:a16="http://schemas.microsoft.com/office/drawing/2014/main" id="{17F7A2DC-D8E8-8D3F-55C1-77BA0AC156EE}"/>
+                <a16:creationId xmlns:a16="http://schemas.microsoft.com/office/drawing/2014/main" id="{6B957017-8865-91F8-F707-5D614491F5CB}"/>
               </a:ext>
             </a:extLst>
           </p:cNvPr>
@@ -7629,7 +7629,7 @@
           <p:cNvPr id="4" name="Table 3">
             <a:extLst>
               <a:ext uri="{FF2B5EF4-FFF2-40B4-BE49-F238E27FC236}">
-                <a16:creationId xmlns:a16="http://schemas.microsoft.com/office/drawing/2014/main" id="{7985BBD1-E00E-F84C-7B38-E1D3AD4574D8}"/>
+                <a16:creationId xmlns:a16="http://schemas.microsoft.com/office/drawing/2014/main" id="{FF5B949D-46C3-FBD9-36E0-1BB8EEEEAAE7}"/>
               </a:ext>
             </a:extLst>
           </p:cNvPr>
@@ -7639,7 +7639,7 @@
           <p:nvPr>
             <p:extLst>
               <p:ext uri="{D42A27DB-BD31-4B8C-83A1-F6EECF244321}">
-                <p14:modId xmlns:p14="http://schemas.microsoft.com/office/powerpoint/2010/main" val="3101569552"/>
+                <p14:modId xmlns:p14="http://schemas.microsoft.com/office/powerpoint/2010/main" val="2044435789"/>
               </p:ext>
             </p:extLst>
           </p:nvPr>
@@ -7658,14 +7658,14 @@
                 <a:gridCol w="3810000">
                   <a:extLst>
                     <a:ext uri="{9D8B030D-6E8A-4147-A177-3AD203B41FA5}">
-                      <a16:colId xmlns:a16="http://schemas.microsoft.com/office/drawing/2014/main" val="2765994299"/>
+                      <a16:colId xmlns:a16="http://schemas.microsoft.com/office/drawing/2014/main" val="3907983324"/>
                     </a:ext>
                   </a:extLst>
                 </a:gridCol>
                 <a:gridCol w="4064000">
                   <a:extLst>
                     <a:ext uri="{9D8B030D-6E8A-4147-A177-3AD203B41FA5}">
-                      <a16:colId xmlns:a16="http://schemas.microsoft.com/office/drawing/2014/main" val="981800373"/>
+                      <a16:colId xmlns:a16="http://schemas.microsoft.com/office/drawing/2014/main" val="3408481591"/>
                     </a:ext>
                   </a:extLst>
                 </a:gridCol>
@@ -7717,7 +7717,7 @@
                 </a:tc>
                 <a:extLst>
                   <a:ext uri="{0D108BD9-81ED-4DB2-BD59-A6C34878D82A}">
-                    <a16:rowId xmlns:a16="http://schemas.microsoft.com/office/drawing/2014/main" val="2323096171"/>
+                    <a16:rowId xmlns:a16="http://schemas.microsoft.com/office/drawing/2014/main" val="2532301789"/>
                   </a:ext>
                 </a:extLst>
               </a:tr>
@@ -7768,7 +7768,7 @@
                 </a:tc>
                 <a:extLst>
                   <a:ext uri="{0D108BD9-81ED-4DB2-BD59-A6C34878D82A}">
-                    <a16:rowId xmlns:a16="http://schemas.microsoft.com/office/drawing/2014/main" val="2306329950"/>
+                    <a16:rowId xmlns:a16="http://schemas.microsoft.com/office/drawing/2014/main" val="2063632202"/>
                   </a:ext>
                 </a:extLst>
               </a:tr>
@@ -7811,7 +7811,7 @@
                 </a:tc>
                 <a:extLst>
                   <a:ext uri="{0D108BD9-81ED-4DB2-BD59-A6C34878D82A}">
-                    <a16:rowId xmlns:a16="http://schemas.microsoft.com/office/drawing/2014/main" val="1428259434"/>
+                    <a16:rowId xmlns:a16="http://schemas.microsoft.com/office/drawing/2014/main" val="48390989"/>
                   </a:ext>
                 </a:extLst>
               </a:tr>
@@ -7862,7 +7862,7 @@
                 </a:tc>
                 <a:extLst>
                   <a:ext uri="{0D108BD9-81ED-4DB2-BD59-A6C34878D82A}">
-                    <a16:rowId xmlns:a16="http://schemas.microsoft.com/office/drawing/2014/main" val="3877351035"/>
+                    <a16:rowId xmlns:a16="http://schemas.microsoft.com/office/drawing/2014/main" val="571864240"/>
                   </a:ext>
                 </a:extLst>
               </a:tr>
@@ -7905,7 +7905,7 @@
                 </a:tc>
                 <a:extLst>
                   <a:ext uri="{0D108BD9-81ED-4DB2-BD59-A6C34878D82A}">
-                    <a16:rowId xmlns:a16="http://schemas.microsoft.com/office/drawing/2014/main" val="2938557476"/>
+                    <a16:rowId xmlns:a16="http://schemas.microsoft.com/office/drawing/2014/main" val="3630664265"/>
                   </a:ext>
                 </a:extLst>
               </a:tr>
@@ -7956,7 +7956,7 @@
                 </a:tc>
                 <a:extLst>
                   <a:ext uri="{0D108BD9-81ED-4DB2-BD59-A6C34878D82A}">
-                    <a16:rowId xmlns:a16="http://schemas.microsoft.com/office/drawing/2014/main" val="2865243019"/>
+                    <a16:rowId xmlns:a16="http://schemas.microsoft.com/office/drawing/2014/main" val="2063415053"/>
                   </a:ext>
                 </a:extLst>
               </a:tr>
@@ -7999,7 +7999,7 @@
                 </a:tc>
                 <a:extLst>
                   <a:ext uri="{0D108BD9-81ED-4DB2-BD59-A6C34878D82A}">
-                    <a16:rowId xmlns:a16="http://schemas.microsoft.com/office/drawing/2014/main" val="3740079547"/>
+                    <a16:rowId xmlns:a16="http://schemas.microsoft.com/office/drawing/2014/main" val="2695553465"/>
                   </a:ext>
                 </a:extLst>
               </a:tr>
@@ -8050,7 +8050,7 @@
                 </a:tc>
                 <a:extLst>
                   <a:ext uri="{0D108BD9-81ED-4DB2-BD59-A6C34878D82A}">
-                    <a16:rowId xmlns:a16="http://schemas.microsoft.com/office/drawing/2014/main" val="59560082"/>
+                    <a16:rowId xmlns:a16="http://schemas.microsoft.com/office/drawing/2014/main" val="1459574884"/>
                   </a:ext>
                 </a:extLst>
               </a:tr>
@@ -8093,7 +8093,7 @@
                 </a:tc>
                 <a:extLst>
                   <a:ext uri="{0D108BD9-81ED-4DB2-BD59-A6C34878D82A}">
-                    <a16:rowId xmlns:a16="http://schemas.microsoft.com/office/drawing/2014/main" val="567188079"/>
+                    <a16:rowId xmlns:a16="http://schemas.microsoft.com/office/drawing/2014/main" val="1772433631"/>
                   </a:ext>
                 </a:extLst>
               </a:tr>
@@ -8144,7 +8144,7 @@
                 </a:tc>
                 <a:extLst>
                   <a:ext uri="{0D108BD9-81ED-4DB2-BD59-A6C34878D82A}">
-                    <a16:rowId xmlns:a16="http://schemas.microsoft.com/office/drawing/2014/main" val="3882843431"/>
+                    <a16:rowId xmlns:a16="http://schemas.microsoft.com/office/drawing/2014/main" val="3753302797"/>
                   </a:ext>
                 </a:extLst>
               </a:tr>
@@ -8187,7 +8187,7 @@
                 </a:tc>
                 <a:extLst>
                   <a:ext uri="{0D108BD9-81ED-4DB2-BD59-A6C34878D82A}">
-                    <a16:rowId xmlns:a16="http://schemas.microsoft.com/office/drawing/2014/main" val="833879581"/>
+                    <a16:rowId xmlns:a16="http://schemas.microsoft.com/office/drawing/2014/main" val="4247139267"/>
                   </a:ext>
                 </a:extLst>
               </a:tr>
@@ -8200,7 +8200,7 @@
           <p:cNvPr id="5" name="TextBox 4">
             <a:extLst>
               <a:ext uri="{FF2B5EF4-FFF2-40B4-BE49-F238E27FC236}">
-                <a16:creationId xmlns:a16="http://schemas.microsoft.com/office/drawing/2014/main" id="{DA5F9577-8604-A192-F9E3-136F2C79AA94}"/>
+                <a16:creationId xmlns:a16="http://schemas.microsoft.com/office/drawing/2014/main" id="{C776475D-F766-FBD8-F018-6D644E742847}"/>
               </a:ext>
             </a:extLst>
           </p:cNvPr>
@@ -8306,7 +8306,7 @@
     </p:spTree>
     <p:extLst>
       <p:ext uri="{BB962C8B-B14F-4D97-AF65-F5344CB8AC3E}">
-        <p14:creationId xmlns:p14="http://schemas.microsoft.com/office/powerpoint/2010/main" val="1216949122"/>
+        <p14:creationId xmlns:p14="http://schemas.microsoft.com/office/powerpoint/2010/main" val="2058578015"/>
       </p:ext>
     </p:extLst>
   </p:cSld>
@@ -8338,7 +8338,7 @@
           <p:cNvPr id="2" name="Rectangle: Rounded Corners 1">
             <a:extLst>
               <a:ext uri="{FF2B5EF4-FFF2-40B4-BE49-F238E27FC236}">
-                <a16:creationId xmlns:a16="http://schemas.microsoft.com/office/drawing/2014/main" id="{B6537DF4-6A3B-5D92-2430-6D0EAF0A50DF}"/>
+                <a16:creationId xmlns:a16="http://schemas.microsoft.com/office/drawing/2014/main" id="{4B4D777D-5B13-49B9-A573-8039C90C5FF5}"/>
               </a:ext>
             </a:extLst>
           </p:cNvPr>
@@ -8406,7 +8406,7 @@
           <p:cNvPr id="3" name="TextBox 2">
             <a:extLst>
               <a:ext uri="{FF2B5EF4-FFF2-40B4-BE49-F238E27FC236}">
-                <a16:creationId xmlns:a16="http://schemas.microsoft.com/office/drawing/2014/main" id="{9DD971A4-4B1F-CB8E-EDCF-789AD0F7C337}"/>
+                <a16:creationId xmlns:a16="http://schemas.microsoft.com/office/drawing/2014/main" id="{E3DAFF01-DFF3-E42A-4A02-9EAA994F6420}"/>
               </a:ext>
             </a:extLst>
           </p:cNvPr>
@@ -8446,7 +8446,7 @@
           <p:cNvPr id="4" name="Table 3">
             <a:extLst>
               <a:ext uri="{FF2B5EF4-FFF2-40B4-BE49-F238E27FC236}">
-                <a16:creationId xmlns:a16="http://schemas.microsoft.com/office/drawing/2014/main" id="{46DADFBC-C3F9-37BC-590A-8BA6E3FF8FCE}"/>
+                <a16:creationId xmlns:a16="http://schemas.microsoft.com/office/drawing/2014/main" id="{CD30F3AC-329F-86FB-F624-6FBA38E36D44}"/>
               </a:ext>
             </a:extLst>
           </p:cNvPr>
@@ -8456,7 +8456,7 @@
           <p:nvPr>
             <p:extLst>
               <p:ext uri="{D42A27DB-BD31-4B8C-83A1-F6EECF244321}">
-                <p14:modId xmlns:p14="http://schemas.microsoft.com/office/powerpoint/2010/main" val="3314221023"/>
+                <p14:modId xmlns:p14="http://schemas.microsoft.com/office/powerpoint/2010/main" val="3057065298"/>
               </p:ext>
             </p:extLst>
           </p:nvPr>
@@ -8475,21 +8475,21 @@
                 <a:gridCol w="2286000">
                   <a:extLst>
                     <a:ext uri="{9D8B030D-6E8A-4147-A177-3AD203B41FA5}">
-                      <a16:colId xmlns:a16="http://schemas.microsoft.com/office/drawing/2014/main" val="2100096330"/>
+                      <a16:colId xmlns:a16="http://schemas.microsoft.com/office/drawing/2014/main" val="1260929892"/>
                     </a:ext>
                   </a:extLst>
                 </a:gridCol>
                 <a:gridCol w="5842000">
                   <a:extLst>
                     <a:ext uri="{9D8B030D-6E8A-4147-A177-3AD203B41FA5}">
-                      <a16:colId xmlns:a16="http://schemas.microsoft.com/office/drawing/2014/main" val="2669267039"/>
+                      <a16:colId xmlns:a16="http://schemas.microsoft.com/office/drawing/2014/main" val="4178732974"/>
                     </a:ext>
                   </a:extLst>
                 </a:gridCol>
                 <a:gridCol w="1524000">
                   <a:extLst>
                     <a:ext uri="{9D8B030D-6E8A-4147-A177-3AD203B41FA5}">
-                      <a16:colId xmlns:a16="http://schemas.microsoft.com/office/drawing/2014/main" val="1925802440"/>
+                      <a16:colId xmlns:a16="http://schemas.microsoft.com/office/drawing/2014/main" val="1750755082"/>
                     </a:ext>
                   </a:extLst>
                 </a:gridCol>
@@ -8563,7 +8563,7 @@
                 </a:tc>
                 <a:extLst>
                   <a:ext uri="{0D108BD9-81ED-4DB2-BD59-A6C34878D82A}">
-                    <a16:rowId xmlns:a16="http://schemas.microsoft.com/office/drawing/2014/main" val="1274190073"/>
+                    <a16:rowId xmlns:a16="http://schemas.microsoft.com/office/drawing/2014/main" val="3578420557"/>
                   </a:ext>
                 </a:extLst>
               </a:tr>
@@ -8624,7 +8624,7 @@
                           </a:solidFill>
                           <a:latin typeface="Calibri" panose="020F0502020204030204" pitchFamily="34" charset="0"/>
                         </a:rPr>
-                        <a:t>407</a:t>
+                        <a:t>412</a:t>
                       </a:r>
                     </a:p>
                   </a:txBody>
@@ -8636,7 +8636,7 @@
                 </a:tc>
                 <a:extLst>
                   <a:ext uri="{0D108BD9-81ED-4DB2-BD59-A6C34878D82A}">
-                    <a16:rowId xmlns:a16="http://schemas.microsoft.com/office/drawing/2014/main" val="2910161360"/>
+                    <a16:rowId xmlns:a16="http://schemas.microsoft.com/office/drawing/2014/main" val="174121544"/>
                   </a:ext>
                 </a:extLst>
               </a:tr>
@@ -8689,7 +8689,7 @@
                           </a:solidFill>
                           <a:latin typeface="Calibri" panose="020F0502020204030204" pitchFamily="34" charset="0"/>
                         </a:rPr>
-                        <a:t>295</a:t>
+                        <a:t>302</a:t>
                       </a:r>
                     </a:p>
                   </a:txBody>
@@ -8697,7 +8697,7 @@
                 </a:tc>
                 <a:extLst>
                   <a:ext uri="{0D108BD9-81ED-4DB2-BD59-A6C34878D82A}">
-                    <a16:rowId xmlns:a16="http://schemas.microsoft.com/office/drawing/2014/main" val="2072378037"/>
+                    <a16:rowId xmlns:a16="http://schemas.microsoft.com/office/drawing/2014/main" val="3855072468"/>
                   </a:ext>
                 </a:extLst>
               </a:tr>
@@ -8758,7 +8758,7 @@
                           </a:solidFill>
                           <a:latin typeface="Calibri" panose="020F0502020204030204" pitchFamily="34" charset="0"/>
                         </a:rPr>
-                        <a:t>277,880</a:t>
+                        <a:t>353,505</a:t>
                       </a:r>
                     </a:p>
                   </a:txBody>
@@ -8770,7 +8770,7 @@
                 </a:tc>
                 <a:extLst>
                   <a:ext uri="{0D108BD9-81ED-4DB2-BD59-A6C34878D82A}">
-                    <a16:rowId xmlns:a16="http://schemas.microsoft.com/office/drawing/2014/main" val="2382531887"/>
+                    <a16:rowId xmlns:a16="http://schemas.microsoft.com/office/drawing/2014/main" val="565816554"/>
                   </a:ext>
                 </a:extLst>
               </a:tr>
@@ -8783,7 +8783,7 @@
           <p:cNvPr id="5" name="TextBox 4">
             <a:extLst>
               <a:ext uri="{FF2B5EF4-FFF2-40B4-BE49-F238E27FC236}">
-                <a16:creationId xmlns:a16="http://schemas.microsoft.com/office/drawing/2014/main" id="{B7A8866A-6A4F-AA19-9727-72216CA452EF}"/>
+                <a16:creationId xmlns:a16="http://schemas.microsoft.com/office/drawing/2014/main" id="{BF48B0C2-9763-B49D-C791-71C3082C4231}"/>
               </a:ext>
             </a:extLst>
           </p:cNvPr>
@@ -8906,7 +8906,7 @@
     </p:spTree>
     <p:extLst>
       <p:ext uri="{BB962C8B-B14F-4D97-AF65-F5344CB8AC3E}">
-        <p14:creationId xmlns:p14="http://schemas.microsoft.com/office/powerpoint/2010/main" val="597711356"/>
+        <p14:creationId xmlns:p14="http://schemas.microsoft.com/office/powerpoint/2010/main" val="3979165749"/>
       </p:ext>
     </p:extLst>
   </p:cSld>
@@ -8938,7 +8938,7 @@
           <p:cNvPr id="2" name="Rectangle: Rounded Corners 1">
             <a:extLst>
               <a:ext uri="{FF2B5EF4-FFF2-40B4-BE49-F238E27FC236}">
-                <a16:creationId xmlns:a16="http://schemas.microsoft.com/office/drawing/2014/main" id="{02E3458C-6D38-3D60-12FA-037DDA625117}"/>
+                <a16:creationId xmlns:a16="http://schemas.microsoft.com/office/drawing/2014/main" id="{18D8AEFD-2570-6F6B-DD3D-9E978027B275}"/>
               </a:ext>
             </a:extLst>
           </p:cNvPr>
@@ -9006,7 +9006,7 @@
           <p:cNvPr id="3" name="TextBox 2">
             <a:extLst>
               <a:ext uri="{FF2B5EF4-FFF2-40B4-BE49-F238E27FC236}">
-                <a16:creationId xmlns:a16="http://schemas.microsoft.com/office/drawing/2014/main" id="{778EF48B-E278-EA19-E78C-A1F2F85981AC}"/>
+                <a16:creationId xmlns:a16="http://schemas.microsoft.com/office/drawing/2014/main" id="{9D1973EA-FD37-BDA6-4216-9C2E5DE5909D}"/>
               </a:ext>
             </a:extLst>
           </p:cNvPr>
@@ -9046,7 +9046,7 @@
           <p:cNvPr id="4" name="TextBox 3">
             <a:extLst>
               <a:ext uri="{FF2B5EF4-FFF2-40B4-BE49-F238E27FC236}">
-                <a16:creationId xmlns:a16="http://schemas.microsoft.com/office/drawing/2014/main" id="{1B36B75A-A30C-450C-3215-F893C52E4588}"/>
+                <a16:creationId xmlns:a16="http://schemas.microsoft.com/office/drawing/2014/main" id="{35D88785-2173-8C39-29A6-8FC09D728FC7}"/>
               </a:ext>
             </a:extLst>
           </p:cNvPr>
@@ -9272,7 +9272,7 @@
     </p:spTree>
     <p:extLst>
       <p:ext uri="{BB962C8B-B14F-4D97-AF65-F5344CB8AC3E}">
-        <p14:creationId xmlns:p14="http://schemas.microsoft.com/office/powerpoint/2010/main" val="2148699518"/>
+        <p14:creationId xmlns:p14="http://schemas.microsoft.com/office/powerpoint/2010/main" val="3582961804"/>
       </p:ext>
     </p:extLst>
   </p:cSld>
@@ -9304,7 +9304,7 @@
           <p:cNvPr id="2" name="Rectangle: Rounded Corners 1">
             <a:extLst>
               <a:ext uri="{FF2B5EF4-FFF2-40B4-BE49-F238E27FC236}">
-                <a16:creationId xmlns:a16="http://schemas.microsoft.com/office/drawing/2014/main" id="{0E8936B9-4405-3C6F-B543-7D0F3C2AEC2A}"/>
+                <a16:creationId xmlns:a16="http://schemas.microsoft.com/office/drawing/2014/main" id="{C5613E6C-EEF6-3B7C-12FE-9879128B975B}"/>
               </a:ext>
             </a:extLst>
           </p:cNvPr>
@@ -9372,7 +9372,7 @@
           <p:cNvPr id="3" name="TextBox 2">
             <a:extLst>
               <a:ext uri="{FF2B5EF4-FFF2-40B4-BE49-F238E27FC236}">
-                <a16:creationId xmlns:a16="http://schemas.microsoft.com/office/drawing/2014/main" id="{E675749B-2CE4-1190-7A2B-8E22F0C51BAE}"/>
+                <a16:creationId xmlns:a16="http://schemas.microsoft.com/office/drawing/2014/main" id="{3F0306F1-259B-2856-9604-5F351BF5B259}"/>
               </a:ext>
             </a:extLst>
           </p:cNvPr>
@@ -9412,7 +9412,7 @@
           <p:cNvPr id="4" name="Table 3">
             <a:extLst>
               <a:ext uri="{FF2B5EF4-FFF2-40B4-BE49-F238E27FC236}">
-                <a16:creationId xmlns:a16="http://schemas.microsoft.com/office/drawing/2014/main" id="{7C953BFE-41DE-394C-C8EF-7DD6A1701A30}"/>
+                <a16:creationId xmlns:a16="http://schemas.microsoft.com/office/drawing/2014/main" id="{64096D70-6C81-5807-D68B-013C7DC84543}"/>
               </a:ext>
             </a:extLst>
           </p:cNvPr>
@@ -9422,7 +9422,7 @@
           <p:nvPr>
             <p:extLst>
               <p:ext uri="{D42A27DB-BD31-4B8C-83A1-F6EECF244321}">
-                <p14:modId xmlns:p14="http://schemas.microsoft.com/office/powerpoint/2010/main" val="3140419893"/>
+                <p14:modId xmlns:p14="http://schemas.microsoft.com/office/powerpoint/2010/main" val="3683663459"/>
               </p:ext>
             </p:extLst>
           </p:nvPr>
@@ -9441,28 +9441,28 @@
                 <a:gridCol w="1905000">
                   <a:extLst>
                     <a:ext uri="{9D8B030D-6E8A-4147-A177-3AD203B41FA5}">
-                      <a16:colId xmlns:a16="http://schemas.microsoft.com/office/drawing/2014/main" val="959137385"/>
+                      <a16:colId xmlns:a16="http://schemas.microsoft.com/office/drawing/2014/main" val="1675802288"/>
                     </a:ext>
                   </a:extLst>
                 </a:gridCol>
                 <a:gridCol w="1524000">
                   <a:extLst>
                     <a:ext uri="{9D8B030D-6E8A-4147-A177-3AD203B41FA5}">
-                      <a16:colId xmlns:a16="http://schemas.microsoft.com/office/drawing/2014/main" val="704101177"/>
+                      <a16:colId xmlns:a16="http://schemas.microsoft.com/office/drawing/2014/main" val="3741423599"/>
                     </a:ext>
                   </a:extLst>
                 </a:gridCol>
                 <a:gridCol w="4064000">
                   <a:extLst>
                     <a:ext uri="{9D8B030D-6E8A-4147-A177-3AD203B41FA5}">
-                      <a16:colId xmlns:a16="http://schemas.microsoft.com/office/drawing/2014/main" val="2830614756"/>
+                      <a16:colId xmlns:a16="http://schemas.microsoft.com/office/drawing/2014/main" val="2704949034"/>
                     </a:ext>
                   </a:extLst>
                 </a:gridCol>
                 <a:gridCol w="3175000">
                   <a:extLst>
                     <a:ext uri="{9D8B030D-6E8A-4147-A177-3AD203B41FA5}">
-                      <a16:colId xmlns:a16="http://schemas.microsoft.com/office/drawing/2014/main" val="3878511715"/>
+                      <a16:colId xmlns:a16="http://schemas.microsoft.com/office/drawing/2014/main" val="4156444565"/>
                     </a:ext>
                   </a:extLst>
                 </a:gridCol>
@@ -9558,7 +9558,7 @@
                 </a:tc>
                 <a:extLst>
                   <a:ext uri="{0D108BD9-81ED-4DB2-BD59-A6C34878D82A}">
-                    <a16:rowId xmlns:a16="http://schemas.microsoft.com/office/drawing/2014/main" val="3850281373"/>
+                    <a16:rowId xmlns:a16="http://schemas.microsoft.com/office/drawing/2014/main" val="2438427170"/>
                   </a:ext>
                 </a:extLst>
               </a:tr>
@@ -9653,7 +9653,7 @@
                 </a:tc>
                 <a:extLst>
                   <a:ext uri="{0D108BD9-81ED-4DB2-BD59-A6C34878D82A}">
-                    <a16:rowId xmlns:a16="http://schemas.microsoft.com/office/drawing/2014/main" val="2383408313"/>
+                    <a16:rowId xmlns:a16="http://schemas.microsoft.com/office/drawing/2014/main" val="1944682771"/>
                   </a:ext>
                 </a:extLst>
               </a:tr>
@@ -9732,7 +9732,7 @@
                 </a:tc>
                 <a:extLst>
                   <a:ext uri="{0D108BD9-81ED-4DB2-BD59-A6C34878D82A}">
-                    <a16:rowId xmlns:a16="http://schemas.microsoft.com/office/drawing/2014/main" val="3875649343"/>
+                    <a16:rowId xmlns:a16="http://schemas.microsoft.com/office/drawing/2014/main" val="2321625202"/>
                   </a:ext>
                 </a:extLst>
               </a:tr>
@@ -9745,7 +9745,7 @@
           <p:cNvPr id="5" name="TextBox 4">
             <a:extLst>
               <a:ext uri="{FF2B5EF4-FFF2-40B4-BE49-F238E27FC236}">
-                <a16:creationId xmlns:a16="http://schemas.microsoft.com/office/drawing/2014/main" id="{AFE0C5D4-0435-E99B-4F11-A0BB0C5ECFA5}"/>
+                <a16:creationId xmlns:a16="http://schemas.microsoft.com/office/drawing/2014/main" id="{24A11BC2-EB88-DC4E-511A-933DEDFD0587}"/>
               </a:ext>
             </a:extLst>
           </p:cNvPr>
@@ -9868,7 +9868,7 @@
     </p:spTree>
     <p:extLst>
       <p:ext uri="{BB962C8B-B14F-4D97-AF65-F5344CB8AC3E}">
-        <p14:creationId xmlns:p14="http://schemas.microsoft.com/office/powerpoint/2010/main" val="2212483692"/>
+        <p14:creationId xmlns:p14="http://schemas.microsoft.com/office/powerpoint/2010/main" val="1133207700"/>
       </p:ext>
     </p:extLst>
   </p:cSld>
@@ -9900,7 +9900,7 @@
           <p:cNvPr id="2" name="Rectangle: Rounded Corners 1">
             <a:extLst>
               <a:ext uri="{FF2B5EF4-FFF2-40B4-BE49-F238E27FC236}">
-                <a16:creationId xmlns:a16="http://schemas.microsoft.com/office/drawing/2014/main" id="{BE1445EA-39C4-D369-673C-15D3EC54F8CC}"/>
+                <a16:creationId xmlns:a16="http://schemas.microsoft.com/office/drawing/2014/main" id="{CD2D0BDB-8B8A-FEF4-49D1-5D6981D4AE34}"/>
               </a:ext>
             </a:extLst>
           </p:cNvPr>
@@ -9968,7 +9968,7 @@
           <p:cNvPr id="3" name="TextBox 2">
             <a:extLst>
               <a:ext uri="{FF2B5EF4-FFF2-40B4-BE49-F238E27FC236}">
-                <a16:creationId xmlns:a16="http://schemas.microsoft.com/office/drawing/2014/main" id="{1311DC33-470D-A5A5-62E3-932A4CE181A6}"/>
+                <a16:creationId xmlns:a16="http://schemas.microsoft.com/office/drawing/2014/main" id="{214B1D29-9EBD-B763-7A82-D8197799368D}"/>
               </a:ext>
             </a:extLst>
           </p:cNvPr>
@@ -10008,7 +10008,7 @@
           <p:cNvPr id="4" name="Table 3">
             <a:extLst>
               <a:ext uri="{FF2B5EF4-FFF2-40B4-BE49-F238E27FC236}">
-                <a16:creationId xmlns:a16="http://schemas.microsoft.com/office/drawing/2014/main" id="{6914666B-5373-ABB5-48AE-9C1AFCDF518B}"/>
+                <a16:creationId xmlns:a16="http://schemas.microsoft.com/office/drawing/2014/main" id="{EA258780-F9DF-EDFD-91B6-18E4AC84C215}"/>
               </a:ext>
             </a:extLst>
           </p:cNvPr>
@@ -10018,7 +10018,7 @@
           <p:nvPr>
             <p:extLst>
               <p:ext uri="{D42A27DB-BD31-4B8C-83A1-F6EECF244321}">
-                <p14:modId xmlns:p14="http://schemas.microsoft.com/office/powerpoint/2010/main" val="4131342732"/>
+                <p14:modId xmlns:p14="http://schemas.microsoft.com/office/powerpoint/2010/main" val="2394147073"/>
               </p:ext>
             </p:extLst>
           </p:nvPr>
@@ -10037,21 +10037,21 @@
                 <a:gridCol w="3048000">
                   <a:extLst>
                     <a:ext uri="{9D8B030D-6E8A-4147-A177-3AD203B41FA5}">
-                      <a16:colId xmlns:a16="http://schemas.microsoft.com/office/drawing/2014/main" val="1644612992"/>
+                      <a16:colId xmlns:a16="http://schemas.microsoft.com/office/drawing/2014/main" val="1804802252"/>
                     </a:ext>
                   </a:extLst>
                 </a:gridCol>
                 <a:gridCol w="4064000">
                   <a:extLst>
                     <a:ext uri="{9D8B030D-6E8A-4147-A177-3AD203B41FA5}">
-                      <a16:colId xmlns:a16="http://schemas.microsoft.com/office/drawing/2014/main" val="3619534964"/>
+                      <a16:colId xmlns:a16="http://schemas.microsoft.com/office/drawing/2014/main" val="3692010000"/>
                     </a:ext>
                   </a:extLst>
                 </a:gridCol>
                 <a:gridCol w="3048000">
                   <a:extLst>
                     <a:ext uri="{9D8B030D-6E8A-4147-A177-3AD203B41FA5}">
-                      <a16:colId xmlns:a16="http://schemas.microsoft.com/office/drawing/2014/main" val="1293579040"/>
+                      <a16:colId xmlns:a16="http://schemas.microsoft.com/office/drawing/2014/main" val="3212255664"/>
                     </a:ext>
                   </a:extLst>
                 </a:gridCol>
@@ -10125,7 +10125,7 @@
                 </a:tc>
                 <a:extLst>
                   <a:ext uri="{0D108BD9-81ED-4DB2-BD59-A6C34878D82A}">
-                    <a16:rowId xmlns:a16="http://schemas.microsoft.com/office/drawing/2014/main" val="3258761252"/>
+                    <a16:rowId xmlns:a16="http://schemas.microsoft.com/office/drawing/2014/main" val="753939888"/>
                   </a:ext>
                 </a:extLst>
               </a:tr>
@@ -10164,7 +10164,7 @@
                           </a:solidFill>
                           <a:latin typeface="Calibri" panose="020F0502020204030204" pitchFamily="34" charset="0"/>
                         </a:rPr>
-                        <a:t>= SalesOrderDetails 277,880</a:t>
+                        <a:t>= SalesOrderDetails 353,505</a:t>
                       </a:r>
                     </a:p>
                   </a:txBody>
@@ -10186,7 +10186,7 @@
                           </a:solidFill>
                           <a:latin typeface="Calibri" panose="020F0502020204030204" pitchFamily="34" charset="0"/>
                         </a:rPr>
-                        <a:t>277,880 (both runs)</a:t>
+                        <a:t>353,505</a:t>
                       </a:r>
                     </a:p>
                   </a:txBody>
@@ -10198,7 +10198,7 @@
                 </a:tc>
                 <a:extLst>
                   <a:ext uri="{0D108BD9-81ED-4DB2-BD59-A6C34878D82A}">
-                    <a16:rowId xmlns:a16="http://schemas.microsoft.com/office/drawing/2014/main" val="85862889"/>
+                    <a16:rowId xmlns:a16="http://schemas.microsoft.com/office/drawing/2014/main" val="4124278133"/>
                   </a:ext>
                 </a:extLst>
               </a:tr>
@@ -10259,7 +10259,7 @@
                 </a:tc>
                 <a:extLst>
                   <a:ext uri="{0D108BD9-81ED-4DB2-BD59-A6C34878D82A}">
-                    <a16:rowId xmlns:a16="http://schemas.microsoft.com/office/drawing/2014/main" val="1821477363"/>
+                    <a16:rowId xmlns:a16="http://schemas.microsoft.com/office/drawing/2014/main" val="2357062716"/>
                   </a:ext>
                 </a:extLst>
               </a:tr>
@@ -10298,7 +10298,7 @@
                           </a:solidFill>
                           <a:latin typeface="Calibri" panose="020F0502020204030204" pitchFamily="34" charset="0"/>
                         </a:rPr>
-                        <a:t>= distinct customers 407</a:t>
+                        <a:t>= distinct customers 412</a:t>
                       </a:r>
                     </a:p>
                   </a:txBody>
@@ -10320,7 +10320,7 @@
                           </a:solidFill>
                           <a:latin typeface="Calibri" panose="020F0502020204030204" pitchFamily="34" charset="0"/>
                         </a:rPr>
-                        <a:t>407</a:t>
+                        <a:t>412</a:t>
                       </a:r>
                     </a:p>
                   </a:txBody>
@@ -10332,7 +10332,7 @@
                 </a:tc>
                 <a:extLst>
                   <a:ext uri="{0D108BD9-81ED-4DB2-BD59-A6C34878D82A}">
-                    <a16:rowId xmlns:a16="http://schemas.microsoft.com/office/drawing/2014/main" val="1533255055"/>
+                    <a16:rowId xmlns:a16="http://schemas.microsoft.com/office/drawing/2014/main" val="3324160441"/>
                   </a:ext>
                 </a:extLst>
               </a:tr>
@@ -10367,7 +10367,7 @@
                           </a:solidFill>
                           <a:latin typeface="Calibri" panose="020F0502020204030204" pitchFamily="34" charset="0"/>
                         </a:rPr>
-                        <a:t>= distinct products 295</a:t>
+                        <a:t>= 295 base + 5 new + 2 SCD2 variants</a:t>
                       </a:r>
                     </a:p>
                   </a:txBody>
@@ -10385,7 +10385,7 @@
                           </a:solidFill>
                           <a:latin typeface="Calibri" panose="020F0502020204030204" pitchFamily="34" charset="0"/>
                         </a:rPr>
-                        <a:t>295</a:t>
+                        <a:t>302</a:t>
                       </a:r>
                     </a:p>
                   </a:txBody>
@@ -10393,7 +10393,7 @@
                 </a:tc>
                 <a:extLst>
                   <a:ext uri="{0D108BD9-81ED-4DB2-BD59-A6C34878D82A}">
-                    <a16:rowId xmlns:a16="http://schemas.microsoft.com/office/drawing/2014/main" val="1165232315"/>
+                    <a16:rowId xmlns:a16="http://schemas.microsoft.com/office/drawing/2014/main" val="506105496"/>
                   </a:ext>
                 </a:extLst>
               </a:tr>
@@ -10466,7 +10466,7 @@
                 </a:tc>
                 <a:extLst>
                   <a:ext uri="{0D108BD9-81ED-4DB2-BD59-A6C34878D82A}">
-                    <a16:rowId xmlns:a16="http://schemas.microsoft.com/office/drawing/2014/main" val="1254693046"/>
+                    <a16:rowId xmlns:a16="http://schemas.microsoft.com/office/drawing/2014/main" val="313598533"/>
                   </a:ext>
                 </a:extLst>
               </a:tr>
@@ -10527,7 +10527,7 @@
                 </a:tc>
                 <a:extLst>
                   <a:ext uri="{0D108BD9-81ED-4DB2-BD59-A6C34878D82A}">
-                    <a16:rowId xmlns:a16="http://schemas.microsoft.com/office/drawing/2014/main" val="803324762"/>
+                    <a16:rowId xmlns:a16="http://schemas.microsoft.com/office/drawing/2014/main" val="1189039428"/>
                   </a:ext>
                 </a:extLst>
               </a:tr>
@@ -10540,7 +10540,7 @@
           <p:cNvPr id="5" name="TextBox 4">
             <a:extLst>
               <a:ext uri="{FF2B5EF4-FFF2-40B4-BE49-F238E27FC236}">
-                <a16:creationId xmlns:a16="http://schemas.microsoft.com/office/drawing/2014/main" id="{9C4240B4-931E-1E5D-0A6C-39AB306963B9}"/>
+                <a16:creationId xmlns:a16="http://schemas.microsoft.com/office/drawing/2014/main" id="{0F254581-7C0C-A5EF-1B91-82D51B16EA1A}"/>
               </a:ext>
             </a:extLst>
           </p:cNvPr>
@@ -10550,7 +10550,7 @@
         <p:spPr>
           <a:xfrm>
             <a:off x="762000" y="4826000"/>
-            <a:ext cx="10668000" cy="1077218"/>
+            <a:ext cx="10668000" cy="1815882"/>
           </a:xfrm>
           <a:prstGeom prst="rect">
             <a:avLst/>
@@ -10587,7 +10587,7 @@
                 </a:solidFill>
                 <a:latin typeface="Calibri" panose="020F0502020204030204" pitchFamily="34" charset="0"/>
               </a:rPr>
-              <a:t>Run II (InitialLoad=False, CurrentJobTime=12-30-2026): exit 0, increment empty, counts unchanged</a:t>
+              <a:t>V2 simulation after Run I: +5,000 orders / +75,625 details / +5 products / +5 customers</a:t>
             </a:r>
             <a:br>
               <a:rPr lang="en-US" sz="1600">
@@ -10604,7 +10604,41 @@
                 </a:solidFill>
                 <a:latin typeface="Calibri" panose="020F0502020204030204" pitchFamily="34" charset="0"/>
               </a:rPr>
-              <a:t>OLTP vs OLAP queries: 432/432 rows equal, 0 numeric mismatches (TotalSales, GrossSales, discounts, ratios)</a:t>
+              <a:t>Run II (InitialLoad=False, CurrentJobTime=12-30-2026): exit 0, incremental load, +75,625 fact rows</a:t>
+            </a:r>
+            <a:br>
+              <a:rPr lang="en-US" sz="1600">
+                <a:solidFill>
+                  <a:srgbClr val="1F3864"/>
+                </a:solidFill>
+                <a:latin typeface="Calibri" panose="020F0502020204030204" pitchFamily="34" charset="0"/>
+              </a:rPr>
+            </a:br>
+            <a:r>
+              <a:rPr lang="en-US" sz="1600">
+                <a:solidFill>
+                  <a:srgbClr val="1F3864"/>
+                </a:solidFill>
+                <a:latin typeface="Calibri" panose="020F0502020204030204" pitchFamily="34" charset="0"/>
+              </a:rPr>
+              <a:t>SCD2: products 680/706 got new variants (+10% Cost/Price) on 2026-12-30; 707/708 SellEndDate=2024-06-30 set on existing variant</a:t>
+            </a:r>
+            <a:br>
+              <a:rPr lang="en-US" sz="1600">
+                <a:solidFill>
+                  <a:srgbClr val="1F3864"/>
+                </a:solidFill>
+                <a:latin typeface="Calibri" panose="020F0502020204030204" pitchFamily="34" charset="0"/>
+              </a:rPr>
+            </a:br>
+            <a:r>
+              <a:rPr lang="en-US" sz="1600">
+                <a:solidFill>
+                  <a:srgbClr val="1F3864"/>
+                </a:solidFill>
+                <a:latin typeface="Calibri" panose="020F0502020204030204" pitchFamily="34" charset="0"/>
+              </a:rPr>
+              <a:t>OLTP vs OLAP queries: 842/842 aggregation rows identical, 0 mismatches (all 7 metrics per row)</a:t>
             </a:r>
             <a:br>
               <a:rPr lang="en-US" sz="1600">
@@ -10629,7 +10663,7 @@
     </p:spTree>
     <p:extLst>
       <p:ext uri="{BB962C8B-B14F-4D97-AF65-F5344CB8AC3E}">
-        <p14:creationId xmlns:p14="http://schemas.microsoft.com/office/powerpoint/2010/main" val="3467930178"/>
+        <p14:creationId xmlns:p14="http://schemas.microsoft.com/office/powerpoint/2010/main" val="4163304005"/>
       </p:ext>
     </p:extLst>
   </p:cSld>

</xml_diff>